<commit_message>
translate on the feed
</commit_message>
<xml_diff>
--- a/feeder/tools/pics-making.pptx
+++ b/feeder/tools/pics-making.pptx
@@ -11,7 +11,8 @@
     <p:sldId id="263" r:id="rId5"/>
     <p:sldId id="261" r:id="rId6"/>
     <p:sldId id="262" r:id="rId7"/>
-    <p:sldId id="259" r:id="rId8"/>
+    <p:sldId id="264" r:id="rId8"/>
+    <p:sldId id="259" r:id="rId9"/>
   </p:sldIdLst>
   <p:sldSz cx="9144000" cy="6858000" type="screen4x3"/>
   <p:notesSz cx="6858000" cy="9144000"/>
@@ -310,7 +311,7 @@
           <a:p>
             <a:fld id="{56E5DCE2-4C0C-4B49-9538-1E32127C0620}" type="datetimeFigureOut">
               <a:rPr lang="en-IN" smtClean="0"/>
-              <a:t>08-05-2023</a:t>
+              <a:t>07-01-2024</a:t>
             </a:fld>
             <a:endParaRPr lang="en-IN"/>
           </a:p>
@@ -480,7 +481,7 @@
           <a:p>
             <a:fld id="{56E5DCE2-4C0C-4B49-9538-1E32127C0620}" type="datetimeFigureOut">
               <a:rPr lang="en-IN" smtClean="0"/>
-              <a:t>08-05-2023</a:t>
+              <a:t>07-01-2024</a:t>
             </a:fld>
             <a:endParaRPr lang="en-IN"/>
           </a:p>
@@ -660,7 +661,7 @@
           <a:p>
             <a:fld id="{56E5DCE2-4C0C-4B49-9538-1E32127C0620}" type="datetimeFigureOut">
               <a:rPr lang="en-IN" smtClean="0"/>
-              <a:t>08-05-2023</a:t>
+              <a:t>07-01-2024</a:t>
             </a:fld>
             <a:endParaRPr lang="en-IN"/>
           </a:p>
@@ -830,7 +831,7 @@
           <a:p>
             <a:fld id="{56E5DCE2-4C0C-4B49-9538-1E32127C0620}" type="datetimeFigureOut">
               <a:rPr lang="en-IN" smtClean="0"/>
-              <a:t>08-05-2023</a:t>
+              <a:t>07-01-2024</a:t>
             </a:fld>
             <a:endParaRPr lang="en-IN"/>
           </a:p>
@@ -1076,7 +1077,7 @@
           <a:p>
             <a:fld id="{56E5DCE2-4C0C-4B49-9538-1E32127C0620}" type="datetimeFigureOut">
               <a:rPr lang="en-IN" smtClean="0"/>
-              <a:t>08-05-2023</a:t>
+              <a:t>07-01-2024</a:t>
             </a:fld>
             <a:endParaRPr lang="en-IN"/>
           </a:p>
@@ -1364,7 +1365,7 @@
           <a:p>
             <a:fld id="{56E5DCE2-4C0C-4B49-9538-1E32127C0620}" type="datetimeFigureOut">
               <a:rPr lang="en-IN" smtClean="0"/>
-              <a:t>08-05-2023</a:t>
+              <a:t>07-01-2024</a:t>
             </a:fld>
             <a:endParaRPr lang="en-IN"/>
           </a:p>
@@ -1786,7 +1787,7 @@
           <a:p>
             <a:fld id="{56E5DCE2-4C0C-4B49-9538-1E32127C0620}" type="datetimeFigureOut">
               <a:rPr lang="en-IN" smtClean="0"/>
-              <a:t>08-05-2023</a:t>
+              <a:t>07-01-2024</a:t>
             </a:fld>
             <a:endParaRPr lang="en-IN"/>
           </a:p>
@@ -1904,7 +1905,7 @@
           <a:p>
             <a:fld id="{56E5DCE2-4C0C-4B49-9538-1E32127C0620}" type="datetimeFigureOut">
               <a:rPr lang="en-IN" smtClean="0"/>
-              <a:t>08-05-2023</a:t>
+              <a:t>07-01-2024</a:t>
             </a:fld>
             <a:endParaRPr lang="en-IN"/>
           </a:p>
@@ -1999,7 +2000,7 @@
           <a:p>
             <a:fld id="{56E5DCE2-4C0C-4B49-9538-1E32127C0620}" type="datetimeFigureOut">
               <a:rPr lang="en-IN" smtClean="0"/>
-              <a:t>08-05-2023</a:t>
+              <a:t>07-01-2024</a:t>
             </a:fld>
             <a:endParaRPr lang="en-IN"/>
           </a:p>
@@ -2276,7 +2277,7 @@
           <a:p>
             <a:fld id="{56E5DCE2-4C0C-4B49-9538-1E32127C0620}" type="datetimeFigureOut">
               <a:rPr lang="en-IN" smtClean="0"/>
-              <a:t>08-05-2023</a:t>
+              <a:t>07-01-2024</a:t>
             </a:fld>
             <a:endParaRPr lang="en-IN"/>
           </a:p>
@@ -2529,7 +2530,7 @@
           <a:p>
             <a:fld id="{56E5DCE2-4C0C-4B49-9538-1E32127C0620}" type="datetimeFigureOut">
               <a:rPr lang="en-IN" smtClean="0"/>
-              <a:t>08-05-2023</a:t>
+              <a:t>07-01-2024</a:t>
             </a:fld>
             <a:endParaRPr lang="en-IN"/>
           </a:p>
@@ -2742,7 +2743,7 @@
           <a:p>
             <a:fld id="{56E5DCE2-4C0C-4B49-9538-1E32127C0620}" type="datetimeFigureOut">
               <a:rPr lang="en-IN" smtClean="0"/>
-              <a:t>08-05-2023</a:t>
+              <a:t>07-01-2024</a:t>
             </a:fld>
             <a:endParaRPr lang="en-IN"/>
           </a:p>
@@ -24065,6 +24066,241 @@
       </p:grpSpPr>
       <p:sp>
         <p:nvSpPr>
+          <p:cNvPr id="5" name="TextBox 4">
+            <a:extLst>
+              <a:ext uri="{FF2B5EF4-FFF2-40B4-BE49-F238E27FC236}">
+                <a16:creationId xmlns:a16="http://schemas.microsoft.com/office/drawing/2014/main" id="{77921907-7D50-F0DA-35F2-41736ACEB398}"/>
+              </a:ext>
+            </a:extLst>
+          </p:cNvPr>
+          <p:cNvSpPr txBox="1"/>
+          <p:nvPr/>
+        </p:nvSpPr>
+        <p:spPr>
+          <a:xfrm>
+            <a:off x="2286000" y="3251540"/>
+            <a:ext cx="381000" cy="276999"/>
+          </a:xfrm>
+          <a:prstGeom prst="rect">
+            <a:avLst/>
+          </a:prstGeom>
+          <a:noFill/>
+        </p:spPr>
+        <p:txBody>
+          <a:bodyPr wrap="square" lIns="0" tIns="0" rIns="0" bIns="0">
+            <a:spAutoFit/>
+          </a:bodyPr>
+          <a:lstStyle/>
+          <a:p>
+            <a:r>
+              <a:rPr lang="en-IN" dirty="0">
+                <a:solidFill>
+                  <a:schemeClr val="accent6">
+                    <a:lumMod val="75000"/>
+                  </a:schemeClr>
+                </a:solidFill>
+              </a:rPr>
+              <a:t>अ</a:t>
+            </a:r>
+          </a:p>
+        </p:txBody>
+      </p:sp>
+      <p:sp>
+        <p:nvSpPr>
+          <p:cNvPr id="6" name="TextBox 5">
+            <a:extLst>
+              <a:ext uri="{FF2B5EF4-FFF2-40B4-BE49-F238E27FC236}">
+                <a16:creationId xmlns:a16="http://schemas.microsoft.com/office/drawing/2014/main" id="{6774A57B-B6DF-E6B5-E152-ADB37D9C52A2}"/>
+              </a:ext>
+            </a:extLst>
+          </p:cNvPr>
+          <p:cNvSpPr txBox="1"/>
+          <p:nvPr/>
+        </p:nvSpPr>
+        <p:spPr>
+          <a:xfrm>
+            <a:off x="2501684" y="3360006"/>
+            <a:ext cx="133050" cy="276999"/>
+          </a:xfrm>
+          <a:prstGeom prst="rect">
+            <a:avLst/>
+          </a:prstGeom>
+          <a:noFill/>
+        </p:spPr>
+        <p:txBody>
+          <a:bodyPr wrap="none" lIns="0" tIns="0" rIns="0" bIns="0" rtlCol="0">
+            <a:spAutoFit/>
+          </a:bodyPr>
+          <a:lstStyle/>
+          <a:p>
+            <a:r>
+              <a:rPr lang="en-GB" dirty="0">
+                <a:solidFill>
+                  <a:schemeClr val="tx1">
+                    <a:lumMod val="50000"/>
+                    <a:lumOff val="50000"/>
+                  </a:schemeClr>
+                </a:solidFill>
+              </a:rPr>
+              <a:t>A</a:t>
+            </a:r>
+            <a:endParaRPr lang="en-IN" dirty="0">
+              <a:solidFill>
+                <a:schemeClr val="tx1">
+                  <a:lumMod val="50000"/>
+                  <a:lumOff val="50000"/>
+                </a:schemeClr>
+              </a:solidFill>
+            </a:endParaRPr>
+          </a:p>
+        </p:txBody>
+      </p:sp>
+      <p:sp>
+        <p:nvSpPr>
+          <p:cNvPr id="12" name="Arrow: Curved Down 11">
+            <a:extLst>
+              <a:ext uri="{FF2B5EF4-FFF2-40B4-BE49-F238E27FC236}">
+                <a16:creationId xmlns:a16="http://schemas.microsoft.com/office/drawing/2014/main" id="{D9635E36-2C65-92EA-F134-794EEBB24143}"/>
+              </a:ext>
+            </a:extLst>
+          </p:cNvPr>
+          <p:cNvSpPr/>
+          <p:nvPr/>
+        </p:nvSpPr>
+        <p:spPr>
+          <a:xfrm rot="2021404">
+            <a:off x="2502453" y="3308660"/>
+            <a:ext cx="152400" cy="76200"/>
+          </a:xfrm>
+          <a:prstGeom prst="curvedDownArrow">
+            <a:avLst/>
+          </a:prstGeom>
+        </p:spPr>
+        <p:style>
+          <a:lnRef idx="2">
+            <a:schemeClr val="accent1">
+              <a:shade val="15000"/>
+            </a:schemeClr>
+          </a:lnRef>
+          <a:fillRef idx="1">
+            <a:schemeClr val="accent1"/>
+          </a:fillRef>
+          <a:effectRef idx="0">
+            <a:schemeClr val="accent1"/>
+          </a:effectRef>
+          <a:fontRef idx="minor">
+            <a:schemeClr val="lt1"/>
+          </a:fontRef>
+        </p:style>
+        <p:txBody>
+          <a:bodyPr rtlCol="0" anchor="ctr"/>
+          <a:lstStyle/>
+          <a:p>
+            <a:pPr algn="ctr"/>
+            <a:endParaRPr lang="en-IN">
+              <a:solidFill>
+                <a:schemeClr val="tx1"/>
+              </a:solidFill>
+            </a:endParaRPr>
+          </a:p>
+        </p:txBody>
+      </p:sp>
+      <p:sp>
+        <p:nvSpPr>
+          <p:cNvPr id="13" name="Arrow: Curved Down 12">
+            <a:extLst>
+              <a:ext uri="{FF2B5EF4-FFF2-40B4-BE49-F238E27FC236}">
+                <a16:creationId xmlns:a16="http://schemas.microsoft.com/office/drawing/2014/main" id="{225BCA09-71A3-6819-7B17-B4D2B2A256D8}"/>
+              </a:ext>
+            </a:extLst>
+          </p:cNvPr>
+          <p:cNvSpPr/>
+          <p:nvPr/>
+        </p:nvSpPr>
+        <p:spPr>
+          <a:xfrm rot="13327094">
+            <a:off x="2337136" y="3530054"/>
+            <a:ext cx="152400" cy="76200"/>
+          </a:xfrm>
+          <a:prstGeom prst="curvedDownArrow">
+            <a:avLst/>
+          </a:prstGeom>
+          <a:solidFill>
+            <a:schemeClr val="accent6">
+              <a:lumMod val="75000"/>
+            </a:schemeClr>
+          </a:solidFill>
+          <a:ln>
+            <a:solidFill>
+              <a:schemeClr val="accent6">
+                <a:lumMod val="75000"/>
+              </a:schemeClr>
+            </a:solidFill>
+          </a:ln>
+        </p:spPr>
+        <p:style>
+          <a:lnRef idx="2">
+            <a:schemeClr val="accent1">
+              <a:shade val="15000"/>
+            </a:schemeClr>
+          </a:lnRef>
+          <a:fillRef idx="1">
+            <a:schemeClr val="accent1"/>
+          </a:fillRef>
+          <a:effectRef idx="0">
+            <a:schemeClr val="accent1"/>
+          </a:effectRef>
+          <a:fontRef idx="minor">
+            <a:schemeClr val="lt1"/>
+          </a:fontRef>
+        </p:style>
+        <p:txBody>
+          <a:bodyPr rtlCol="0" anchor="ctr"/>
+          <a:lstStyle/>
+          <a:p>
+            <a:pPr algn="ctr"/>
+            <a:endParaRPr lang="en-IN">
+              <a:solidFill>
+                <a:schemeClr val="accent6">
+                  <a:lumMod val="75000"/>
+                </a:schemeClr>
+              </a:solidFill>
+            </a:endParaRPr>
+          </a:p>
+        </p:txBody>
+      </p:sp>
+    </p:spTree>
+    <p:extLst>
+      <p:ext uri="{BB962C8B-B14F-4D97-AF65-F5344CB8AC3E}">
+        <p14:creationId xmlns:p14="http://schemas.microsoft.com/office/powerpoint/2010/main" val="2997685879"/>
+      </p:ext>
+    </p:extLst>
+  </p:cSld>
+  <p:clrMapOvr>
+    <a:masterClrMapping/>
+  </p:clrMapOvr>
+</p:sld>
+</file>
+
+<file path=ppt/slides/slide8.xml><?xml version="1.0" encoding="utf-8"?>
+<p:sld xmlns:a="http://schemas.openxmlformats.org/drawingml/2006/main" xmlns:r="http://schemas.openxmlformats.org/officeDocument/2006/relationships" xmlns:p="http://schemas.openxmlformats.org/presentationml/2006/main">
+  <p:cSld>
+    <p:spTree>
+      <p:nvGrpSpPr>
+        <p:cNvPr id="1" name=""/>
+        <p:cNvGrpSpPr/>
+        <p:nvPr/>
+      </p:nvGrpSpPr>
+      <p:grpSpPr>
+        <a:xfrm>
+          <a:off x="0" y="0"/>
+          <a:ext cx="0" cy="0"/>
+          <a:chOff x="0" y="0"/>
+          <a:chExt cx="0" cy="0"/>
+        </a:xfrm>
+      </p:grpSpPr>
+      <p:sp>
+        <p:nvSpPr>
           <p:cNvPr id="12" name="Rectangle 11"/>
           <p:cNvSpPr/>
           <p:nvPr/>

</xml_diff>

<commit_message>
redraw on first load
</commit_message>
<xml_diff>
--- a/feeder/tools/pics-making.pptx
+++ b/feeder/tools/pics-making.pptx
@@ -7,11 +7,12 @@
   <p:sldIdLst>
     <p:sldId id="257" r:id="rId2"/>
     <p:sldId id="258" r:id="rId3"/>
-    <p:sldId id="260" r:id="rId4"/>
-    <p:sldId id="263" r:id="rId5"/>
-    <p:sldId id="261" r:id="rId6"/>
-    <p:sldId id="262" r:id="rId7"/>
-    <p:sldId id="259" r:id="rId8"/>
+    <p:sldId id="264" r:id="rId4"/>
+    <p:sldId id="260" r:id="rId5"/>
+    <p:sldId id="263" r:id="rId6"/>
+    <p:sldId id="261" r:id="rId7"/>
+    <p:sldId id="262" r:id="rId8"/>
+    <p:sldId id="259" r:id="rId9"/>
   </p:sldIdLst>
   <p:sldSz cx="9144000" cy="6858000" type="screen4x3"/>
   <p:notesSz cx="6858000" cy="9144000"/>
@@ -310,7 +311,7 @@
           <a:p>
             <a:fld id="{56E5DCE2-4C0C-4B49-9538-1E32127C0620}" type="datetimeFigureOut">
               <a:rPr lang="en-IN" smtClean="0"/>
-              <a:t>19-06-2024</a:t>
+              <a:t>10-11-2024</a:t>
             </a:fld>
             <a:endParaRPr lang="en-IN"/>
           </a:p>
@@ -480,7 +481,7 @@
           <a:p>
             <a:fld id="{56E5DCE2-4C0C-4B49-9538-1E32127C0620}" type="datetimeFigureOut">
               <a:rPr lang="en-IN" smtClean="0"/>
-              <a:t>19-06-2024</a:t>
+              <a:t>10-11-2024</a:t>
             </a:fld>
             <a:endParaRPr lang="en-IN"/>
           </a:p>
@@ -660,7 +661,7 @@
           <a:p>
             <a:fld id="{56E5DCE2-4C0C-4B49-9538-1E32127C0620}" type="datetimeFigureOut">
               <a:rPr lang="en-IN" smtClean="0"/>
-              <a:t>19-06-2024</a:t>
+              <a:t>10-11-2024</a:t>
             </a:fld>
             <a:endParaRPr lang="en-IN"/>
           </a:p>
@@ -830,7 +831,7 @@
           <a:p>
             <a:fld id="{56E5DCE2-4C0C-4B49-9538-1E32127C0620}" type="datetimeFigureOut">
               <a:rPr lang="en-IN" smtClean="0"/>
-              <a:t>19-06-2024</a:t>
+              <a:t>10-11-2024</a:t>
             </a:fld>
             <a:endParaRPr lang="en-IN"/>
           </a:p>
@@ -1076,7 +1077,7 @@
           <a:p>
             <a:fld id="{56E5DCE2-4C0C-4B49-9538-1E32127C0620}" type="datetimeFigureOut">
               <a:rPr lang="en-IN" smtClean="0"/>
-              <a:t>19-06-2024</a:t>
+              <a:t>10-11-2024</a:t>
             </a:fld>
             <a:endParaRPr lang="en-IN"/>
           </a:p>
@@ -1364,7 +1365,7 @@
           <a:p>
             <a:fld id="{56E5DCE2-4C0C-4B49-9538-1E32127C0620}" type="datetimeFigureOut">
               <a:rPr lang="en-IN" smtClean="0"/>
-              <a:t>19-06-2024</a:t>
+              <a:t>10-11-2024</a:t>
             </a:fld>
             <a:endParaRPr lang="en-IN"/>
           </a:p>
@@ -1786,7 +1787,7 @@
           <a:p>
             <a:fld id="{56E5DCE2-4C0C-4B49-9538-1E32127C0620}" type="datetimeFigureOut">
               <a:rPr lang="en-IN" smtClean="0"/>
-              <a:t>19-06-2024</a:t>
+              <a:t>10-11-2024</a:t>
             </a:fld>
             <a:endParaRPr lang="en-IN"/>
           </a:p>
@@ -1904,7 +1905,7 @@
           <a:p>
             <a:fld id="{56E5DCE2-4C0C-4B49-9538-1E32127C0620}" type="datetimeFigureOut">
               <a:rPr lang="en-IN" smtClean="0"/>
-              <a:t>19-06-2024</a:t>
+              <a:t>10-11-2024</a:t>
             </a:fld>
             <a:endParaRPr lang="en-IN"/>
           </a:p>
@@ -1999,7 +2000,7 @@
           <a:p>
             <a:fld id="{56E5DCE2-4C0C-4B49-9538-1E32127C0620}" type="datetimeFigureOut">
               <a:rPr lang="en-IN" smtClean="0"/>
-              <a:t>19-06-2024</a:t>
+              <a:t>10-11-2024</a:t>
             </a:fld>
             <a:endParaRPr lang="en-IN"/>
           </a:p>
@@ -2276,7 +2277,7 @@
           <a:p>
             <a:fld id="{56E5DCE2-4C0C-4B49-9538-1E32127C0620}" type="datetimeFigureOut">
               <a:rPr lang="en-IN" smtClean="0"/>
-              <a:t>19-06-2024</a:t>
+              <a:t>10-11-2024</a:t>
             </a:fld>
             <a:endParaRPr lang="en-IN"/>
           </a:p>
@@ -2529,7 +2530,7 @@
           <a:p>
             <a:fld id="{56E5DCE2-4C0C-4B49-9538-1E32127C0620}" type="datetimeFigureOut">
               <a:rPr lang="en-IN" smtClean="0"/>
-              <a:t>19-06-2024</a:t>
+              <a:t>10-11-2024</a:t>
             </a:fld>
             <a:endParaRPr lang="en-IN"/>
           </a:p>
@@ -2742,7 +2743,7 @@
           <a:p>
             <a:fld id="{56E5DCE2-4C0C-4B49-9538-1E32127C0620}" type="datetimeFigureOut">
               <a:rPr lang="en-IN" smtClean="0"/>
-              <a:t>19-06-2024</a:t>
+              <a:t>10-11-2024</a:t>
             </a:fld>
             <a:endParaRPr lang="en-IN"/>
           </a:p>
@@ -6117,6 +6118,176 @@
 </file>
 
 <file path=ppt/slides/slide3.xml><?xml version="1.0" encoding="utf-8"?>
+<p:sld xmlns:a="http://schemas.openxmlformats.org/drawingml/2006/main" xmlns:r="http://schemas.openxmlformats.org/officeDocument/2006/relationships" xmlns:p="http://schemas.openxmlformats.org/presentationml/2006/main">
+  <p:cSld>
+    <p:spTree>
+      <p:nvGrpSpPr>
+        <p:cNvPr id="1" name=""/>
+        <p:cNvGrpSpPr/>
+        <p:nvPr/>
+      </p:nvGrpSpPr>
+      <p:grpSpPr>
+        <a:xfrm>
+          <a:off x="0" y="0"/>
+          <a:ext cx="0" cy="0"/>
+          <a:chOff x="0" y="0"/>
+          <a:chExt cx="0" cy="0"/>
+        </a:xfrm>
+      </p:grpSpPr>
+      <p:grpSp>
+        <p:nvGrpSpPr>
+          <p:cNvPr id="6" name="Group 5">
+            <a:extLst>
+              <a:ext uri="{FF2B5EF4-FFF2-40B4-BE49-F238E27FC236}">
+                <a16:creationId xmlns:a16="http://schemas.microsoft.com/office/drawing/2014/main" id="{A93D99E4-E0A7-D65C-C7DF-628C1BB46F76}"/>
+              </a:ext>
+            </a:extLst>
+          </p:cNvPr>
+          <p:cNvGrpSpPr/>
+          <p:nvPr/>
+        </p:nvGrpSpPr>
+        <p:grpSpPr>
+          <a:xfrm>
+            <a:off x="1220536" y="670806"/>
+            <a:ext cx="1978177" cy="995176"/>
+            <a:chOff x="1220536" y="670806"/>
+            <a:chExt cx="1978177" cy="995176"/>
+          </a:xfrm>
+        </p:grpSpPr>
+        <p:sp>
+          <p:nvSpPr>
+            <p:cNvPr id="4" name="TextBox 3">
+              <a:extLst>
+                <a:ext uri="{FF2B5EF4-FFF2-40B4-BE49-F238E27FC236}">
+                  <a16:creationId xmlns:a16="http://schemas.microsoft.com/office/drawing/2014/main" id="{283522D8-5F58-AA62-A448-82C22FC5D464}"/>
+                </a:ext>
+              </a:extLst>
+            </p:cNvPr>
+            <p:cNvSpPr txBox="1"/>
+            <p:nvPr/>
+          </p:nvSpPr>
+          <p:spPr>
+            <a:xfrm rot="21405905">
+              <a:off x="1220536" y="670806"/>
+              <a:ext cx="1676191" cy="646331"/>
+            </a:xfrm>
+            <a:prstGeom prst="rect">
+              <a:avLst/>
+            </a:prstGeom>
+            <a:noFill/>
+          </p:spPr>
+          <p:txBody>
+            <a:bodyPr wrap="square" rtlCol="0">
+              <a:spAutoFit/>
+            </a:bodyPr>
+            <a:lstStyle/>
+            <a:p>
+              <a:r>
+                <a:rPr lang="en-GB" dirty="0">
+                  <a:solidFill>
+                    <a:schemeClr val="accent2">
+                      <a:lumMod val="60000"/>
+                      <a:lumOff val="40000"/>
+                    </a:schemeClr>
+                  </a:solidFill>
+                </a:rPr>
+                <a:t>look </a:t>
+              </a:r>
+              <a:r>
+                <a:rPr lang="en-GB" sz="3600" dirty="0">
+                  <a:solidFill>
+                    <a:schemeClr val="accent2">
+                      <a:lumMod val="60000"/>
+                      <a:lumOff val="40000"/>
+                    </a:schemeClr>
+                  </a:solidFill>
+                </a:rPr>
+                <a:t>Once</a:t>
+              </a:r>
+              <a:endParaRPr lang="en-IN" dirty="0">
+                <a:solidFill>
+                  <a:schemeClr val="accent2">
+                    <a:lumMod val="60000"/>
+                    <a:lumOff val="40000"/>
+                  </a:schemeClr>
+                </a:solidFill>
+              </a:endParaRPr>
+            </a:p>
+          </p:txBody>
+        </p:sp>
+        <p:sp>
+          <p:nvSpPr>
+            <p:cNvPr id="5" name="TextBox 4">
+              <a:extLst>
+                <a:ext uri="{FF2B5EF4-FFF2-40B4-BE49-F238E27FC236}">
+                  <a16:creationId xmlns:a16="http://schemas.microsoft.com/office/drawing/2014/main" id="{E9EA3937-9165-83C7-769F-7E3DD5ECD9B3}"/>
+                </a:ext>
+              </a:extLst>
+            </p:cNvPr>
+            <p:cNvSpPr txBox="1"/>
+            <p:nvPr/>
+          </p:nvSpPr>
+          <p:spPr>
+            <a:xfrm rot="182339">
+              <a:off x="1533135" y="1081207"/>
+              <a:ext cx="1665578" cy="584775"/>
+            </a:xfrm>
+            <a:prstGeom prst="rect">
+              <a:avLst/>
+            </a:prstGeom>
+            <a:noFill/>
+          </p:spPr>
+          <p:txBody>
+            <a:bodyPr wrap="square" rtlCol="0">
+              <a:spAutoFit/>
+            </a:bodyPr>
+            <a:lstStyle/>
+            <a:p>
+              <a:r>
+                <a:rPr lang="en-GB" dirty="0">
+                  <a:solidFill>
+                    <a:schemeClr val="accent6">
+                      <a:lumMod val="75000"/>
+                    </a:schemeClr>
+                  </a:solidFill>
+                </a:rPr>
+                <a:t>listen </a:t>
+              </a:r>
+              <a:r>
+                <a:rPr lang="en-GB" sz="3200" dirty="0">
+                  <a:solidFill>
+                    <a:schemeClr val="accent6">
+                      <a:lumMod val="75000"/>
+                    </a:schemeClr>
+                  </a:solidFill>
+                </a:rPr>
+                <a:t>Again</a:t>
+              </a:r>
+              <a:endParaRPr lang="en-IN" dirty="0">
+                <a:solidFill>
+                  <a:schemeClr val="accent6">
+                    <a:lumMod val="75000"/>
+                  </a:schemeClr>
+                </a:solidFill>
+              </a:endParaRPr>
+            </a:p>
+          </p:txBody>
+        </p:sp>
+      </p:grpSp>
+    </p:spTree>
+    <p:extLst>
+      <p:ext uri="{BB962C8B-B14F-4D97-AF65-F5344CB8AC3E}">
+        <p14:creationId xmlns:p14="http://schemas.microsoft.com/office/powerpoint/2010/main" val="3451974539"/>
+      </p:ext>
+    </p:extLst>
+  </p:cSld>
+  <p:clrMapOvr>
+    <a:masterClrMapping/>
+  </p:clrMapOvr>
+</p:sld>
+</file>
+
+<file path=ppt/slides/slide4.xml><?xml version="1.0" encoding="utf-8"?>
 <p:sld xmlns:a="http://schemas.openxmlformats.org/drawingml/2006/main" xmlns:r="http://schemas.openxmlformats.org/officeDocument/2006/relationships" xmlns:p="http://schemas.openxmlformats.org/presentationml/2006/main">
   <p:cSld>
     <p:spTree>
@@ -13161,7 +13332,7 @@
 </p:sld>
 </file>
 
-<file path=ppt/slides/slide4.xml><?xml version="1.0" encoding="utf-8"?>
+<file path=ppt/slides/slide5.xml><?xml version="1.0" encoding="utf-8"?>
 <p:sld xmlns:a="http://schemas.openxmlformats.org/drawingml/2006/main" xmlns:r="http://schemas.openxmlformats.org/officeDocument/2006/relationships" xmlns:p="http://schemas.openxmlformats.org/presentationml/2006/main">
   <p:cSld>
     <p:spTree>
@@ -24639,7 +24810,7 @@
 </p:sld>
 </file>
 
-<file path=ppt/slides/slide5.xml><?xml version="1.0" encoding="utf-8"?>
+<file path=ppt/slides/slide6.xml><?xml version="1.0" encoding="utf-8"?>
 <p:sld xmlns:a="http://schemas.openxmlformats.org/drawingml/2006/main" xmlns:r="http://schemas.openxmlformats.org/officeDocument/2006/relationships" xmlns:p="http://schemas.openxmlformats.org/presentationml/2006/main">
   <p:cSld>
     <p:spTree>
@@ -24841,7 +25012,7 @@
 </p:sld>
 </file>
 
-<file path=ppt/slides/slide6.xml><?xml version="1.0" encoding="utf-8"?>
+<file path=ppt/slides/slide7.xml><?xml version="1.0" encoding="utf-8"?>
 <p:sld xmlns:a="http://schemas.openxmlformats.org/drawingml/2006/main" xmlns:r="http://schemas.openxmlformats.org/officeDocument/2006/relationships" xmlns:p="http://schemas.openxmlformats.org/presentationml/2006/main">
   <p:cSld>
     <p:spTree>
@@ -24928,7 +25099,7 @@
 </p:sld>
 </file>
 
-<file path=ppt/slides/slide7.xml><?xml version="1.0" encoding="utf-8"?>
+<file path=ppt/slides/slide8.xml><?xml version="1.0" encoding="utf-8"?>
 <p:sld xmlns:a="http://schemas.openxmlformats.org/drawingml/2006/main" xmlns:r="http://schemas.openxmlformats.org/officeDocument/2006/relationships" xmlns:p="http://schemas.openxmlformats.org/presentationml/2006/main">
   <p:cSld>
     <p:spTree>

</xml_diff>

<commit_message>
chapters with notes image
</commit_message>
<xml_diff>
--- a/feeder/tools/pics-making.pptx
+++ b/feeder/tools/pics-making.pptx
@@ -6274,6 +6274,2799 @@
           </p:txBody>
         </p:sp>
       </p:grpSp>
+      <p:grpSp>
+        <p:nvGrpSpPr>
+          <p:cNvPr id="35" name="Group 34">
+            <a:extLst>
+              <a:ext uri="{FF2B5EF4-FFF2-40B4-BE49-F238E27FC236}">
+                <a16:creationId xmlns:a16="http://schemas.microsoft.com/office/drawing/2014/main" id="{7B4F6882-261E-F847-ADC6-70BAB77CF676}"/>
+              </a:ext>
+            </a:extLst>
+          </p:cNvPr>
+          <p:cNvGrpSpPr/>
+          <p:nvPr/>
+        </p:nvGrpSpPr>
+        <p:grpSpPr>
+          <a:xfrm rot="20045583">
+            <a:off x="7092077" y="3610805"/>
+            <a:ext cx="1610635" cy="1088954"/>
+            <a:chOff x="7092077" y="3610805"/>
+            <a:chExt cx="1610635" cy="1088954"/>
+          </a:xfrm>
+        </p:grpSpPr>
+        <p:grpSp>
+          <p:nvGrpSpPr>
+            <p:cNvPr id="7" name="Group 6">
+              <a:extLst>
+                <a:ext uri="{FF2B5EF4-FFF2-40B4-BE49-F238E27FC236}">
+                  <a16:creationId xmlns:a16="http://schemas.microsoft.com/office/drawing/2014/main" id="{9B5E6072-95D8-ADD6-4CAE-BF972A7C517C}"/>
+                </a:ext>
+              </a:extLst>
+            </p:cNvPr>
+            <p:cNvGrpSpPr/>
+            <p:nvPr/>
+          </p:nvGrpSpPr>
+          <p:grpSpPr>
+            <a:xfrm rot="3582214">
+              <a:off x="7485024" y="3855442"/>
+              <a:ext cx="230400" cy="525600"/>
+              <a:chOff x="8024239" y="1985356"/>
+              <a:chExt cx="2141775" cy="4911414"/>
+            </a:xfrm>
+          </p:grpSpPr>
+          <p:sp>
+            <p:nvSpPr>
+              <p:cNvPr id="8" name="Freeform 5">
+                <a:extLst>
+                  <a:ext uri="{FF2B5EF4-FFF2-40B4-BE49-F238E27FC236}">
+                    <a16:creationId xmlns:a16="http://schemas.microsoft.com/office/drawing/2014/main" id="{170729A6-6FF2-818B-28CC-B2F3F66D52B6}"/>
+                  </a:ext>
+                </a:extLst>
+              </p:cNvPr>
+              <p:cNvSpPr/>
+              <p:nvPr/>
+            </p:nvSpPr>
+            <p:spPr>
+              <a:xfrm rot="10626065" flipH="1">
+                <a:off x="8024239" y="2973626"/>
+                <a:ext cx="2141775" cy="3923144"/>
+              </a:xfrm>
+              <a:custGeom>
+                <a:avLst/>
+                <a:gdLst>
+                  <a:gd name="connsiteX0" fmla="*/ 452236 w 2914469"/>
+                  <a:gd name="connsiteY0" fmla="*/ 4744449 h 5470974"/>
+                  <a:gd name="connsiteX1" fmla="*/ 8891 w 2914469"/>
+                  <a:gd name="connsiteY1" fmla="*/ 2749394 h 5470974"/>
+                  <a:gd name="connsiteX2" fmla="*/ 175146 w 2914469"/>
+                  <a:gd name="connsiteY2" fmla="*/ 1211540 h 5470974"/>
+                  <a:gd name="connsiteX3" fmla="*/ 410673 w 2914469"/>
+                  <a:gd name="connsiteY3" fmla="*/ 394122 h 5470974"/>
+                  <a:gd name="connsiteX4" fmla="*/ 1186527 w 2914469"/>
+                  <a:gd name="connsiteY4" fmla="*/ 6194 h 5470974"/>
+                  <a:gd name="connsiteX5" fmla="*/ 2142491 w 2914469"/>
+                  <a:gd name="connsiteY5" fmla="*/ 269431 h 5470974"/>
+                  <a:gd name="connsiteX6" fmla="*/ 2447291 w 2914469"/>
+                  <a:gd name="connsiteY6" fmla="*/ 1599467 h 5470974"/>
+                  <a:gd name="connsiteX7" fmla="*/ 1990091 w 2914469"/>
+                  <a:gd name="connsiteY7" fmla="*/ 2610849 h 5470974"/>
+                  <a:gd name="connsiteX8" fmla="*/ 1809982 w 2914469"/>
+                  <a:gd name="connsiteY8" fmla="*/ 3622231 h 5470974"/>
+                  <a:gd name="connsiteX9" fmla="*/ 2655109 w 2914469"/>
+                  <a:gd name="connsiteY9" fmla="*/ 4522776 h 5470974"/>
+                  <a:gd name="connsiteX10" fmla="*/ 2890636 w 2914469"/>
+                  <a:gd name="connsiteY10" fmla="*/ 5049249 h 5470974"/>
+                  <a:gd name="connsiteX11" fmla="*/ 2170200 w 2914469"/>
+                  <a:gd name="connsiteY11" fmla="*/ 5423322 h 5470974"/>
+                  <a:gd name="connsiteX12" fmla="*/ 729327 w 2914469"/>
+                  <a:gd name="connsiteY12" fmla="*/ 5395613 h 5470974"/>
+                  <a:gd name="connsiteX13" fmla="*/ 452236 w 2914469"/>
+                  <a:gd name="connsiteY13" fmla="*/ 4744449 h 5470974"/>
+                  <a:gd name="connsiteX0" fmla="*/ 452236 w 2733397"/>
+                  <a:gd name="connsiteY0" fmla="*/ 4744449 h 5470974"/>
+                  <a:gd name="connsiteX1" fmla="*/ 8891 w 2733397"/>
+                  <a:gd name="connsiteY1" fmla="*/ 2749394 h 5470974"/>
+                  <a:gd name="connsiteX2" fmla="*/ 175146 w 2733397"/>
+                  <a:gd name="connsiteY2" fmla="*/ 1211540 h 5470974"/>
+                  <a:gd name="connsiteX3" fmla="*/ 410673 w 2733397"/>
+                  <a:gd name="connsiteY3" fmla="*/ 394122 h 5470974"/>
+                  <a:gd name="connsiteX4" fmla="*/ 1186527 w 2733397"/>
+                  <a:gd name="connsiteY4" fmla="*/ 6194 h 5470974"/>
+                  <a:gd name="connsiteX5" fmla="*/ 2142491 w 2733397"/>
+                  <a:gd name="connsiteY5" fmla="*/ 269431 h 5470974"/>
+                  <a:gd name="connsiteX6" fmla="*/ 2447291 w 2733397"/>
+                  <a:gd name="connsiteY6" fmla="*/ 1599467 h 5470974"/>
+                  <a:gd name="connsiteX7" fmla="*/ 1990091 w 2733397"/>
+                  <a:gd name="connsiteY7" fmla="*/ 2610849 h 5470974"/>
+                  <a:gd name="connsiteX8" fmla="*/ 1809982 w 2733397"/>
+                  <a:gd name="connsiteY8" fmla="*/ 3622231 h 5470974"/>
+                  <a:gd name="connsiteX9" fmla="*/ 2655109 w 2733397"/>
+                  <a:gd name="connsiteY9" fmla="*/ 4522776 h 5470974"/>
+                  <a:gd name="connsiteX10" fmla="*/ 2641254 w 2733397"/>
+                  <a:gd name="connsiteY10" fmla="*/ 5146231 h 5470974"/>
+                  <a:gd name="connsiteX11" fmla="*/ 2170200 w 2733397"/>
+                  <a:gd name="connsiteY11" fmla="*/ 5423322 h 5470974"/>
+                  <a:gd name="connsiteX12" fmla="*/ 729327 w 2733397"/>
+                  <a:gd name="connsiteY12" fmla="*/ 5395613 h 5470974"/>
+                  <a:gd name="connsiteX13" fmla="*/ 452236 w 2733397"/>
+                  <a:gd name="connsiteY13" fmla="*/ 4744449 h 5470974"/>
+                  <a:gd name="connsiteX0" fmla="*/ 452236 w 2662490"/>
+                  <a:gd name="connsiteY0" fmla="*/ 4744449 h 5470974"/>
+                  <a:gd name="connsiteX1" fmla="*/ 8891 w 2662490"/>
+                  <a:gd name="connsiteY1" fmla="*/ 2749394 h 5470974"/>
+                  <a:gd name="connsiteX2" fmla="*/ 175146 w 2662490"/>
+                  <a:gd name="connsiteY2" fmla="*/ 1211540 h 5470974"/>
+                  <a:gd name="connsiteX3" fmla="*/ 410673 w 2662490"/>
+                  <a:gd name="connsiteY3" fmla="*/ 394122 h 5470974"/>
+                  <a:gd name="connsiteX4" fmla="*/ 1186527 w 2662490"/>
+                  <a:gd name="connsiteY4" fmla="*/ 6194 h 5470974"/>
+                  <a:gd name="connsiteX5" fmla="*/ 2142491 w 2662490"/>
+                  <a:gd name="connsiteY5" fmla="*/ 269431 h 5470974"/>
+                  <a:gd name="connsiteX6" fmla="*/ 2447291 w 2662490"/>
+                  <a:gd name="connsiteY6" fmla="*/ 1599467 h 5470974"/>
+                  <a:gd name="connsiteX7" fmla="*/ 1990091 w 2662490"/>
+                  <a:gd name="connsiteY7" fmla="*/ 2610849 h 5470974"/>
+                  <a:gd name="connsiteX8" fmla="*/ 1809982 w 2662490"/>
+                  <a:gd name="connsiteY8" fmla="*/ 3622231 h 5470974"/>
+                  <a:gd name="connsiteX9" fmla="*/ 2502709 w 2662490"/>
+                  <a:gd name="connsiteY9" fmla="*/ 4508922 h 5470974"/>
+                  <a:gd name="connsiteX10" fmla="*/ 2641254 w 2662490"/>
+                  <a:gd name="connsiteY10" fmla="*/ 5146231 h 5470974"/>
+                  <a:gd name="connsiteX11" fmla="*/ 2170200 w 2662490"/>
+                  <a:gd name="connsiteY11" fmla="*/ 5423322 h 5470974"/>
+                  <a:gd name="connsiteX12" fmla="*/ 729327 w 2662490"/>
+                  <a:gd name="connsiteY12" fmla="*/ 5395613 h 5470974"/>
+                  <a:gd name="connsiteX13" fmla="*/ 452236 w 2662490"/>
+                  <a:gd name="connsiteY13" fmla="*/ 4744449 h 5470974"/>
+                  <a:gd name="connsiteX0" fmla="*/ 452236 w 2628430"/>
+                  <a:gd name="connsiteY0" fmla="*/ 4744449 h 5470974"/>
+                  <a:gd name="connsiteX1" fmla="*/ 8891 w 2628430"/>
+                  <a:gd name="connsiteY1" fmla="*/ 2749394 h 5470974"/>
+                  <a:gd name="connsiteX2" fmla="*/ 175146 w 2628430"/>
+                  <a:gd name="connsiteY2" fmla="*/ 1211540 h 5470974"/>
+                  <a:gd name="connsiteX3" fmla="*/ 410673 w 2628430"/>
+                  <a:gd name="connsiteY3" fmla="*/ 394122 h 5470974"/>
+                  <a:gd name="connsiteX4" fmla="*/ 1186527 w 2628430"/>
+                  <a:gd name="connsiteY4" fmla="*/ 6194 h 5470974"/>
+                  <a:gd name="connsiteX5" fmla="*/ 2142491 w 2628430"/>
+                  <a:gd name="connsiteY5" fmla="*/ 269431 h 5470974"/>
+                  <a:gd name="connsiteX6" fmla="*/ 2447291 w 2628430"/>
+                  <a:gd name="connsiteY6" fmla="*/ 1599467 h 5470974"/>
+                  <a:gd name="connsiteX7" fmla="*/ 1990091 w 2628430"/>
+                  <a:gd name="connsiteY7" fmla="*/ 2610849 h 5470974"/>
+                  <a:gd name="connsiteX8" fmla="*/ 1809982 w 2628430"/>
+                  <a:gd name="connsiteY8" fmla="*/ 3622231 h 5470974"/>
+                  <a:gd name="connsiteX9" fmla="*/ 2502709 w 2628430"/>
+                  <a:gd name="connsiteY9" fmla="*/ 4508922 h 5470974"/>
+                  <a:gd name="connsiteX10" fmla="*/ 2599690 w 2628430"/>
+                  <a:gd name="connsiteY10" fmla="*/ 5132377 h 5470974"/>
+                  <a:gd name="connsiteX11" fmla="*/ 2170200 w 2628430"/>
+                  <a:gd name="connsiteY11" fmla="*/ 5423322 h 5470974"/>
+                  <a:gd name="connsiteX12" fmla="*/ 729327 w 2628430"/>
+                  <a:gd name="connsiteY12" fmla="*/ 5395613 h 5470974"/>
+                  <a:gd name="connsiteX13" fmla="*/ 452236 w 2628430"/>
+                  <a:gd name="connsiteY13" fmla="*/ 4744449 h 5470974"/>
+                  <a:gd name="connsiteX0" fmla="*/ 452236 w 2628430"/>
+                  <a:gd name="connsiteY0" fmla="*/ 4744449 h 5464715"/>
+                  <a:gd name="connsiteX1" fmla="*/ 8891 w 2628430"/>
+                  <a:gd name="connsiteY1" fmla="*/ 2749394 h 5464715"/>
+                  <a:gd name="connsiteX2" fmla="*/ 175146 w 2628430"/>
+                  <a:gd name="connsiteY2" fmla="*/ 1211540 h 5464715"/>
+                  <a:gd name="connsiteX3" fmla="*/ 410673 w 2628430"/>
+                  <a:gd name="connsiteY3" fmla="*/ 394122 h 5464715"/>
+                  <a:gd name="connsiteX4" fmla="*/ 1186527 w 2628430"/>
+                  <a:gd name="connsiteY4" fmla="*/ 6194 h 5464715"/>
+                  <a:gd name="connsiteX5" fmla="*/ 2142491 w 2628430"/>
+                  <a:gd name="connsiteY5" fmla="*/ 269431 h 5464715"/>
+                  <a:gd name="connsiteX6" fmla="*/ 2447291 w 2628430"/>
+                  <a:gd name="connsiteY6" fmla="*/ 1599467 h 5464715"/>
+                  <a:gd name="connsiteX7" fmla="*/ 1990091 w 2628430"/>
+                  <a:gd name="connsiteY7" fmla="*/ 2610849 h 5464715"/>
+                  <a:gd name="connsiteX8" fmla="*/ 1809982 w 2628430"/>
+                  <a:gd name="connsiteY8" fmla="*/ 3622231 h 5464715"/>
+                  <a:gd name="connsiteX9" fmla="*/ 2502709 w 2628430"/>
+                  <a:gd name="connsiteY9" fmla="*/ 4508922 h 5464715"/>
+                  <a:gd name="connsiteX10" fmla="*/ 2599690 w 2628430"/>
+                  <a:gd name="connsiteY10" fmla="*/ 5132377 h 5464715"/>
+                  <a:gd name="connsiteX11" fmla="*/ 2170200 w 2628430"/>
+                  <a:gd name="connsiteY11" fmla="*/ 5423322 h 5464715"/>
+                  <a:gd name="connsiteX12" fmla="*/ 895581 w 2628430"/>
+                  <a:gd name="connsiteY12" fmla="*/ 5381759 h 5464715"/>
+                  <a:gd name="connsiteX13" fmla="*/ 452236 w 2628430"/>
+                  <a:gd name="connsiteY13" fmla="*/ 4744449 h 5464715"/>
+                  <a:gd name="connsiteX0" fmla="*/ 281453 w 2457647"/>
+                  <a:gd name="connsiteY0" fmla="*/ 4744449 h 5464715"/>
+                  <a:gd name="connsiteX1" fmla="*/ 101345 w 2457647"/>
+                  <a:gd name="connsiteY1" fmla="*/ 2790958 h 5464715"/>
+                  <a:gd name="connsiteX2" fmla="*/ 4363 w 2457647"/>
+                  <a:gd name="connsiteY2" fmla="*/ 1211540 h 5464715"/>
+                  <a:gd name="connsiteX3" fmla="*/ 239890 w 2457647"/>
+                  <a:gd name="connsiteY3" fmla="*/ 394122 h 5464715"/>
+                  <a:gd name="connsiteX4" fmla="*/ 1015744 w 2457647"/>
+                  <a:gd name="connsiteY4" fmla="*/ 6194 h 5464715"/>
+                  <a:gd name="connsiteX5" fmla="*/ 1971708 w 2457647"/>
+                  <a:gd name="connsiteY5" fmla="*/ 269431 h 5464715"/>
+                  <a:gd name="connsiteX6" fmla="*/ 2276508 w 2457647"/>
+                  <a:gd name="connsiteY6" fmla="*/ 1599467 h 5464715"/>
+                  <a:gd name="connsiteX7" fmla="*/ 1819308 w 2457647"/>
+                  <a:gd name="connsiteY7" fmla="*/ 2610849 h 5464715"/>
+                  <a:gd name="connsiteX8" fmla="*/ 1639199 w 2457647"/>
+                  <a:gd name="connsiteY8" fmla="*/ 3622231 h 5464715"/>
+                  <a:gd name="connsiteX9" fmla="*/ 2331926 w 2457647"/>
+                  <a:gd name="connsiteY9" fmla="*/ 4508922 h 5464715"/>
+                  <a:gd name="connsiteX10" fmla="*/ 2428907 w 2457647"/>
+                  <a:gd name="connsiteY10" fmla="*/ 5132377 h 5464715"/>
+                  <a:gd name="connsiteX11" fmla="*/ 1999417 w 2457647"/>
+                  <a:gd name="connsiteY11" fmla="*/ 5423322 h 5464715"/>
+                  <a:gd name="connsiteX12" fmla="*/ 724798 w 2457647"/>
+                  <a:gd name="connsiteY12" fmla="*/ 5381759 h 5464715"/>
+                  <a:gd name="connsiteX13" fmla="*/ 281453 w 2457647"/>
+                  <a:gd name="connsiteY13" fmla="*/ 4744449 h 5464715"/>
+                  <a:gd name="connsiteX0" fmla="*/ 182997 w 2359191"/>
+                  <a:gd name="connsiteY0" fmla="*/ 4744449 h 5464715"/>
+                  <a:gd name="connsiteX1" fmla="*/ 2889 w 2359191"/>
+                  <a:gd name="connsiteY1" fmla="*/ 2790958 h 5464715"/>
+                  <a:gd name="connsiteX2" fmla="*/ 141434 w 2359191"/>
+                  <a:gd name="connsiteY2" fmla="*/ 394122 h 5464715"/>
+                  <a:gd name="connsiteX3" fmla="*/ 917288 w 2359191"/>
+                  <a:gd name="connsiteY3" fmla="*/ 6194 h 5464715"/>
+                  <a:gd name="connsiteX4" fmla="*/ 1873252 w 2359191"/>
+                  <a:gd name="connsiteY4" fmla="*/ 269431 h 5464715"/>
+                  <a:gd name="connsiteX5" fmla="*/ 2178052 w 2359191"/>
+                  <a:gd name="connsiteY5" fmla="*/ 1599467 h 5464715"/>
+                  <a:gd name="connsiteX6" fmla="*/ 1720852 w 2359191"/>
+                  <a:gd name="connsiteY6" fmla="*/ 2610849 h 5464715"/>
+                  <a:gd name="connsiteX7" fmla="*/ 1540743 w 2359191"/>
+                  <a:gd name="connsiteY7" fmla="*/ 3622231 h 5464715"/>
+                  <a:gd name="connsiteX8" fmla="*/ 2233470 w 2359191"/>
+                  <a:gd name="connsiteY8" fmla="*/ 4508922 h 5464715"/>
+                  <a:gd name="connsiteX9" fmla="*/ 2330451 w 2359191"/>
+                  <a:gd name="connsiteY9" fmla="*/ 5132377 h 5464715"/>
+                  <a:gd name="connsiteX10" fmla="*/ 1900961 w 2359191"/>
+                  <a:gd name="connsiteY10" fmla="*/ 5423322 h 5464715"/>
+                  <a:gd name="connsiteX11" fmla="*/ 626342 w 2359191"/>
+                  <a:gd name="connsiteY11" fmla="*/ 5381759 h 5464715"/>
+                  <a:gd name="connsiteX12" fmla="*/ 182997 w 2359191"/>
+                  <a:gd name="connsiteY12" fmla="*/ 4744449 h 5464715"/>
+                  <a:gd name="connsiteX0" fmla="*/ 180110 w 2356304"/>
+                  <a:gd name="connsiteY0" fmla="*/ 4785805 h 5506071"/>
+                  <a:gd name="connsiteX1" fmla="*/ 2 w 2356304"/>
+                  <a:gd name="connsiteY1" fmla="*/ 2832314 h 5506071"/>
+                  <a:gd name="connsiteX2" fmla="*/ 182207 w 2356304"/>
+                  <a:gd name="connsiteY2" fmla="*/ 1038518 h 5506071"/>
+                  <a:gd name="connsiteX3" fmla="*/ 914401 w 2356304"/>
+                  <a:gd name="connsiteY3" fmla="*/ 47550 h 5506071"/>
+                  <a:gd name="connsiteX4" fmla="*/ 1870365 w 2356304"/>
+                  <a:gd name="connsiteY4" fmla="*/ 310787 h 5506071"/>
+                  <a:gd name="connsiteX5" fmla="*/ 2175165 w 2356304"/>
+                  <a:gd name="connsiteY5" fmla="*/ 1640823 h 5506071"/>
+                  <a:gd name="connsiteX6" fmla="*/ 1717965 w 2356304"/>
+                  <a:gd name="connsiteY6" fmla="*/ 2652205 h 5506071"/>
+                  <a:gd name="connsiteX7" fmla="*/ 1537856 w 2356304"/>
+                  <a:gd name="connsiteY7" fmla="*/ 3663587 h 5506071"/>
+                  <a:gd name="connsiteX8" fmla="*/ 2230583 w 2356304"/>
+                  <a:gd name="connsiteY8" fmla="*/ 4550278 h 5506071"/>
+                  <a:gd name="connsiteX9" fmla="*/ 2327564 w 2356304"/>
+                  <a:gd name="connsiteY9" fmla="*/ 5173733 h 5506071"/>
+                  <a:gd name="connsiteX10" fmla="*/ 1898074 w 2356304"/>
+                  <a:gd name="connsiteY10" fmla="*/ 5464678 h 5506071"/>
+                  <a:gd name="connsiteX11" fmla="*/ 623455 w 2356304"/>
+                  <a:gd name="connsiteY11" fmla="*/ 5423115 h 5506071"/>
+                  <a:gd name="connsiteX12" fmla="*/ 180110 w 2356304"/>
+                  <a:gd name="connsiteY12" fmla="*/ 4785805 h 5506071"/>
+                  <a:gd name="connsiteX0" fmla="*/ 181079 w 2357273"/>
+                  <a:gd name="connsiteY0" fmla="*/ 4796399 h 5516665"/>
+                  <a:gd name="connsiteX1" fmla="*/ 971 w 2357273"/>
+                  <a:gd name="connsiteY1" fmla="*/ 2842908 h 5516665"/>
+                  <a:gd name="connsiteX2" fmla="*/ 248289 w 2357273"/>
+                  <a:gd name="connsiteY2" fmla="*/ 1196366 h 5516665"/>
+                  <a:gd name="connsiteX3" fmla="*/ 915370 w 2357273"/>
+                  <a:gd name="connsiteY3" fmla="*/ 58144 h 5516665"/>
+                  <a:gd name="connsiteX4" fmla="*/ 1871334 w 2357273"/>
+                  <a:gd name="connsiteY4" fmla="*/ 321381 h 5516665"/>
+                  <a:gd name="connsiteX5" fmla="*/ 2176134 w 2357273"/>
+                  <a:gd name="connsiteY5" fmla="*/ 1651417 h 5516665"/>
+                  <a:gd name="connsiteX6" fmla="*/ 1718934 w 2357273"/>
+                  <a:gd name="connsiteY6" fmla="*/ 2662799 h 5516665"/>
+                  <a:gd name="connsiteX7" fmla="*/ 1538825 w 2357273"/>
+                  <a:gd name="connsiteY7" fmla="*/ 3674181 h 5516665"/>
+                  <a:gd name="connsiteX8" fmla="*/ 2231552 w 2357273"/>
+                  <a:gd name="connsiteY8" fmla="*/ 4560872 h 5516665"/>
+                  <a:gd name="connsiteX9" fmla="*/ 2328533 w 2357273"/>
+                  <a:gd name="connsiteY9" fmla="*/ 5184327 h 5516665"/>
+                  <a:gd name="connsiteX10" fmla="*/ 1899043 w 2357273"/>
+                  <a:gd name="connsiteY10" fmla="*/ 5475272 h 5516665"/>
+                  <a:gd name="connsiteX11" fmla="*/ 624424 w 2357273"/>
+                  <a:gd name="connsiteY11" fmla="*/ 5433709 h 5516665"/>
+                  <a:gd name="connsiteX12" fmla="*/ 181079 w 2357273"/>
+                  <a:gd name="connsiteY12" fmla="*/ 4796399 h 5516665"/>
+                </a:gdLst>
+                <a:ahLst/>
+                <a:cxnLst>
+                  <a:cxn ang="0">
+                    <a:pos x="connsiteX0" y="connsiteY0"/>
+                  </a:cxn>
+                  <a:cxn ang="0">
+                    <a:pos x="connsiteX1" y="connsiteY1"/>
+                  </a:cxn>
+                  <a:cxn ang="0">
+                    <a:pos x="connsiteX2" y="connsiteY2"/>
+                  </a:cxn>
+                  <a:cxn ang="0">
+                    <a:pos x="connsiteX3" y="connsiteY3"/>
+                  </a:cxn>
+                  <a:cxn ang="0">
+                    <a:pos x="connsiteX4" y="connsiteY4"/>
+                  </a:cxn>
+                  <a:cxn ang="0">
+                    <a:pos x="connsiteX5" y="connsiteY5"/>
+                  </a:cxn>
+                  <a:cxn ang="0">
+                    <a:pos x="connsiteX6" y="connsiteY6"/>
+                  </a:cxn>
+                  <a:cxn ang="0">
+                    <a:pos x="connsiteX7" y="connsiteY7"/>
+                  </a:cxn>
+                  <a:cxn ang="0">
+                    <a:pos x="connsiteX8" y="connsiteY8"/>
+                  </a:cxn>
+                  <a:cxn ang="0">
+                    <a:pos x="connsiteX9" y="connsiteY9"/>
+                  </a:cxn>
+                  <a:cxn ang="0">
+                    <a:pos x="connsiteX10" y="connsiteY10"/>
+                  </a:cxn>
+                  <a:cxn ang="0">
+                    <a:pos x="connsiteX11" y="connsiteY11"/>
+                  </a:cxn>
+                  <a:cxn ang="0">
+                    <a:pos x="connsiteX12" y="connsiteY12"/>
+                  </a:cxn>
+                </a:cxnLst>
+                <a:rect l="l" t="t" r="r" b="b"/>
+                <a:pathLst>
+                  <a:path w="2357273" h="5516665">
+                    <a:moveTo>
+                      <a:pt x="181079" y="4796399"/>
+                    </a:moveTo>
+                    <a:cubicBezTo>
+                      <a:pt x="77170" y="4364599"/>
+                      <a:pt x="-10231" y="3442913"/>
+                      <a:pt x="971" y="2842908"/>
+                    </a:cubicBezTo>
+                    <a:cubicBezTo>
+                      <a:pt x="12173" y="2242903"/>
+                      <a:pt x="95889" y="1660493"/>
+                      <a:pt x="248289" y="1196366"/>
+                    </a:cubicBezTo>
+                    <a:cubicBezTo>
+                      <a:pt x="400689" y="732239"/>
+                      <a:pt x="644863" y="203975"/>
+                      <a:pt x="915370" y="58144"/>
+                    </a:cubicBezTo>
+                    <a:cubicBezTo>
+                      <a:pt x="1185878" y="-87687"/>
+                      <a:pt x="1661207" y="55836"/>
+                      <a:pt x="1871334" y="321381"/>
+                    </a:cubicBezTo>
+                    <a:cubicBezTo>
+                      <a:pt x="2081461" y="586926"/>
+                      <a:pt x="2201534" y="1261181"/>
+                      <a:pt x="2176134" y="1651417"/>
+                    </a:cubicBezTo>
+                    <a:cubicBezTo>
+                      <a:pt x="2150734" y="2041653"/>
+                      <a:pt x="1825152" y="2325672"/>
+                      <a:pt x="1718934" y="2662799"/>
+                    </a:cubicBezTo>
+                    <a:cubicBezTo>
+                      <a:pt x="1612716" y="2999926"/>
+                      <a:pt x="1453389" y="3357836"/>
+                      <a:pt x="1538825" y="3674181"/>
+                    </a:cubicBezTo>
+                    <a:cubicBezTo>
+                      <a:pt x="1624261" y="3990527"/>
+                      <a:pt x="2099934" y="4309181"/>
+                      <a:pt x="2231552" y="4560872"/>
+                    </a:cubicBezTo>
+                    <a:cubicBezTo>
+                      <a:pt x="2363170" y="4812563"/>
+                      <a:pt x="2383951" y="5031927"/>
+                      <a:pt x="2328533" y="5184327"/>
+                    </a:cubicBezTo>
+                    <a:cubicBezTo>
+                      <a:pt x="2273115" y="5336727"/>
+                      <a:pt x="2259261" y="5417545"/>
+                      <a:pt x="1899043" y="5475272"/>
+                    </a:cubicBezTo>
+                    <a:cubicBezTo>
+                      <a:pt x="1538825" y="5532999"/>
+                      <a:pt x="908442" y="5539927"/>
+                      <a:pt x="624424" y="5433709"/>
+                    </a:cubicBezTo>
+                    <a:cubicBezTo>
+                      <a:pt x="340406" y="5327491"/>
+                      <a:pt x="284988" y="5228199"/>
+                      <a:pt x="181079" y="4796399"/>
+                    </a:cubicBezTo>
+                    <a:close/>
+                  </a:path>
+                </a:pathLst>
+              </a:custGeom>
+              <a:solidFill>
+                <a:schemeClr val="accent2"/>
+              </a:solidFill>
+              <a:ln>
+                <a:noFill/>
+              </a:ln>
+            </p:spPr>
+            <p:style>
+              <a:lnRef idx="2">
+                <a:schemeClr val="accent1">
+                  <a:shade val="50000"/>
+                </a:schemeClr>
+              </a:lnRef>
+              <a:fillRef idx="1">
+                <a:schemeClr val="accent1"/>
+              </a:fillRef>
+              <a:effectRef idx="0">
+                <a:schemeClr val="accent1"/>
+              </a:effectRef>
+              <a:fontRef idx="minor">
+                <a:schemeClr val="lt1"/>
+              </a:fontRef>
+            </p:style>
+            <p:txBody>
+              <a:bodyPr rtlCol="0" anchor="ctr"/>
+              <a:lstStyle/>
+              <a:p>
+                <a:pPr algn="ctr"/>
+                <a:endParaRPr lang="en-US"/>
+              </a:p>
+            </p:txBody>
+          </p:sp>
+          <p:sp>
+            <p:nvSpPr>
+              <p:cNvPr id="9" name="Oval 8">
+                <a:extLst>
+                  <a:ext uri="{FF2B5EF4-FFF2-40B4-BE49-F238E27FC236}">
+                    <a16:creationId xmlns:a16="http://schemas.microsoft.com/office/drawing/2014/main" id="{20284252-355E-581E-6115-3C347C5C4F97}"/>
+                  </a:ext>
+                </a:extLst>
+              </p:cNvPr>
+              <p:cNvSpPr/>
+              <p:nvPr/>
+            </p:nvSpPr>
+            <p:spPr>
+              <a:xfrm rot="10800000">
+                <a:off x="9506781" y="1985356"/>
+                <a:ext cx="609600" cy="893561"/>
+              </a:xfrm>
+              <a:prstGeom prst="ellipse">
+                <a:avLst/>
+              </a:prstGeom>
+              <a:solidFill>
+                <a:schemeClr val="accent2"/>
+              </a:solidFill>
+              <a:ln>
+                <a:noFill/>
+              </a:ln>
+              <a:effectLst/>
+            </p:spPr>
+            <p:style>
+              <a:lnRef idx="2">
+                <a:schemeClr val="accent1">
+                  <a:shade val="50000"/>
+                </a:schemeClr>
+              </a:lnRef>
+              <a:fillRef idx="1">
+                <a:schemeClr val="accent1"/>
+              </a:fillRef>
+              <a:effectRef idx="0">
+                <a:schemeClr val="accent1"/>
+              </a:effectRef>
+              <a:fontRef idx="minor">
+                <a:schemeClr val="lt1"/>
+              </a:fontRef>
+            </p:style>
+            <p:txBody>
+              <a:bodyPr rtlCol="0" anchor="ctr"/>
+              <a:lstStyle/>
+              <a:p>
+                <a:pPr algn="ctr"/>
+                <a:endParaRPr lang="en-US"/>
+              </a:p>
+            </p:txBody>
+          </p:sp>
+          <p:sp>
+            <p:nvSpPr>
+              <p:cNvPr id="10" name="Oval 9">
+                <a:extLst>
+                  <a:ext uri="{FF2B5EF4-FFF2-40B4-BE49-F238E27FC236}">
+                    <a16:creationId xmlns:a16="http://schemas.microsoft.com/office/drawing/2014/main" id="{7CA035DB-7AF6-23D8-278B-83529901E845}"/>
+                  </a:ext>
+                </a:extLst>
+              </p:cNvPr>
+              <p:cNvSpPr/>
+              <p:nvPr/>
+            </p:nvSpPr>
+            <p:spPr>
+              <a:xfrm rot="10800000">
+                <a:off x="9107731" y="2190964"/>
+                <a:ext cx="274361" cy="548640"/>
+              </a:xfrm>
+              <a:prstGeom prst="ellipse">
+                <a:avLst/>
+              </a:prstGeom>
+              <a:solidFill>
+                <a:schemeClr val="accent2"/>
+              </a:solidFill>
+              <a:ln>
+                <a:noFill/>
+              </a:ln>
+              <a:effectLst/>
+            </p:spPr>
+            <p:style>
+              <a:lnRef idx="2">
+                <a:schemeClr val="accent1">
+                  <a:shade val="50000"/>
+                </a:schemeClr>
+              </a:lnRef>
+              <a:fillRef idx="1">
+                <a:schemeClr val="accent1"/>
+              </a:fillRef>
+              <a:effectRef idx="0">
+                <a:schemeClr val="accent1"/>
+              </a:effectRef>
+              <a:fontRef idx="minor">
+                <a:schemeClr val="lt1"/>
+              </a:fontRef>
+            </p:style>
+            <p:txBody>
+              <a:bodyPr rtlCol="0" anchor="ctr"/>
+              <a:lstStyle/>
+              <a:p>
+                <a:pPr algn="ctr"/>
+                <a:endParaRPr lang="en-US"/>
+              </a:p>
+            </p:txBody>
+          </p:sp>
+          <p:sp>
+            <p:nvSpPr>
+              <p:cNvPr id="11" name="Oval 10">
+                <a:extLst>
+                  <a:ext uri="{FF2B5EF4-FFF2-40B4-BE49-F238E27FC236}">
+                    <a16:creationId xmlns:a16="http://schemas.microsoft.com/office/drawing/2014/main" id="{8EDA69D9-43C0-01AA-07EE-528C1BC77A3A}"/>
+                  </a:ext>
+                </a:extLst>
+              </p:cNvPr>
+              <p:cNvSpPr/>
+              <p:nvPr/>
+            </p:nvSpPr>
+            <p:spPr>
+              <a:xfrm rot="10800000">
+                <a:off x="8741529" y="2282404"/>
+                <a:ext cx="274361" cy="548640"/>
+              </a:xfrm>
+              <a:prstGeom prst="ellipse">
+                <a:avLst/>
+              </a:prstGeom>
+              <a:solidFill>
+                <a:schemeClr val="accent2"/>
+              </a:solidFill>
+              <a:ln>
+                <a:noFill/>
+              </a:ln>
+              <a:effectLst/>
+            </p:spPr>
+            <p:style>
+              <a:lnRef idx="2">
+                <a:schemeClr val="accent1">
+                  <a:shade val="50000"/>
+                </a:schemeClr>
+              </a:lnRef>
+              <a:fillRef idx="1">
+                <a:schemeClr val="accent1"/>
+              </a:fillRef>
+              <a:effectRef idx="0">
+                <a:schemeClr val="accent1"/>
+              </a:effectRef>
+              <a:fontRef idx="minor">
+                <a:schemeClr val="lt1"/>
+              </a:fontRef>
+            </p:style>
+            <p:txBody>
+              <a:bodyPr rtlCol="0" anchor="ctr"/>
+              <a:lstStyle/>
+              <a:p>
+                <a:pPr algn="ctr"/>
+                <a:endParaRPr lang="en-US"/>
+              </a:p>
+            </p:txBody>
+          </p:sp>
+          <p:sp>
+            <p:nvSpPr>
+              <p:cNvPr id="12" name="Oval 11">
+                <a:extLst>
+                  <a:ext uri="{FF2B5EF4-FFF2-40B4-BE49-F238E27FC236}">
+                    <a16:creationId xmlns:a16="http://schemas.microsoft.com/office/drawing/2014/main" id="{846195EC-F0A2-9DE4-1E57-876E934E82D7}"/>
+                  </a:ext>
+                </a:extLst>
+              </p:cNvPr>
+              <p:cNvSpPr/>
+              <p:nvPr/>
+            </p:nvSpPr>
+            <p:spPr>
+              <a:xfrm rot="10800000">
+                <a:off x="8392434" y="2393906"/>
+                <a:ext cx="274361" cy="457200"/>
+              </a:xfrm>
+              <a:prstGeom prst="ellipse">
+                <a:avLst/>
+              </a:prstGeom>
+              <a:solidFill>
+                <a:schemeClr val="accent2"/>
+              </a:solidFill>
+              <a:ln>
+                <a:noFill/>
+              </a:ln>
+              <a:effectLst/>
+            </p:spPr>
+            <p:style>
+              <a:lnRef idx="2">
+                <a:schemeClr val="accent1">
+                  <a:shade val="50000"/>
+                </a:schemeClr>
+              </a:lnRef>
+              <a:fillRef idx="1">
+                <a:schemeClr val="accent1"/>
+              </a:fillRef>
+              <a:effectRef idx="0">
+                <a:schemeClr val="accent1"/>
+              </a:effectRef>
+              <a:fontRef idx="minor">
+                <a:schemeClr val="lt1"/>
+              </a:fontRef>
+            </p:style>
+            <p:txBody>
+              <a:bodyPr rtlCol="0" anchor="ctr"/>
+              <a:lstStyle/>
+              <a:p>
+                <a:pPr algn="ctr"/>
+                <a:endParaRPr lang="en-US"/>
+              </a:p>
+            </p:txBody>
+          </p:sp>
+          <p:sp>
+            <p:nvSpPr>
+              <p:cNvPr id="13" name="Oval 12">
+                <a:extLst>
+                  <a:ext uri="{FF2B5EF4-FFF2-40B4-BE49-F238E27FC236}">
+                    <a16:creationId xmlns:a16="http://schemas.microsoft.com/office/drawing/2014/main" id="{D9E63E10-6A63-6754-2CB5-09F3EBF7124C}"/>
+                  </a:ext>
+                </a:extLst>
+              </p:cNvPr>
+              <p:cNvSpPr/>
+              <p:nvPr/>
+            </p:nvSpPr>
+            <p:spPr>
+              <a:xfrm rot="10800000">
+                <a:off x="8040832" y="2648164"/>
+                <a:ext cx="274361" cy="365760"/>
+              </a:xfrm>
+              <a:prstGeom prst="ellipse">
+                <a:avLst/>
+              </a:prstGeom>
+              <a:solidFill>
+                <a:schemeClr val="accent2"/>
+              </a:solidFill>
+              <a:ln>
+                <a:noFill/>
+              </a:ln>
+              <a:effectLst/>
+            </p:spPr>
+            <p:style>
+              <a:lnRef idx="2">
+                <a:schemeClr val="accent1">
+                  <a:shade val="50000"/>
+                </a:schemeClr>
+              </a:lnRef>
+              <a:fillRef idx="1">
+                <a:schemeClr val="accent1"/>
+              </a:fillRef>
+              <a:effectRef idx="0">
+                <a:schemeClr val="accent1"/>
+              </a:effectRef>
+              <a:fontRef idx="minor">
+                <a:schemeClr val="lt1"/>
+              </a:fontRef>
+            </p:style>
+            <p:txBody>
+              <a:bodyPr rtlCol="0" anchor="ctr"/>
+              <a:lstStyle/>
+              <a:p>
+                <a:pPr algn="ctr"/>
+                <a:endParaRPr lang="en-US"/>
+              </a:p>
+            </p:txBody>
+          </p:sp>
+        </p:grpSp>
+        <p:grpSp>
+          <p:nvGrpSpPr>
+            <p:cNvPr id="14" name="Group 13">
+              <a:extLst>
+                <a:ext uri="{FF2B5EF4-FFF2-40B4-BE49-F238E27FC236}">
+                  <a16:creationId xmlns:a16="http://schemas.microsoft.com/office/drawing/2014/main" id="{2747C04E-AC55-1872-B259-911ACFB3271E}"/>
+                </a:ext>
+              </a:extLst>
+            </p:cNvPr>
+            <p:cNvGrpSpPr/>
+            <p:nvPr/>
+          </p:nvGrpSpPr>
+          <p:grpSpPr>
+            <a:xfrm rot="4881240">
+              <a:off x="7240202" y="4320867"/>
+              <a:ext cx="230767" cy="527018"/>
+              <a:chOff x="8668623" y="1008139"/>
+              <a:chExt cx="2146049" cy="4901076"/>
+            </a:xfrm>
+          </p:grpSpPr>
+          <p:sp>
+            <p:nvSpPr>
+              <p:cNvPr id="15" name="Freeform 4">
+                <a:extLst>
+                  <a:ext uri="{FF2B5EF4-FFF2-40B4-BE49-F238E27FC236}">
+                    <a16:creationId xmlns:a16="http://schemas.microsoft.com/office/drawing/2014/main" id="{55237AD0-8C03-CD6C-ADC7-930CA406893A}"/>
+                  </a:ext>
+                </a:extLst>
+              </p:cNvPr>
+              <p:cNvSpPr/>
+              <p:nvPr/>
+            </p:nvSpPr>
+            <p:spPr>
+              <a:xfrm rot="10984993">
+                <a:off x="8668623" y="1996245"/>
+                <a:ext cx="2140997" cy="3912970"/>
+              </a:xfrm>
+              <a:custGeom>
+                <a:avLst/>
+                <a:gdLst>
+                  <a:gd name="connsiteX0" fmla="*/ 452236 w 2914469"/>
+                  <a:gd name="connsiteY0" fmla="*/ 4744449 h 5470974"/>
+                  <a:gd name="connsiteX1" fmla="*/ 8891 w 2914469"/>
+                  <a:gd name="connsiteY1" fmla="*/ 2749394 h 5470974"/>
+                  <a:gd name="connsiteX2" fmla="*/ 175146 w 2914469"/>
+                  <a:gd name="connsiteY2" fmla="*/ 1211540 h 5470974"/>
+                  <a:gd name="connsiteX3" fmla="*/ 410673 w 2914469"/>
+                  <a:gd name="connsiteY3" fmla="*/ 394122 h 5470974"/>
+                  <a:gd name="connsiteX4" fmla="*/ 1186527 w 2914469"/>
+                  <a:gd name="connsiteY4" fmla="*/ 6194 h 5470974"/>
+                  <a:gd name="connsiteX5" fmla="*/ 2142491 w 2914469"/>
+                  <a:gd name="connsiteY5" fmla="*/ 269431 h 5470974"/>
+                  <a:gd name="connsiteX6" fmla="*/ 2447291 w 2914469"/>
+                  <a:gd name="connsiteY6" fmla="*/ 1599467 h 5470974"/>
+                  <a:gd name="connsiteX7" fmla="*/ 1990091 w 2914469"/>
+                  <a:gd name="connsiteY7" fmla="*/ 2610849 h 5470974"/>
+                  <a:gd name="connsiteX8" fmla="*/ 1809982 w 2914469"/>
+                  <a:gd name="connsiteY8" fmla="*/ 3622231 h 5470974"/>
+                  <a:gd name="connsiteX9" fmla="*/ 2655109 w 2914469"/>
+                  <a:gd name="connsiteY9" fmla="*/ 4522776 h 5470974"/>
+                  <a:gd name="connsiteX10" fmla="*/ 2890636 w 2914469"/>
+                  <a:gd name="connsiteY10" fmla="*/ 5049249 h 5470974"/>
+                  <a:gd name="connsiteX11" fmla="*/ 2170200 w 2914469"/>
+                  <a:gd name="connsiteY11" fmla="*/ 5423322 h 5470974"/>
+                  <a:gd name="connsiteX12" fmla="*/ 729327 w 2914469"/>
+                  <a:gd name="connsiteY12" fmla="*/ 5395613 h 5470974"/>
+                  <a:gd name="connsiteX13" fmla="*/ 452236 w 2914469"/>
+                  <a:gd name="connsiteY13" fmla="*/ 4744449 h 5470974"/>
+                  <a:gd name="connsiteX0" fmla="*/ 452236 w 2733397"/>
+                  <a:gd name="connsiteY0" fmla="*/ 4744449 h 5470974"/>
+                  <a:gd name="connsiteX1" fmla="*/ 8891 w 2733397"/>
+                  <a:gd name="connsiteY1" fmla="*/ 2749394 h 5470974"/>
+                  <a:gd name="connsiteX2" fmla="*/ 175146 w 2733397"/>
+                  <a:gd name="connsiteY2" fmla="*/ 1211540 h 5470974"/>
+                  <a:gd name="connsiteX3" fmla="*/ 410673 w 2733397"/>
+                  <a:gd name="connsiteY3" fmla="*/ 394122 h 5470974"/>
+                  <a:gd name="connsiteX4" fmla="*/ 1186527 w 2733397"/>
+                  <a:gd name="connsiteY4" fmla="*/ 6194 h 5470974"/>
+                  <a:gd name="connsiteX5" fmla="*/ 2142491 w 2733397"/>
+                  <a:gd name="connsiteY5" fmla="*/ 269431 h 5470974"/>
+                  <a:gd name="connsiteX6" fmla="*/ 2447291 w 2733397"/>
+                  <a:gd name="connsiteY6" fmla="*/ 1599467 h 5470974"/>
+                  <a:gd name="connsiteX7" fmla="*/ 1990091 w 2733397"/>
+                  <a:gd name="connsiteY7" fmla="*/ 2610849 h 5470974"/>
+                  <a:gd name="connsiteX8" fmla="*/ 1809982 w 2733397"/>
+                  <a:gd name="connsiteY8" fmla="*/ 3622231 h 5470974"/>
+                  <a:gd name="connsiteX9" fmla="*/ 2655109 w 2733397"/>
+                  <a:gd name="connsiteY9" fmla="*/ 4522776 h 5470974"/>
+                  <a:gd name="connsiteX10" fmla="*/ 2641254 w 2733397"/>
+                  <a:gd name="connsiteY10" fmla="*/ 5146231 h 5470974"/>
+                  <a:gd name="connsiteX11" fmla="*/ 2170200 w 2733397"/>
+                  <a:gd name="connsiteY11" fmla="*/ 5423322 h 5470974"/>
+                  <a:gd name="connsiteX12" fmla="*/ 729327 w 2733397"/>
+                  <a:gd name="connsiteY12" fmla="*/ 5395613 h 5470974"/>
+                  <a:gd name="connsiteX13" fmla="*/ 452236 w 2733397"/>
+                  <a:gd name="connsiteY13" fmla="*/ 4744449 h 5470974"/>
+                  <a:gd name="connsiteX0" fmla="*/ 452236 w 2662490"/>
+                  <a:gd name="connsiteY0" fmla="*/ 4744449 h 5470974"/>
+                  <a:gd name="connsiteX1" fmla="*/ 8891 w 2662490"/>
+                  <a:gd name="connsiteY1" fmla="*/ 2749394 h 5470974"/>
+                  <a:gd name="connsiteX2" fmla="*/ 175146 w 2662490"/>
+                  <a:gd name="connsiteY2" fmla="*/ 1211540 h 5470974"/>
+                  <a:gd name="connsiteX3" fmla="*/ 410673 w 2662490"/>
+                  <a:gd name="connsiteY3" fmla="*/ 394122 h 5470974"/>
+                  <a:gd name="connsiteX4" fmla="*/ 1186527 w 2662490"/>
+                  <a:gd name="connsiteY4" fmla="*/ 6194 h 5470974"/>
+                  <a:gd name="connsiteX5" fmla="*/ 2142491 w 2662490"/>
+                  <a:gd name="connsiteY5" fmla="*/ 269431 h 5470974"/>
+                  <a:gd name="connsiteX6" fmla="*/ 2447291 w 2662490"/>
+                  <a:gd name="connsiteY6" fmla="*/ 1599467 h 5470974"/>
+                  <a:gd name="connsiteX7" fmla="*/ 1990091 w 2662490"/>
+                  <a:gd name="connsiteY7" fmla="*/ 2610849 h 5470974"/>
+                  <a:gd name="connsiteX8" fmla="*/ 1809982 w 2662490"/>
+                  <a:gd name="connsiteY8" fmla="*/ 3622231 h 5470974"/>
+                  <a:gd name="connsiteX9" fmla="*/ 2502709 w 2662490"/>
+                  <a:gd name="connsiteY9" fmla="*/ 4508922 h 5470974"/>
+                  <a:gd name="connsiteX10" fmla="*/ 2641254 w 2662490"/>
+                  <a:gd name="connsiteY10" fmla="*/ 5146231 h 5470974"/>
+                  <a:gd name="connsiteX11" fmla="*/ 2170200 w 2662490"/>
+                  <a:gd name="connsiteY11" fmla="*/ 5423322 h 5470974"/>
+                  <a:gd name="connsiteX12" fmla="*/ 729327 w 2662490"/>
+                  <a:gd name="connsiteY12" fmla="*/ 5395613 h 5470974"/>
+                  <a:gd name="connsiteX13" fmla="*/ 452236 w 2662490"/>
+                  <a:gd name="connsiteY13" fmla="*/ 4744449 h 5470974"/>
+                  <a:gd name="connsiteX0" fmla="*/ 452236 w 2628430"/>
+                  <a:gd name="connsiteY0" fmla="*/ 4744449 h 5470974"/>
+                  <a:gd name="connsiteX1" fmla="*/ 8891 w 2628430"/>
+                  <a:gd name="connsiteY1" fmla="*/ 2749394 h 5470974"/>
+                  <a:gd name="connsiteX2" fmla="*/ 175146 w 2628430"/>
+                  <a:gd name="connsiteY2" fmla="*/ 1211540 h 5470974"/>
+                  <a:gd name="connsiteX3" fmla="*/ 410673 w 2628430"/>
+                  <a:gd name="connsiteY3" fmla="*/ 394122 h 5470974"/>
+                  <a:gd name="connsiteX4" fmla="*/ 1186527 w 2628430"/>
+                  <a:gd name="connsiteY4" fmla="*/ 6194 h 5470974"/>
+                  <a:gd name="connsiteX5" fmla="*/ 2142491 w 2628430"/>
+                  <a:gd name="connsiteY5" fmla="*/ 269431 h 5470974"/>
+                  <a:gd name="connsiteX6" fmla="*/ 2447291 w 2628430"/>
+                  <a:gd name="connsiteY6" fmla="*/ 1599467 h 5470974"/>
+                  <a:gd name="connsiteX7" fmla="*/ 1990091 w 2628430"/>
+                  <a:gd name="connsiteY7" fmla="*/ 2610849 h 5470974"/>
+                  <a:gd name="connsiteX8" fmla="*/ 1809982 w 2628430"/>
+                  <a:gd name="connsiteY8" fmla="*/ 3622231 h 5470974"/>
+                  <a:gd name="connsiteX9" fmla="*/ 2502709 w 2628430"/>
+                  <a:gd name="connsiteY9" fmla="*/ 4508922 h 5470974"/>
+                  <a:gd name="connsiteX10" fmla="*/ 2599690 w 2628430"/>
+                  <a:gd name="connsiteY10" fmla="*/ 5132377 h 5470974"/>
+                  <a:gd name="connsiteX11" fmla="*/ 2170200 w 2628430"/>
+                  <a:gd name="connsiteY11" fmla="*/ 5423322 h 5470974"/>
+                  <a:gd name="connsiteX12" fmla="*/ 729327 w 2628430"/>
+                  <a:gd name="connsiteY12" fmla="*/ 5395613 h 5470974"/>
+                  <a:gd name="connsiteX13" fmla="*/ 452236 w 2628430"/>
+                  <a:gd name="connsiteY13" fmla="*/ 4744449 h 5470974"/>
+                  <a:gd name="connsiteX0" fmla="*/ 452236 w 2628430"/>
+                  <a:gd name="connsiteY0" fmla="*/ 4744449 h 5464715"/>
+                  <a:gd name="connsiteX1" fmla="*/ 8891 w 2628430"/>
+                  <a:gd name="connsiteY1" fmla="*/ 2749394 h 5464715"/>
+                  <a:gd name="connsiteX2" fmla="*/ 175146 w 2628430"/>
+                  <a:gd name="connsiteY2" fmla="*/ 1211540 h 5464715"/>
+                  <a:gd name="connsiteX3" fmla="*/ 410673 w 2628430"/>
+                  <a:gd name="connsiteY3" fmla="*/ 394122 h 5464715"/>
+                  <a:gd name="connsiteX4" fmla="*/ 1186527 w 2628430"/>
+                  <a:gd name="connsiteY4" fmla="*/ 6194 h 5464715"/>
+                  <a:gd name="connsiteX5" fmla="*/ 2142491 w 2628430"/>
+                  <a:gd name="connsiteY5" fmla="*/ 269431 h 5464715"/>
+                  <a:gd name="connsiteX6" fmla="*/ 2447291 w 2628430"/>
+                  <a:gd name="connsiteY6" fmla="*/ 1599467 h 5464715"/>
+                  <a:gd name="connsiteX7" fmla="*/ 1990091 w 2628430"/>
+                  <a:gd name="connsiteY7" fmla="*/ 2610849 h 5464715"/>
+                  <a:gd name="connsiteX8" fmla="*/ 1809982 w 2628430"/>
+                  <a:gd name="connsiteY8" fmla="*/ 3622231 h 5464715"/>
+                  <a:gd name="connsiteX9" fmla="*/ 2502709 w 2628430"/>
+                  <a:gd name="connsiteY9" fmla="*/ 4508922 h 5464715"/>
+                  <a:gd name="connsiteX10" fmla="*/ 2599690 w 2628430"/>
+                  <a:gd name="connsiteY10" fmla="*/ 5132377 h 5464715"/>
+                  <a:gd name="connsiteX11" fmla="*/ 2170200 w 2628430"/>
+                  <a:gd name="connsiteY11" fmla="*/ 5423322 h 5464715"/>
+                  <a:gd name="connsiteX12" fmla="*/ 895581 w 2628430"/>
+                  <a:gd name="connsiteY12" fmla="*/ 5381759 h 5464715"/>
+                  <a:gd name="connsiteX13" fmla="*/ 452236 w 2628430"/>
+                  <a:gd name="connsiteY13" fmla="*/ 4744449 h 5464715"/>
+                  <a:gd name="connsiteX0" fmla="*/ 281453 w 2457647"/>
+                  <a:gd name="connsiteY0" fmla="*/ 4744449 h 5464715"/>
+                  <a:gd name="connsiteX1" fmla="*/ 101345 w 2457647"/>
+                  <a:gd name="connsiteY1" fmla="*/ 2790958 h 5464715"/>
+                  <a:gd name="connsiteX2" fmla="*/ 4363 w 2457647"/>
+                  <a:gd name="connsiteY2" fmla="*/ 1211540 h 5464715"/>
+                  <a:gd name="connsiteX3" fmla="*/ 239890 w 2457647"/>
+                  <a:gd name="connsiteY3" fmla="*/ 394122 h 5464715"/>
+                  <a:gd name="connsiteX4" fmla="*/ 1015744 w 2457647"/>
+                  <a:gd name="connsiteY4" fmla="*/ 6194 h 5464715"/>
+                  <a:gd name="connsiteX5" fmla="*/ 1971708 w 2457647"/>
+                  <a:gd name="connsiteY5" fmla="*/ 269431 h 5464715"/>
+                  <a:gd name="connsiteX6" fmla="*/ 2276508 w 2457647"/>
+                  <a:gd name="connsiteY6" fmla="*/ 1599467 h 5464715"/>
+                  <a:gd name="connsiteX7" fmla="*/ 1819308 w 2457647"/>
+                  <a:gd name="connsiteY7" fmla="*/ 2610849 h 5464715"/>
+                  <a:gd name="connsiteX8" fmla="*/ 1639199 w 2457647"/>
+                  <a:gd name="connsiteY8" fmla="*/ 3622231 h 5464715"/>
+                  <a:gd name="connsiteX9" fmla="*/ 2331926 w 2457647"/>
+                  <a:gd name="connsiteY9" fmla="*/ 4508922 h 5464715"/>
+                  <a:gd name="connsiteX10" fmla="*/ 2428907 w 2457647"/>
+                  <a:gd name="connsiteY10" fmla="*/ 5132377 h 5464715"/>
+                  <a:gd name="connsiteX11" fmla="*/ 1999417 w 2457647"/>
+                  <a:gd name="connsiteY11" fmla="*/ 5423322 h 5464715"/>
+                  <a:gd name="connsiteX12" fmla="*/ 724798 w 2457647"/>
+                  <a:gd name="connsiteY12" fmla="*/ 5381759 h 5464715"/>
+                  <a:gd name="connsiteX13" fmla="*/ 281453 w 2457647"/>
+                  <a:gd name="connsiteY13" fmla="*/ 4744449 h 5464715"/>
+                  <a:gd name="connsiteX0" fmla="*/ 182997 w 2359191"/>
+                  <a:gd name="connsiteY0" fmla="*/ 4744449 h 5464715"/>
+                  <a:gd name="connsiteX1" fmla="*/ 2889 w 2359191"/>
+                  <a:gd name="connsiteY1" fmla="*/ 2790958 h 5464715"/>
+                  <a:gd name="connsiteX2" fmla="*/ 141434 w 2359191"/>
+                  <a:gd name="connsiteY2" fmla="*/ 394122 h 5464715"/>
+                  <a:gd name="connsiteX3" fmla="*/ 917288 w 2359191"/>
+                  <a:gd name="connsiteY3" fmla="*/ 6194 h 5464715"/>
+                  <a:gd name="connsiteX4" fmla="*/ 1873252 w 2359191"/>
+                  <a:gd name="connsiteY4" fmla="*/ 269431 h 5464715"/>
+                  <a:gd name="connsiteX5" fmla="*/ 2178052 w 2359191"/>
+                  <a:gd name="connsiteY5" fmla="*/ 1599467 h 5464715"/>
+                  <a:gd name="connsiteX6" fmla="*/ 1720852 w 2359191"/>
+                  <a:gd name="connsiteY6" fmla="*/ 2610849 h 5464715"/>
+                  <a:gd name="connsiteX7" fmla="*/ 1540743 w 2359191"/>
+                  <a:gd name="connsiteY7" fmla="*/ 3622231 h 5464715"/>
+                  <a:gd name="connsiteX8" fmla="*/ 2233470 w 2359191"/>
+                  <a:gd name="connsiteY8" fmla="*/ 4508922 h 5464715"/>
+                  <a:gd name="connsiteX9" fmla="*/ 2330451 w 2359191"/>
+                  <a:gd name="connsiteY9" fmla="*/ 5132377 h 5464715"/>
+                  <a:gd name="connsiteX10" fmla="*/ 1900961 w 2359191"/>
+                  <a:gd name="connsiteY10" fmla="*/ 5423322 h 5464715"/>
+                  <a:gd name="connsiteX11" fmla="*/ 626342 w 2359191"/>
+                  <a:gd name="connsiteY11" fmla="*/ 5381759 h 5464715"/>
+                  <a:gd name="connsiteX12" fmla="*/ 182997 w 2359191"/>
+                  <a:gd name="connsiteY12" fmla="*/ 4744449 h 5464715"/>
+                  <a:gd name="connsiteX0" fmla="*/ 180222 w 2356416"/>
+                  <a:gd name="connsiteY0" fmla="*/ 4782093 h 5502359"/>
+                  <a:gd name="connsiteX1" fmla="*/ 114 w 2356416"/>
+                  <a:gd name="connsiteY1" fmla="*/ 2828602 h 5502359"/>
+                  <a:gd name="connsiteX2" fmla="*/ 201419 w 2356416"/>
+                  <a:gd name="connsiteY2" fmla="*/ 982913 h 5502359"/>
+                  <a:gd name="connsiteX3" fmla="*/ 914513 w 2356416"/>
+                  <a:gd name="connsiteY3" fmla="*/ 43838 h 5502359"/>
+                  <a:gd name="connsiteX4" fmla="*/ 1870477 w 2356416"/>
+                  <a:gd name="connsiteY4" fmla="*/ 307075 h 5502359"/>
+                  <a:gd name="connsiteX5" fmla="*/ 2175277 w 2356416"/>
+                  <a:gd name="connsiteY5" fmla="*/ 1637111 h 5502359"/>
+                  <a:gd name="connsiteX6" fmla="*/ 1718077 w 2356416"/>
+                  <a:gd name="connsiteY6" fmla="*/ 2648493 h 5502359"/>
+                  <a:gd name="connsiteX7" fmla="*/ 1537968 w 2356416"/>
+                  <a:gd name="connsiteY7" fmla="*/ 3659875 h 5502359"/>
+                  <a:gd name="connsiteX8" fmla="*/ 2230695 w 2356416"/>
+                  <a:gd name="connsiteY8" fmla="*/ 4546566 h 5502359"/>
+                  <a:gd name="connsiteX9" fmla="*/ 2327676 w 2356416"/>
+                  <a:gd name="connsiteY9" fmla="*/ 5170021 h 5502359"/>
+                  <a:gd name="connsiteX10" fmla="*/ 1898186 w 2356416"/>
+                  <a:gd name="connsiteY10" fmla="*/ 5460966 h 5502359"/>
+                  <a:gd name="connsiteX11" fmla="*/ 623567 w 2356416"/>
+                  <a:gd name="connsiteY11" fmla="*/ 5419403 h 5502359"/>
+                  <a:gd name="connsiteX12" fmla="*/ 180222 w 2356416"/>
+                  <a:gd name="connsiteY12" fmla="*/ 4782093 h 5502359"/>
+                </a:gdLst>
+                <a:ahLst/>
+                <a:cxnLst>
+                  <a:cxn ang="0">
+                    <a:pos x="connsiteX0" y="connsiteY0"/>
+                  </a:cxn>
+                  <a:cxn ang="0">
+                    <a:pos x="connsiteX1" y="connsiteY1"/>
+                  </a:cxn>
+                  <a:cxn ang="0">
+                    <a:pos x="connsiteX2" y="connsiteY2"/>
+                  </a:cxn>
+                  <a:cxn ang="0">
+                    <a:pos x="connsiteX3" y="connsiteY3"/>
+                  </a:cxn>
+                  <a:cxn ang="0">
+                    <a:pos x="connsiteX4" y="connsiteY4"/>
+                  </a:cxn>
+                  <a:cxn ang="0">
+                    <a:pos x="connsiteX5" y="connsiteY5"/>
+                  </a:cxn>
+                  <a:cxn ang="0">
+                    <a:pos x="connsiteX6" y="connsiteY6"/>
+                  </a:cxn>
+                  <a:cxn ang="0">
+                    <a:pos x="connsiteX7" y="connsiteY7"/>
+                  </a:cxn>
+                  <a:cxn ang="0">
+                    <a:pos x="connsiteX8" y="connsiteY8"/>
+                  </a:cxn>
+                  <a:cxn ang="0">
+                    <a:pos x="connsiteX9" y="connsiteY9"/>
+                  </a:cxn>
+                  <a:cxn ang="0">
+                    <a:pos x="connsiteX10" y="connsiteY10"/>
+                  </a:cxn>
+                  <a:cxn ang="0">
+                    <a:pos x="connsiteX11" y="connsiteY11"/>
+                  </a:cxn>
+                  <a:cxn ang="0">
+                    <a:pos x="connsiteX12" y="connsiteY12"/>
+                  </a:cxn>
+                </a:cxnLst>
+                <a:rect l="l" t="t" r="r" b="b"/>
+                <a:pathLst>
+                  <a:path w="2356416" h="5502359">
+                    <a:moveTo>
+                      <a:pt x="180222" y="4782093"/>
+                    </a:moveTo>
+                    <a:cubicBezTo>
+                      <a:pt x="76313" y="4350293"/>
+                      <a:pt x="-3419" y="3461799"/>
+                      <a:pt x="114" y="2828602"/>
+                    </a:cubicBezTo>
+                    <a:cubicBezTo>
+                      <a:pt x="3647" y="2195405"/>
+                      <a:pt x="49019" y="1447040"/>
+                      <a:pt x="201419" y="982913"/>
+                    </a:cubicBezTo>
+                    <a:cubicBezTo>
+                      <a:pt x="353819" y="518786"/>
+                      <a:pt x="636337" y="156478"/>
+                      <a:pt x="914513" y="43838"/>
+                    </a:cubicBezTo>
+                    <a:cubicBezTo>
+                      <a:pt x="1192689" y="-68802"/>
+                      <a:pt x="1660350" y="41530"/>
+                      <a:pt x="1870477" y="307075"/>
+                    </a:cubicBezTo>
+                    <a:cubicBezTo>
+                      <a:pt x="2080604" y="572620"/>
+                      <a:pt x="2200677" y="1246875"/>
+                      <a:pt x="2175277" y="1637111"/>
+                    </a:cubicBezTo>
+                    <a:cubicBezTo>
+                      <a:pt x="2149877" y="2027347"/>
+                      <a:pt x="1824295" y="2311366"/>
+                      <a:pt x="1718077" y="2648493"/>
+                    </a:cubicBezTo>
+                    <a:cubicBezTo>
+                      <a:pt x="1611859" y="2985620"/>
+                      <a:pt x="1452532" y="3343530"/>
+                      <a:pt x="1537968" y="3659875"/>
+                    </a:cubicBezTo>
+                    <a:cubicBezTo>
+                      <a:pt x="1623404" y="3976221"/>
+                      <a:pt x="2099077" y="4294875"/>
+                      <a:pt x="2230695" y="4546566"/>
+                    </a:cubicBezTo>
+                    <a:cubicBezTo>
+                      <a:pt x="2362313" y="4798257"/>
+                      <a:pt x="2383094" y="5017621"/>
+                      <a:pt x="2327676" y="5170021"/>
+                    </a:cubicBezTo>
+                    <a:cubicBezTo>
+                      <a:pt x="2272258" y="5322421"/>
+                      <a:pt x="2258404" y="5403239"/>
+                      <a:pt x="1898186" y="5460966"/>
+                    </a:cubicBezTo>
+                    <a:cubicBezTo>
+                      <a:pt x="1537968" y="5518693"/>
+                      <a:pt x="907585" y="5525621"/>
+                      <a:pt x="623567" y="5419403"/>
+                    </a:cubicBezTo>
+                    <a:cubicBezTo>
+                      <a:pt x="339549" y="5313185"/>
+                      <a:pt x="284131" y="5213893"/>
+                      <a:pt x="180222" y="4782093"/>
+                    </a:cubicBezTo>
+                    <a:close/>
+                  </a:path>
+                </a:pathLst>
+              </a:custGeom>
+              <a:solidFill>
+                <a:schemeClr val="accent2"/>
+              </a:solidFill>
+              <a:ln>
+                <a:noFill/>
+              </a:ln>
+            </p:spPr>
+            <p:style>
+              <a:lnRef idx="2">
+                <a:schemeClr val="accent1">
+                  <a:shade val="50000"/>
+                </a:schemeClr>
+              </a:lnRef>
+              <a:fillRef idx="1">
+                <a:schemeClr val="accent1"/>
+              </a:fillRef>
+              <a:effectRef idx="0">
+                <a:schemeClr val="accent1"/>
+              </a:effectRef>
+              <a:fontRef idx="minor">
+                <a:schemeClr val="lt1"/>
+              </a:fontRef>
+            </p:style>
+            <p:txBody>
+              <a:bodyPr rtlCol="0" anchor="ctr"/>
+              <a:lstStyle/>
+              <a:p>
+                <a:pPr algn="ctr"/>
+                <a:endParaRPr lang="en-US"/>
+              </a:p>
+            </p:txBody>
+          </p:sp>
+          <p:sp>
+            <p:nvSpPr>
+              <p:cNvPr id="16" name="Oval 15">
+                <a:extLst>
+                  <a:ext uri="{FF2B5EF4-FFF2-40B4-BE49-F238E27FC236}">
+                    <a16:creationId xmlns:a16="http://schemas.microsoft.com/office/drawing/2014/main" id="{9F7C79F5-8E5C-7866-CACB-F5B34EAE4E89}"/>
+                  </a:ext>
+                </a:extLst>
+              </p:cNvPr>
+              <p:cNvSpPr/>
+              <p:nvPr/>
+            </p:nvSpPr>
+            <p:spPr>
+              <a:xfrm rot="10800000">
+                <a:off x="8747807" y="1008139"/>
+                <a:ext cx="609600" cy="893561"/>
+              </a:xfrm>
+              <a:prstGeom prst="ellipse">
+                <a:avLst/>
+              </a:prstGeom>
+              <a:solidFill>
+                <a:schemeClr val="accent2"/>
+              </a:solidFill>
+              <a:ln>
+                <a:noFill/>
+              </a:ln>
+              <a:effectLst/>
+            </p:spPr>
+            <p:style>
+              <a:lnRef idx="2">
+                <a:schemeClr val="accent1">
+                  <a:shade val="50000"/>
+                </a:schemeClr>
+              </a:lnRef>
+              <a:fillRef idx="1">
+                <a:schemeClr val="accent1"/>
+              </a:fillRef>
+              <a:effectRef idx="0">
+                <a:schemeClr val="accent1"/>
+              </a:effectRef>
+              <a:fontRef idx="minor">
+                <a:schemeClr val="lt1"/>
+              </a:fontRef>
+            </p:style>
+            <p:txBody>
+              <a:bodyPr rtlCol="0" anchor="ctr"/>
+              <a:lstStyle/>
+              <a:p>
+                <a:pPr algn="ctr"/>
+                <a:endParaRPr lang="en-US"/>
+              </a:p>
+            </p:txBody>
+          </p:sp>
+          <p:sp>
+            <p:nvSpPr>
+              <p:cNvPr id="17" name="Oval 16">
+                <a:extLst>
+                  <a:ext uri="{FF2B5EF4-FFF2-40B4-BE49-F238E27FC236}">
+                    <a16:creationId xmlns:a16="http://schemas.microsoft.com/office/drawing/2014/main" id="{8E6E4751-2292-A576-50A2-CB579735B100}"/>
+                  </a:ext>
+                </a:extLst>
+              </p:cNvPr>
+              <p:cNvSpPr/>
+              <p:nvPr/>
+            </p:nvSpPr>
+            <p:spPr>
+              <a:xfrm rot="10800000">
+                <a:off x="9519274" y="1213747"/>
+                <a:ext cx="274361" cy="548640"/>
+              </a:xfrm>
+              <a:prstGeom prst="ellipse">
+                <a:avLst/>
+              </a:prstGeom>
+              <a:solidFill>
+                <a:schemeClr val="accent2"/>
+              </a:solidFill>
+              <a:ln>
+                <a:noFill/>
+              </a:ln>
+              <a:effectLst/>
+            </p:spPr>
+            <p:style>
+              <a:lnRef idx="2">
+                <a:schemeClr val="accent1">
+                  <a:shade val="50000"/>
+                </a:schemeClr>
+              </a:lnRef>
+              <a:fillRef idx="1">
+                <a:schemeClr val="accent1"/>
+              </a:fillRef>
+              <a:effectRef idx="0">
+                <a:schemeClr val="accent1"/>
+              </a:effectRef>
+              <a:fontRef idx="minor">
+                <a:schemeClr val="lt1"/>
+              </a:fontRef>
+            </p:style>
+            <p:txBody>
+              <a:bodyPr rtlCol="0" anchor="ctr"/>
+              <a:lstStyle/>
+              <a:p>
+                <a:pPr algn="ctr"/>
+                <a:endParaRPr lang="en-US"/>
+              </a:p>
+            </p:txBody>
+          </p:sp>
+          <p:sp>
+            <p:nvSpPr>
+              <p:cNvPr id="18" name="Oval 17">
+                <a:extLst>
+                  <a:ext uri="{FF2B5EF4-FFF2-40B4-BE49-F238E27FC236}">
+                    <a16:creationId xmlns:a16="http://schemas.microsoft.com/office/drawing/2014/main" id="{4895AA54-1D08-534E-BC40-E33DB0604DFE}"/>
+                  </a:ext>
+                </a:extLst>
+              </p:cNvPr>
+              <p:cNvSpPr/>
+              <p:nvPr/>
+            </p:nvSpPr>
+            <p:spPr>
+              <a:xfrm rot="10800000">
+                <a:off x="9854512" y="1305187"/>
+                <a:ext cx="274361" cy="548640"/>
+              </a:xfrm>
+              <a:prstGeom prst="ellipse">
+                <a:avLst/>
+              </a:prstGeom>
+              <a:solidFill>
+                <a:schemeClr val="accent2"/>
+              </a:solidFill>
+              <a:ln>
+                <a:noFill/>
+              </a:ln>
+              <a:effectLst/>
+            </p:spPr>
+            <p:style>
+              <a:lnRef idx="2">
+                <a:schemeClr val="accent1">
+                  <a:shade val="50000"/>
+                </a:schemeClr>
+              </a:lnRef>
+              <a:fillRef idx="1">
+                <a:schemeClr val="accent1"/>
+              </a:fillRef>
+              <a:effectRef idx="0">
+                <a:schemeClr val="accent1"/>
+              </a:effectRef>
+              <a:fontRef idx="minor">
+                <a:schemeClr val="lt1"/>
+              </a:fontRef>
+            </p:style>
+            <p:txBody>
+              <a:bodyPr rtlCol="0" anchor="ctr"/>
+              <a:lstStyle/>
+              <a:p>
+                <a:pPr algn="ctr"/>
+                <a:endParaRPr lang="en-US"/>
+              </a:p>
+            </p:txBody>
+          </p:sp>
+          <p:sp>
+            <p:nvSpPr>
+              <p:cNvPr id="19" name="Oval 18">
+                <a:extLst>
+                  <a:ext uri="{FF2B5EF4-FFF2-40B4-BE49-F238E27FC236}">
+                    <a16:creationId xmlns:a16="http://schemas.microsoft.com/office/drawing/2014/main" id="{77B8A511-2BF3-12A8-0BC6-35969E5E87E0}"/>
+                  </a:ext>
+                </a:extLst>
+              </p:cNvPr>
+              <p:cNvSpPr/>
+              <p:nvPr/>
+            </p:nvSpPr>
+            <p:spPr>
+              <a:xfrm rot="10800000">
+                <a:off x="10205073" y="1416688"/>
+                <a:ext cx="274361" cy="457200"/>
+              </a:xfrm>
+              <a:prstGeom prst="ellipse">
+                <a:avLst/>
+              </a:prstGeom>
+              <a:solidFill>
+                <a:schemeClr val="accent2"/>
+              </a:solidFill>
+              <a:ln>
+                <a:noFill/>
+              </a:ln>
+              <a:effectLst/>
+            </p:spPr>
+            <p:style>
+              <a:lnRef idx="2">
+                <a:schemeClr val="accent1">
+                  <a:shade val="50000"/>
+                </a:schemeClr>
+              </a:lnRef>
+              <a:fillRef idx="1">
+                <a:schemeClr val="accent1"/>
+              </a:fillRef>
+              <a:effectRef idx="0">
+                <a:schemeClr val="accent1"/>
+              </a:effectRef>
+              <a:fontRef idx="minor">
+                <a:schemeClr val="lt1"/>
+              </a:fontRef>
+            </p:style>
+            <p:txBody>
+              <a:bodyPr rtlCol="0" anchor="ctr"/>
+              <a:lstStyle/>
+              <a:p>
+                <a:pPr algn="ctr"/>
+                <a:endParaRPr lang="en-US"/>
+              </a:p>
+            </p:txBody>
+          </p:sp>
+          <p:sp>
+            <p:nvSpPr>
+              <p:cNvPr id="20" name="Oval 19">
+                <a:extLst>
+                  <a:ext uri="{FF2B5EF4-FFF2-40B4-BE49-F238E27FC236}">
+                    <a16:creationId xmlns:a16="http://schemas.microsoft.com/office/drawing/2014/main" id="{B7EF5510-3280-7275-1DD2-B3E3B40049CB}"/>
+                  </a:ext>
+                </a:extLst>
+              </p:cNvPr>
+              <p:cNvSpPr/>
+              <p:nvPr/>
+            </p:nvSpPr>
+            <p:spPr>
+              <a:xfrm rot="10800000">
+                <a:off x="10540311" y="1670947"/>
+                <a:ext cx="274361" cy="365760"/>
+              </a:xfrm>
+              <a:prstGeom prst="ellipse">
+                <a:avLst/>
+              </a:prstGeom>
+              <a:solidFill>
+                <a:schemeClr val="accent2"/>
+              </a:solidFill>
+              <a:ln>
+                <a:noFill/>
+              </a:ln>
+              <a:effectLst/>
+            </p:spPr>
+            <p:style>
+              <a:lnRef idx="2">
+                <a:schemeClr val="accent1">
+                  <a:shade val="50000"/>
+                </a:schemeClr>
+              </a:lnRef>
+              <a:fillRef idx="1">
+                <a:schemeClr val="accent1"/>
+              </a:fillRef>
+              <a:effectRef idx="0">
+                <a:schemeClr val="accent1"/>
+              </a:effectRef>
+              <a:fontRef idx="minor">
+                <a:schemeClr val="lt1"/>
+              </a:fontRef>
+            </p:style>
+            <p:txBody>
+              <a:bodyPr rtlCol="0" anchor="ctr"/>
+              <a:lstStyle/>
+              <a:p>
+                <a:pPr algn="ctr"/>
+                <a:endParaRPr lang="en-US"/>
+              </a:p>
+            </p:txBody>
+          </p:sp>
+        </p:grpSp>
+        <p:grpSp>
+          <p:nvGrpSpPr>
+            <p:cNvPr id="21" name="Group 20">
+              <a:extLst>
+                <a:ext uri="{FF2B5EF4-FFF2-40B4-BE49-F238E27FC236}">
+                  <a16:creationId xmlns:a16="http://schemas.microsoft.com/office/drawing/2014/main" id="{CFC6F139-38A8-FFFA-D0C5-39E02899C91D}"/>
+                </a:ext>
+              </a:extLst>
+            </p:cNvPr>
+            <p:cNvGrpSpPr/>
+            <p:nvPr/>
+          </p:nvGrpSpPr>
+          <p:grpSpPr>
+            <a:xfrm rot="3582214">
+              <a:off x="8324712" y="3463205"/>
+              <a:ext cx="230400" cy="525600"/>
+              <a:chOff x="8024239" y="1985356"/>
+              <a:chExt cx="2141775" cy="4911414"/>
+            </a:xfrm>
+          </p:grpSpPr>
+          <p:sp>
+            <p:nvSpPr>
+              <p:cNvPr id="22" name="Freeform 5">
+                <a:extLst>
+                  <a:ext uri="{FF2B5EF4-FFF2-40B4-BE49-F238E27FC236}">
+                    <a16:creationId xmlns:a16="http://schemas.microsoft.com/office/drawing/2014/main" id="{779FB585-4780-B52E-E754-8A1090B5CE40}"/>
+                  </a:ext>
+                </a:extLst>
+              </p:cNvPr>
+              <p:cNvSpPr/>
+              <p:nvPr/>
+            </p:nvSpPr>
+            <p:spPr>
+              <a:xfrm rot="10626065" flipH="1">
+                <a:off x="8024239" y="2973626"/>
+                <a:ext cx="2141775" cy="3923144"/>
+              </a:xfrm>
+              <a:custGeom>
+                <a:avLst/>
+                <a:gdLst>
+                  <a:gd name="connsiteX0" fmla="*/ 452236 w 2914469"/>
+                  <a:gd name="connsiteY0" fmla="*/ 4744449 h 5470974"/>
+                  <a:gd name="connsiteX1" fmla="*/ 8891 w 2914469"/>
+                  <a:gd name="connsiteY1" fmla="*/ 2749394 h 5470974"/>
+                  <a:gd name="connsiteX2" fmla="*/ 175146 w 2914469"/>
+                  <a:gd name="connsiteY2" fmla="*/ 1211540 h 5470974"/>
+                  <a:gd name="connsiteX3" fmla="*/ 410673 w 2914469"/>
+                  <a:gd name="connsiteY3" fmla="*/ 394122 h 5470974"/>
+                  <a:gd name="connsiteX4" fmla="*/ 1186527 w 2914469"/>
+                  <a:gd name="connsiteY4" fmla="*/ 6194 h 5470974"/>
+                  <a:gd name="connsiteX5" fmla="*/ 2142491 w 2914469"/>
+                  <a:gd name="connsiteY5" fmla="*/ 269431 h 5470974"/>
+                  <a:gd name="connsiteX6" fmla="*/ 2447291 w 2914469"/>
+                  <a:gd name="connsiteY6" fmla="*/ 1599467 h 5470974"/>
+                  <a:gd name="connsiteX7" fmla="*/ 1990091 w 2914469"/>
+                  <a:gd name="connsiteY7" fmla="*/ 2610849 h 5470974"/>
+                  <a:gd name="connsiteX8" fmla="*/ 1809982 w 2914469"/>
+                  <a:gd name="connsiteY8" fmla="*/ 3622231 h 5470974"/>
+                  <a:gd name="connsiteX9" fmla="*/ 2655109 w 2914469"/>
+                  <a:gd name="connsiteY9" fmla="*/ 4522776 h 5470974"/>
+                  <a:gd name="connsiteX10" fmla="*/ 2890636 w 2914469"/>
+                  <a:gd name="connsiteY10" fmla="*/ 5049249 h 5470974"/>
+                  <a:gd name="connsiteX11" fmla="*/ 2170200 w 2914469"/>
+                  <a:gd name="connsiteY11" fmla="*/ 5423322 h 5470974"/>
+                  <a:gd name="connsiteX12" fmla="*/ 729327 w 2914469"/>
+                  <a:gd name="connsiteY12" fmla="*/ 5395613 h 5470974"/>
+                  <a:gd name="connsiteX13" fmla="*/ 452236 w 2914469"/>
+                  <a:gd name="connsiteY13" fmla="*/ 4744449 h 5470974"/>
+                  <a:gd name="connsiteX0" fmla="*/ 452236 w 2733397"/>
+                  <a:gd name="connsiteY0" fmla="*/ 4744449 h 5470974"/>
+                  <a:gd name="connsiteX1" fmla="*/ 8891 w 2733397"/>
+                  <a:gd name="connsiteY1" fmla="*/ 2749394 h 5470974"/>
+                  <a:gd name="connsiteX2" fmla="*/ 175146 w 2733397"/>
+                  <a:gd name="connsiteY2" fmla="*/ 1211540 h 5470974"/>
+                  <a:gd name="connsiteX3" fmla="*/ 410673 w 2733397"/>
+                  <a:gd name="connsiteY3" fmla="*/ 394122 h 5470974"/>
+                  <a:gd name="connsiteX4" fmla="*/ 1186527 w 2733397"/>
+                  <a:gd name="connsiteY4" fmla="*/ 6194 h 5470974"/>
+                  <a:gd name="connsiteX5" fmla="*/ 2142491 w 2733397"/>
+                  <a:gd name="connsiteY5" fmla="*/ 269431 h 5470974"/>
+                  <a:gd name="connsiteX6" fmla="*/ 2447291 w 2733397"/>
+                  <a:gd name="connsiteY6" fmla="*/ 1599467 h 5470974"/>
+                  <a:gd name="connsiteX7" fmla="*/ 1990091 w 2733397"/>
+                  <a:gd name="connsiteY7" fmla="*/ 2610849 h 5470974"/>
+                  <a:gd name="connsiteX8" fmla="*/ 1809982 w 2733397"/>
+                  <a:gd name="connsiteY8" fmla="*/ 3622231 h 5470974"/>
+                  <a:gd name="connsiteX9" fmla="*/ 2655109 w 2733397"/>
+                  <a:gd name="connsiteY9" fmla="*/ 4522776 h 5470974"/>
+                  <a:gd name="connsiteX10" fmla="*/ 2641254 w 2733397"/>
+                  <a:gd name="connsiteY10" fmla="*/ 5146231 h 5470974"/>
+                  <a:gd name="connsiteX11" fmla="*/ 2170200 w 2733397"/>
+                  <a:gd name="connsiteY11" fmla="*/ 5423322 h 5470974"/>
+                  <a:gd name="connsiteX12" fmla="*/ 729327 w 2733397"/>
+                  <a:gd name="connsiteY12" fmla="*/ 5395613 h 5470974"/>
+                  <a:gd name="connsiteX13" fmla="*/ 452236 w 2733397"/>
+                  <a:gd name="connsiteY13" fmla="*/ 4744449 h 5470974"/>
+                  <a:gd name="connsiteX0" fmla="*/ 452236 w 2662490"/>
+                  <a:gd name="connsiteY0" fmla="*/ 4744449 h 5470974"/>
+                  <a:gd name="connsiteX1" fmla="*/ 8891 w 2662490"/>
+                  <a:gd name="connsiteY1" fmla="*/ 2749394 h 5470974"/>
+                  <a:gd name="connsiteX2" fmla="*/ 175146 w 2662490"/>
+                  <a:gd name="connsiteY2" fmla="*/ 1211540 h 5470974"/>
+                  <a:gd name="connsiteX3" fmla="*/ 410673 w 2662490"/>
+                  <a:gd name="connsiteY3" fmla="*/ 394122 h 5470974"/>
+                  <a:gd name="connsiteX4" fmla="*/ 1186527 w 2662490"/>
+                  <a:gd name="connsiteY4" fmla="*/ 6194 h 5470974"/>
+                  <a:gd name="connsiteX5" fmla="*/ 2142491 w 2662490"/>
+                  <a:gd name="connsiteY5" fmla="*/ 269431 h 5470974"/>
+                  <a:gd name="connsiteX6" fmla="*/ 2447291 w 2662490"/>
+                  <a:gd name="connsiteY6" fmla="*/ 1599467 h 5470974"/>
+                  <a:gd name="connsiteX7" fmla="*/ 1990091 w 2662490"/>
+                  <a:gd name="connsiteY7" fmla="*/ 2610849 h 5470974"/>
+                  <a:gd name="connsiteX8" fmla="*/ 1809982 w 2662490"/>
+                  <a:gd name="connsiteY8" fmla="*/ 3622231 h 5470974"/>
+                  <a:gd name="connsiteX9" fmla="*/ 2502709 w 2662490"/>
+                  <a:gd name="connsiteY9" fmla="*/ 4508922 h 5470974"/>
+                  <a:gd name="connsiteX10" fmla="*/ 2641254 w 2662490"/>
+                  <a:gd name="connsiteY10" fmla="*/ 5146231 h 5470974"/>
+                  <a:gd name="connsiteX11" fmla="*/ 2170200 w 2662490"/>
+                  <a:gd name="connsiteY11" fmla="*/ 5423322 h 5470974"/>
+                  <a:gd name="connsiteX12" fmla="*/ 729327 w 2662490"/>
+                  <a:gd name="connsiteY12" fmla="*/ 5395613 h 5470974"/>
+                  <a:gd name="connsiteX13" fmla="*/ 452236 w 2662490"/>
+                  <a:gd name="connsiteY13" fmla="*/ 4744449 h 5470974"/>
+                  <a:gd name="connsiteX0" fmla="*/ 452236 w 2628430"/>
+                  <a:gd name="connsiteY0" fmla="*/ 4744449 h 5470974"/>
+                  <a:gd name="connsiteX1" fmla="*/ 8891 w 2628430"/>
+                  <a:gd name="connsiteY1" fmla="*/ 2749394 h 5470974"/>
+                  <a:gd name="connsiteX2" fmla="*/ 175146 w 2628430"/>
+                  <a:gd name="connsiteY2" fmla="*/ 1211540 h 5470974"/>
+                  <a:gd name="connsiteX3" fmla="*/ 410673 w 2628430"/>
+                  <a:gd name="connsiteY3" fmla="*/ 394122 h 5470974"/>
+                  <a:gd name="connsiteX4" fmla="*/ 1186527 w 2628430"/>
+                  <a:gd name="connsiteY4" fmla="*/ 6194 h 5470974"/>
+                  <a:gd name="connsiteX5" fmla="*/ 2142491 w 2628430"/>
+                  <a:gd name="connsiteY5" fmla="*/ 269431 h 5470974"/>
+                  <a:gd name="connsiteX6" fmla="*/ 2447291 w 2628430"/>
+                  <a:gd name="connsiteY6" fmla="*/ 1599467 h 5470974"/>
+                  <a:gd name="connsiteX7" fmla="*/ 1990091 w 2628430"/>
+                  <a:gd name="connsiteY7" fmla="*/ 2610849 h 5470974"/>
+                  <a:gd name="connsiteX8" fmla="*/ 1809982 w 2628430"/>
+                  <a:gd name="connsiteY8" fmla="*/ 3622231 h 5470974"/>
+                  <a:gd name="connsiteX9" fmla="*/ 2502709 w 2628430"/>
+                  <a:gd name="connsiteY9" fmla="*/ 4508922 h 5470974"/>
+                  <a:gd name="connsiteX10" fmla="*/ 2599690 w 2628430"/>
+                  <a:gd name="connsiteY10" fmla="*/ 5132377 h 5470974"/>
+                  <a:gd name="connsiteX11" fmla="*/ 2170200 w 2628430"/>
+                  <a:gd name="connsiteY11" fmla="*/ 5423322 h 5470974"/>
+                  <a:gd name="connsiteX12" fmla="*/ 729327 w 2628430"/>
+                  <a:gd name="connsiteY12" fmla="*/ 5395613 h 5470974"/>
+                  <a:gd name="connsiteX13" fmla="*/ 452236 w 2628430"/>
+                  <a:gd name="connsiteY13" fmla="*/ 4744449 h 5470974"/>
+                  <a:gd name="connsiteX0" fmla="*/ 452236 w 2628430"/>
+                  <a:gd name="connsiteY0" fmla="*/ 4744449 h 5464715"/>
+                  <a:gd name="connsiteX1" fmla="*/ 8891 w 2628430"/>
+                  <a:gd name="connsiteY1" fmla="*/ 2749394 h 5464715"/>
+                  <a:gd name="connsiteX2" fmla="*/ 175146 w 2628430"/>
+                  <a:gd name="connsiteY2" fmla="*/ 1211540 h 5464715"/>
+                  <a:gd name="connsiteX3" fmla="*/ 410673 w 2628430"/>
+                  <a:gd name="connsiteY3" fmla="*/ 394122 h 5464715"/>
+                  <a:gd name="connsiteX4" fmla="*/ 1186527 w 2628430"/>
+                  <a:gd name="connsiteY4" fmla="*/ 6194 h 5464715"/>
+                  <a:gd name="connsiteX5" fmla="*/ 2142491 w 2628430"/>
+                  <a:gd name="connsiteY5" fmla="*/ 269431 h 5464715"/>
+                  <a:gd name="connsiteX6" fmla="*/ 2447291 w 2628430"/>
+                  <a:gd name="connsiteY6" fmla="*/ 1599467 h 5464715"/>
+                  <a:gd name="connsiteX7" fmla="*/ 1990091 w 2628430"/>
+                  <a:gd name="connsiteY7" fmla="*/ 2610849 h 5464715"/>
+                  <a:gd name="connsiteX8" fmla="*/ 1809982 w 2628430"/>
+                  <a:gd name="connsiteY8" fmla="*/ 3622231 h 5464715"/>
+                  <a:gd name="connsiteX9" fmla="*/ 2502709 w 2628430"/>
+                  <a:gd name="connsiteY9" fmla="*/ 4508922 h 5464715"/>
+                  <a:gd name="connsiteX10" fmla="*/ 2599690 w 2628430"/>
+                  <a:gd name="connsiteY10" fmla="*/ 5132377 h 5464715"/>
+                  <a:gd name="connsiteX11" fmla="*/ 2170200 w 2628430"/>
+                  <a:gd name="connsiteY11" fmla="*/ 5423322 h 5464715"/>
+                  <a:gd name="connsiteX12" fmla="*/ 895581 w 2628430"/>
+                  <a:gd name="connsiteY12" fmla="*/ 5381759 h 5464715"/>
+                  <a:gd name="connsiteX13" fmla="*/ 452236 w 2628430"/>
+                  <a:gd name="connsiteY13" fmla="*/ 4744449 h 5464715"/>
+                  <a:gd name="connsiteX0" fmla="*/ 281453 w 2457647"/>
+                  <a:gd name="connsiteY0" fmla="*/ 4744449 h 5464715"/>
+                  <a:gd name="connsiteX1" fmla="*/ 101345 w 2457647"/>
+                  <a:gd name="connsiteY1" fmla="*/ 2790958 h 5464715"/>
+                  <a:gd name="connsiteX2" fmla="*/ 4363 w 2457647"/>
+                  <a:gd name="connsiteY2" fmla="*/ 1211540 h 5464715"/>
+                  <a:gd name="connsiteX3" fmla="*/ 239890 w 2457647"/>
+                  <a:gd name="connsiteY3" fmla="*/ 394122 h 5464715"/>
+                  <a:gd name="connsiteX4" fmla="*/ 1015744 w 2457647"/>
+                  <a:gd name="connsiteY4" fmla="*/ 6194 h 5464715"/>
+                  <a:gd name="connsiteX5" fmla="*/ 1971708 w 2457647"/>
+                  <a:gd name="connsiteY5" fmla="*/ 269431 h 5464715"/>
+                  <a:gd name="connsiteX6" fmla="*/ 2276508 w 2457647"/>
+                  <a:gd name="connsiteY6" fmla="*/ 1599467 h 5464715"/>
+                  <a:gd name="connsiteX7" fmla="*/ 1819308 w 2457647"/>
+                  <a:gd name="connsiteY7" fmla="*/ 2610849 h 5464715"/>
+                  <a:gd name="connsiteX8" fmla="*/ 1639199 w 2457647"/>
+                  <a:gd name="connsiteY8" fmla="*/ 3622231 h 5464715"/>
+                  <a:gd name="connsiteX9" fmla="*/ 2331926 w 2457647"/>
+                  <a:gd name="connsiteY9" fmla="*/ 4508922 h 5464715"/>
+                  <a:gd name="connsiteX10" fmla="*/ 2428907 w 2457647"/>
+                  <a:gd name="connsiteY10" fmla="*/ 5132377 h 5464715"/>
+                  <a:gd name="connsiteX11" fmla="*/ 1999417 w 2457647"/>
+                  <a:gd name="connsiteY11" fmla="*/ 5423322 h 5464715"/>
+                  <a:gd name="connsiteX12" fmla="*/ 724798 w 2457647"/>
+                  <a:gd name="connsiteY12" fmla="*/ 5381759 h 5464715"/>
+                  <a:gd name="connsiteX13" fmla="*/ 281453 w 2457647"/>
+                  <a:gd name="connsiteY13" fmla="*/ 4744449 h 5464715"/>
+                  <a:gd name="connsiteX0" fmla="*/ 182997 w 2359191"/>
+                  <a:gd name="connsiteY0" fmla="*/ 4744449 h 5464715"/>
+                  <a:gd name="connsiteX1" fmla="*/ 2889 w 2359191"/>
+                  <a:gd name="connsiteY1" fmla="*/ 2790958 h 5464715"/>
+                  <a:gd name="connsiteX2" fmla="*/ 141434 w 2359191"/>
+                  <a:gd name="connsiteY2" fmla="*/ 394122 h 5464715"/>
+                  <a:gd name="connsiteX3" fmla="*/ 917288 w 2359191"/>
+                  <a:gd name="connsiteY3" fmla="*/ 6194 h 5464715"/>
+                  <a:gd name="connsiteX4" fmla="*/ 1873252 w 2359191"/>
+                  <a:gd name="connsiteY4" fmla="*/ 269431 h 5464715"/>
+                  <a:gd name="connsiteX5" fmla="*/ 2178052 w 2359191"/>
+                  <a:gd name="connsiteY5" fmla="*/ 1599467 h 5464715"/>
+                  <a:gd name="connsiteX6" fmla="*/ 1720852 w 2359191"/>
+                  <a:gd name="connsiteY6" fmla="*/ 2610849 h 5464715"/>
+                  <a:gd name="connsiteX7" fmla="*/ 1540743 w 2359191"/>
+                  <a:gd name="connsiteY7" fmla="*/ 3622231 h 5464715"/>
+                  <a:gd name="connsiteX8" fmla="*/ 2233470 w 2359191"/>
+                  <a:gd name="connsiteY8" fmla="*/ 4508922 h 5464715"/>
+                  <a:gd name="connsiteX9" fmla="*/ 2330451 w 2359191"/>
+                  <a:gd name="connsiteY9" fmla="*/ 5132377 h 5464715"/>
+                  <a:gd name="connsiteX10" fmla="*/ 1900961 w 2359191"/>
+                  <a:gd name="connsiteY10" fmla="*/ 5423322 h 5464715"/>
+                  <a:gd name="connsiteX11" fmla="*/ 626342 w 2359191"/>
+                  <a:gd name="connsiteY11" fmla="*/ 5381759 h 5464715"/>
+                  <a:gd name="connsiteX12" fmla="*/ 182997 w 2359191"/>
+                  <a:gd name="connsiteY12" fmla="*/ 4744449 h 5464715"/>
+                  <a:gd name="connsiteX0" fmla="*/ 180110 w 2356304"/>
+                  <a:gd name="connsiteY0" fmla="*/ 4785805 h 5506071"/>
+                  <a:gd name="connsiteX1" fmla="*/ 2 w 2356304"/>
+                  <a:gd name="connsiteY1" fmla="*/ 2832314 h 5506071"/>
+                  <a:gd name="connsiteX2" fmla="*/ 182207 w 2356304"/>
+                  <a:gd name="connsiteY2" fmla="*/ 1038518 h 5506071"/>
+                  <a:gd name="connsiteX3" fmla="*/ 914401 w 2356304"/>
+                  <a:gd name="connsiteY3" fmla="*/ 47550 h 5506071"/>
+                  <a:gd name="connsiteX4" fmla="*/ 1870365 w 2356304"/>
+                  <a:gd name="connsiteY4" fmla="*/ 310787 h 5506071"/>
+                  <a:gd name="connsiteX5" fmla="*/ 2175165 w 2356304"/>
+                  <a:gd name="connsiteY5" fmla="*/ 1640823 h 5506071"/>
+                  <a:gd name="connsiteX6" fmla="*/ 1717965 w 2356304"/>
+                  <a:gd name="connsiteY6" fmla="*/ 2652205 h 5506071"/>
+                  <a:gd name="connsiteX7" fmla="*/ 1537856 w 2356304"/>
+                  <a:gd name="connsiteY7" fmla="*/ 3663587 h 5506071"/>
+                  <a:gd name="connsiteX8" fmla="*/ 2230583 w 2356304"/>
+                  <a:gd name="connsiteY8" fmla="*/ 4550278 h 5506071"/>
+                  <a:gd name="connsiteX9" fmla="*/ 2327564 w 2356304"/>
+                  <a:gd name="connsiteY9" fmla="*/ 5173733 h 5506071"/>
+                  <a:gd name="connsiteX10" fmla="*/ 1898074 w 2356304"/>
+                  <a:gd name="connsiteY10" fmla="*/ 5464678 h 5506071"/>
+                  <a:gd name="connsiteX11" fmla="*/ 623455 w 2356304"/>
+                  <a:gd name="connsiteY11" fmla="*/ 5423115 h 5506071"/>
+                  <a:gd name="connsiteX12" fmla="*/ 180110 w 2356304"/>
+                  <a:gd name="connsiteY12" fmla="*/ 4785805 h 5506071"/>
+                  <a:gd name="connsiteX0" fmla="*/ 181079 w 2357273"/>
+                  <a:gd name="connsiteY0" fmla="*/ 4796399 h 5516665"/>
+                  <a:gd name="connsiteX1" fmla="*/ 971 w 2357273"/>
+                  <a:gd name="connsiteY1" fmla="*/ 2842908 h 5516665"/>
+                  <a:gd name="connsiteX2" fmla="*/ 248289 w 2357273"/>
+                  <a:gd name="connsiteY2" fmla="*/ 1196366 h 5516665"/>
+                  <a:gd name="connsiteX3" fmla="*/ 915370 w 2357273"/>
+                  <a:gd name="connsiteY3" fmla="*/ 58144 h 5516665"/>
+                  <a:gd name="connsiteX4" fmla="*/ 1871334 w 2357273"/>
+                  <a:gd name="connsiteY4" fmla="*/ 321381 h 5516665"/>
+                  <a:gd name="connsiteX5" fmla="*/ 2176134 w 2357273"/>
+                  <a:gd name="connsiteY5" fmla="*/ 1651417 h 5516665"/>
+                  <a:gd name="connsiteX6" fmla="*/ 1718934 w 2357273"/>
+                  <a:gd name="connsiteY6" fmla="*/ 2662799 h 5516665"/>
+                  <a:gd name="connsiteX7" fmla="*/ 1538825 w 2357273"/>
+                  <a:gd name="connsiteY7" fmla="*/ 3674181 h 5516665"/>
+                  <a:gd name="connsiteX8" fmla="*/ 2231552 w 2357273"/>
+                  <a:gd name="connsiteY8" fmla="*/ 4560872 h 5516665"/>
+                  <a:gd name="connsiteX9" fmla="*/ 2328533 w 2357273"/>
+                  <a:gd name="connsiteY9" fmla="*/ 5184327 h 5516665"/>
+                  <a:gd name="connsiteX10" fmla="*/ 1899043 w 2357273"/>
+                  <a:gd name="connsiteY10" fmla="*/ 5475272 h 5516665"/>
+                  <a:gd name="connsiteX11" fmla="*/ 624424 w 2357273"/>
+                  <a:gd name="connsiteY11" fmla="*/ 5433709 h 5516665"/>
+                  <a:gd name="connsiteX12" fmla="*/ 181079 w 2357273"/>
+                  <a:gd name="connsiteY12" fmla="*/ 4796399 h 5516665"/>
+                </a:gdLst>
+                <a:ahLst/>
+                <a:cxnLst>
+                  <a:cxn ang="0">
+                    <a:pos x="connsiteX0" y="connsiteY0"/>
+                  </a:cxn>
+                  <a:cxn ang="0">
+                    <a:pos x="connsiteX1" y="connsiteY1"/>
+                  </a:cxn>
+                  <a:cxn ang="0">
+                    <a:pos x="connsiteX2" y="connsiteY2"/>
+                  </a:cxn>
+                  <a:cxn ang="0">
+                    <a:pos x="connsiteX3" y="connsiteY3"/>
+                  </a:cxn>
+                  <a:cxn ang="0">
+                    <a:pos x="connsiteX4" y="connsiteY4"/>
+                  </a:cxn>
+                  <a:cxn ang="0">
+                    <a:pos x="connsiteX5" y="connsiteY5"/>
+                  </a:cxn>
+                  <a:cxn ang="0">
+                    <a:pos x="connsiteX6" y="connsiteY6"/>
+                  </a:cxn>
+                  <a:cxn ang="0">
+                    <a:pos x="connsiteX7" y="connsiteY7"/>
+                  </a:cxn>
+                  <a:cxn ang="0">
+                    <a:pos x="connsiteX8" y="connsiteY8"/>
+                  </a:cxn>
+                  <a:cxn ang="0">
+                    <a:pos x="connsiteX9" y="connsiteY9"/>
+                  </a:cxn>
+                  <a:cxn ang="0">
+                    <a:pos x="connsiteX10" y="connsiteY10"/>
+                  </a:cxn>
+                  <a:cxn ang="0">
+                    <a:pos x="connsiteX11" y="connsiteY11"/>
+                  </a:cxn>
+                  <a:cxn ang="0">
+                    <a:pos x="connsiteX12" y="connsiteY12"/>
+                  </a:cxn>
+                </a:cxnLst>
+                <a:rect l="l" t="t" r="r" b="b"/>
+                <a:pathLst>
+                  <a:path w="2357273" h="5516665">
+                    <a:moveTo>
+                      <a:pt x="181079" y="4796399"/>
+                    </a:moveTo>
+                    <a:cubicBezTo>
+                      <a:pt x="77170" y="4364599"/>
+                      <a:pt x="-10231" y="3442913"/>
+                      <a:pt x="971" y="2842908"/>
+                    </a:cubicBezTo>
+                    <a:cubicBezTo>
+                      <a:pt x="12173" y="2242903"/>
+                      <a:pt x="95889" y="1660493"/>
+                      <a:pt x="248289" y="1196366"/>
+                    </a:cubicBezTo>
+                    <a:cubicBezTo>
+                      <a:pt x="400689" y="732239"/>
+                      <a:pt x="644863" y="203975"/>
+                      <a:pt x="915370" y="58144"/>
+                    </a:cubicBezTo>
+                    <a:cubicBezTo>
+                      <a:pt x="1185878" y="-87687"/>
+                      <a:pt x="1661207" y="55836"/>
+                      <a:pt x="1871334" y="321381"/>
+                    </a:cubicBezTo>
+                    <a:cubicBezTo>
+                      <a:pt x="2081461" y="586926"/>
+                      <a:pt x="2201534" y="1261181"/>
+                      <a:pt x="2176134" y="1651417"/>
+                    </a:cubicBezTo>
+                    <a:cubicBezTo>
+                      <a:pt x="2150734" y="2041653"/>
+                      <a:pt x="1825152" y="2325672"/>
+                      <a:pt x="1718934" y="2662799"/>
+                    </a:cubicBezTo>
+                    <a:cubicBezTo>
+                      <a:pt x="1612716" y="2999926"/>
+                      <a:pt x="1453389" y="3357836"/>
+                      <a:pt x="1538825" y="3674181"/>
+                    </a:cubicBezTo>
+                    <a:cubicBezTo>
+                      <a:pt x="1624261" y="3990527"/>
+                      <a:pt x="2099934" y="4309181"/>
+                      <a:pt x="2231552" y="4560872"/>
+                    </a:cubicBezTo>
+                    <a:cubicBezTo>
+                      <a:pt x="2363170" y="4812563"/>
+                      <a:pt x="2383951" y="5031927"/>
+                      <a:pt x="2328533" y="5184327"/>
+                    </a:cubicBezTo>
+                    <a:cubicBezTo>
+                      <a:pt x="2273115" y="5336727"/>
+                      <a:pt x="2259261" y="5417545"/>
+                      <a:pt x="1899043" y="5475272"/>
+                    </a:cubicBezTo>
+                    <a:cubicBezTo>
+                      <a:pt x="1538825" y="5532999"/>
+                      <a:pt x="908442" y="5539927"/>
+                      <a:pt x="624424" y="5433709"/>
+                    </a:cubicBezTo>
+                    <a:cubicBezTo>
+                      <a:pt x="340406" y="5327491"/>
+                      <a:pt x="284988" y="5228199"/>
+                      <a:pt x="181079" y="4796399"/>
+                    </a:cubicBezTo>
+                    <a:close/>
+                  </a:path>
+                </a:pathLst>
+              </a:custGeom>
+              <a:solidFill>
+                <a:schemeClr val="accent2"/>
+              </a:solidFill>
+              <a:ln>
+                <a:noFill/>
+              </a:ln>
+            </p:spPr>
+            <p:style>
+              <a:lnRef idx="2">
+                <a:schemeClr val="accent1">
+                  <a:shade val="50000"/>
+                </a:schemeClr>
+              </a:lnRef>
+              <a:fillRef idx="1">
+                <a:schemeClr val="accent1"/>
+              </a:fillRef>
+              <a:effectRef idx="0">
+                <a:schemeClr val="accent1"/>
+              </a:effectRef>
+              <a:fontRef idx="minor">
+                <a:schemeClr val="lt1"/>
+              </a:fontRef>
+            </p:style>
+            <p:txBody>
+              <a:bodyPr rtlCol="0" anchor="ctr"/>
+              <a:lstStyle/>
+              <a:p>
+                <a:pPr algn="ctr"/>
+                <a:endParaRPr lang="en-US"/>
+              </a:p>
+            </p:txBody>
+          </p:sp>
+          <p:sp>
+            <p:nvSpPr>
+              <p:cNvPr id="23" name="Oval 22">
+                <a:extLst>
+                  <a:ext uri="{FF2B5EF4-FFF2-40B4-BE49-F238E27FC236}">
+                    <a16:creationId xmlns:a16="http://schemas.microsoft.com/office/drawing/2014/main" id="{A1F73AAA-CE4D-F792-45AA-57A77746ED03}"/>
+                  </a:ext>
+                </a:extLst>
+              </p:cNvPr>
+              <p:cNvSpPr/>
+              <p:nvPr/>
+            </p:nvSpPr>
+            <p:spPr>
+              <a:xfrm rot="10800000">
+                <a:off x="9506781" y="1985356"/>
+                <a:ext cx="609600" cy="893561"/>
+              </a:xfrm>
+              <a:prstGeom prst="ellipse">
+                <a:avLst/>
+              </a:prstGeom>
+              <a:solidFill>
+                <a:schemeClr val="accent2"/>
+              </a:solidFill>
+              <a:ln>
+                <a:noFill/>
+              </a:ln>
+              <a:effectLst/>
+            </p:spPr>
+            <p:style>
+              <a:lnRef idx="2">
+                <a:schemeClr val="accent1">
+                  <a:shade val="50000"/>
+                </a:schemeClr>
+              </a:lnRef>
+              <a:fillRef idx="1">
+                <a:schemeClr val="accent1"/>
+              </a:fillRef>
+              <a:effectRef idx="0">
+                <a:schemeClr val="accent1"/>
+              </a:effectRef>
+              <a:fontRef idx="minor">
+                <a:schemeClr val="lt1"/>
+              </a:fontRef>
+            </p:style>
+            <p:txBody>
+              <a:bodyPr rtlCol="0" anchor="ctr"/>
+              <a:lstStyle/>
+              <a:p>
+                <a:pPr algn="ctr"/>
+                <a:endParaRPr lang="en-US"/>
+              </a:p>
+            </p:txBody>
+          </p:sp>
+          <p:sp>
+            <p:nvSpPr>
+              <p:cNvPr id="24" name="Oval 23">
+                <a:extLst>
+                  <a:ext uri="{FF2B5EF4-FFF2-40B4-BE49-F238E27FC236}">
+                    <a16:creationId xmlns:a16="http://schemas.microsoft.com/office/drawing/2014/main" id="{FB93F53E-E9AE-4411-1D56-EAC172190977}"/>
+                  </a:ext>
+                </a:extLst>
+              </p:cNvPr>
+              <p:cNvSpPr/>
+              <p:nvPr/>
+            </p:nvSpPr>
+            <p:spPr>
+              <a:xfrm rot="10800000">
+                <a:off x="9107731" y="2190964"/>
+                <a:ext cx="274361" cy="548640"/>
+              </a:xfrm>
+              <a:prstGeom prst="ellipse">
+                <a:avLst/>
+              </a:prstGeom>
+              <a:solidFill>
+                <a:schemeClr val="accent2"/>
+              </a:solidFill>
+              <a:ln>
+                <a:noFill/>
+              </a:ln>
+              <a:effectLst/>
+            </p:spPr>
+            <p:style>
+              <a:lnRef idx="2">
+                <a:schemeClr val="accent1">
+                  <a:shade val="50000"/>
+                </a:schemeClr>
+              </a:lnRef>
+              <a:fillRef idx="1">
+                <a:schemeClr val="accent1"/>
+              </a:fillRef>
+              <a:effectRef idx="0">
+                <a:schemeClr val="accent1"/>
+              </a:effectRef>
+              <a:fontRef idx="minor">
+                <a:schemeClr val="lt1"/>
+              </a:fontRef>
+            </p:style>
+            <p:txBody>
+              <a:bodyPr rtlCol="0" anchor="ctr"/>
+              <a:lstStyle/>
+              <a:p>
+                <a:pPr algn="ctr"/>
+                <a:endParaRPr lang="en-US"/>
+              </a:p>
+            </p:txBody>
+          </p:sp>
+          <p:sp>
+            <p:nvSpPr>
+              <p:cNvPr id="25" name="Oval 24">
+                <a:extLst>
+                  <a:ext uri="{FF2B5EF4-FFF2-40B4-BE49-F238E27FC236}">
+                    <a16:creationId xmlns:a16="http://schemas.microsoft.com/office/drawing/2014/main" id="{8EEB79BC-AEDB-19A2-ECE1-332FDDD64A2A}"/>
+                  </a:ext>
+                </a:extLst>
+              </p:cNvPr>
+              <p:cNvSpPr/>
+              <p:nvPr/>
+            </p:nvSpPr>
+            <p:spPr>
+              <a:xfrm rot="10800000">
+                <a:off x="8741529" y="2282404"/>
+                <a:ext cx="274361" cy="548640"/>
+              </a:xfrm>
+              <a:prstGeom prst="ellipse">
+                <a:avLst/>
+              </a:prstGeom>
+              <a:solidFill>
+                <a:schemeClr val="accent2"/>
+              </a:solidFill>
+              <a:ln>
+                <a:noFill/>
+              </a:ln>
+              <a:effectLst/>
+            </p:spPr>
+            <p:style>
+              <a:lnRef idx="2">
+                <a:schemeClr val="accent1">
+                  <a:shade val="50000"/>
+                </a:schemeClr>
+              </a:lnRef>
+              <a:fillRef idx="1">
+                <a:schemeClr val="accent1"/>
+              </a:fillRef>
+              <a:effectRef idx="0">
+                <a:schemeClr val="accent1"/>
+              </a:effectRef>
+              <a:fontRef idx="minor">
+                <a:schemeClr val="lt1"/>
+              </a:fontRef>
+            </p:style>
+            <p:txBody>
+              <a:bodyPr rtlCol="0" anchor="ctr"/>
+              <a:lstStyle/>
+              <a:p>
+                <a:pPr algn="ctr"/>
+                <a:endParaRPr lang="en-US"/>
+              </a:p>
+            </p:txBody>
+          </p:sp>
+          <p:sp>
+            <p:nvSpPr>
+              <p:cNvPr id="26" name="Oval 25">
+                <a:extLst>
+                  <a:ext uri="{FF2B5EF4-FFF2-40B4-BE49-F238E27FC236}">
+                    <a16:creationId xmlns:a16="http://schemas.microsoft.com/office/drawing/2014/main" id="{0C223475-D1EC-62D9-7254-277B532CCCDE}"/>
+                  </a:ext>
+                </a:extLst>
+              </p:cNvPr>
+              <p:cNvSpPr/>
+              <p:nvPr/>
+            </p:nvSpPr>
+            <p:spPr>
+              <a:xfrm rot="10800000">
+                <a:off x="8392434" y="2393906"/>
+                <a:ext cx="274361" cy="457200"/>
+              </a:xfrm>
+              <a:prstGeom prst="ellipse">
+                <a:avLst/>
+              </a:prstGeom>
+              <a:solidFill>
+                <a:schemeClr val="accent2"/>
+              </a:solidFill>
+              <a:ln>
+                <a:noFill/>
+              </a:ln>
+              <a:effectLst/>
+            </p:spPr>
+            <p:style>
+              <a:lnRef idx="2">
+                <a:schemeClr val="accent1">
+                  <a:shade val="50000"/>
+                </a:schemeClr>
+              </a:lnRef>
+              <a:fillRef idx="1">
+                <a:schemeClr val="accent1"/>
+              </a:fillRef>
+              <a:effectRef idx="0">
+                <a:schemeClr val="accent1"/>
+              </a:effectRef>
+              <a:fontRef idx="minor">
+                <a:schemeClr val="lt1"/>
+              </a:fontRef>
+            </p:style>
+            <p:txBody>
+              <a:bodyPr rtlCol="0" anchor="ctr"/>
+              <a:lstStyle/>
+              <a:p>
+                <a:pPr algn="ctr"/>
+                <a:endParaRPr lang="en-US"/>
+              </a:p>
+            </p:txBody>
+          </p:sp>
+          <p:sp>
+            <p:nvSpPr>
+              <p:cNvPr id="27" name="Oval 26">
+                <a:extLst>
+                  <a:ext uri="{FF2B5EF4-FFF2-40B4-BE49-F238E27FC236}">
+                    <a16:creationId xmlns:a16="http://schemas.microsoft.com/office/drawing/2014/main" id="{6D52BC8A-ABA8-66BD-F980-623A6D1222A8}"/>
+                  </a:ext>
+                </a:extLst>
+              </p:cNvPr>
+              <p:cNvSpPr/>
+              <p:nvPr/>
+            </p:nvSpPr>
+            <p:spPr>
+              <a:xfrm rot="10800000">
+                <a:off x="8040832" y="2648164"/>
+                <a:ext cx="274361" cy="365760"/>
+              </a:xfrm>
+              <a:prstGeom prst="ellipse">
+                <a:avLst/>
+              </a:prstGeom>
+              <a:solidFill>
+                <a:schemeClr val="accent2"/>
+              </a:solidFill>
+              <a:ln>
+                <a:noFill/>
+              </a:ln>
+              <a:effectLst/>
+            </p:spPr>
+            <p:style>
+              <a:lnRef idx="2">
+                <a:schemeClr val="accent1">
+                  <a:shade val="50000"/>
+                </a:schemeClr>
+              </a:lnRef>
+              <a:fillRef idx="1">
+                <a:schemeClr val="accent1"/>
+              </a:fillRef>
+              <a:effectRef idx="0">
+                <a:schemeClr val="accent1"/>
+              </a:effectRef>
+              <a:fontRef idx="minor">
+                <a:schemeClr val="lt1"/>
+              </a:fontRef>
+            </p:style>
+            <p:txBody>
+              <a:bodyPr rtlCol="0" anchor="ctr"/>
+              <a:lstStyle/>
+              <a:p>
+                <a:pPr algn="ctr"/>
+                <a:endParaRPr lang="en-US"/>
+              </a:p>
+            </p:txBody>
+          </p:sp>
+        </p:grpSp>
+        <p:grpSp>
+          <p:nvGrpSpPr>
+            <p:cNvPr id="28" name="Group 27">
+              <a:extLst>
+                <a:ext uri="{FF2B5EF4-FFF2-40B4-BE49-F238E27FC236}">
+                  <a16:creationId xmlns:a16="http://schemas.microsoft.com/office/drawing/2014/main" id="{76FE3E64-BFE0-0048-49F5-A40A43ADD7F3}"/>
+                </a:ext>
+              </a:extLst>
+            </p:cNvPr>
+            <p:cNvGrpSpPr/>
+            <p:nvPr/>
+          </p:nvGrpSpPr>
+          <p:grpSpPr>
+            <a:xfrm rot="4881240">
+              <a:off x="8079890" y="3928630"/>
+              <a:ext cx="230767" cy="527018"/>
+              <a:chOff x="8668623" y="1008139"/>
+              <a:chExt cx="2146049" cy="4901076"/>
+            </a:xfrm>
+          </p:grpSpPr>
+          <p:sp>
+            <p:nvSpPr>
+              <p:cNvPr id="29" name="Freeform 4">
+                <a:extLst>
+                  <a:ext uri="{FF2B5EF4-FFF2-40B4-BE49-F238E27FC236}">
+                    <a16:creationId xmlns:a16="http://schemas.microsoft.com/office/drawing/2014/main" id="{4E569B0E-EA8D-3A2D-4A68-A2116B81E52C}"/>
+                  </a:ext>
+                </a:extLst>
+              </p:cNvPr>
+              <p:cNvSpPr/>
+              <p:nvPr/>
+            </p:nvSpPr>
+            <p:spPr>
+              <a:xfrm rot="10984993">
+                <a:off x="8668623" y="1996245"/>
+                <a:ext cx="2140997" cy="3912970"/>
+              </a:xfrm>
+              <a:custGeom>
+                <a:avLst/>
+                <a:gdLst>
+                  <a:gd name="connsiteX0" fmla="*/ 452236 w 2914469"/>
+                  <a:gd name="connsiteY0" fmla="*/ 4744449 h 5470974"/>
+                  <a:gd name="connsiteX1" fmla="*/ 8891 w 2914469"/>
+                  <a:gd name="connsiteY1" fmla="*/ 2749394 h 5470974"/>
+                  <a:gd name="connsiteX2" fmla="*/ 175146 w 2914469"/>
+                  <a:gd name="connsiteY2" fmla="*/ 1211540 h 5470974"/>
+                  <a:gd name="connsiteX3" fmla="*/ 410673 w 2914469"/>
+                  <a:gd name="connsiteY3" fmla="*/ 394122 h 5470974"/>
+                  <a:gd name="connsiteX4" fmla="*/ 1186527 w 2914469"/>
+                  <a:gd name="connsiteY4" fmla="*/ 6194 h 5470974"/>
+                  <a:gd name="connsiteX5" fmla="*/ 2142491 w 2914469"/>
+                  <a:gd name="connsiteY5" fmla="*/ 269431 h 5470974"/>
+                  <a:gd name="connsiteX6" fmla="*/ 2447291 w 2914469"/>
+                  <a:gd name="connsiteY6" fmla="*/ 1599467 h 5470974"/>
+                  <a:gd name="connsiteX7" fmla="*/ 1990091 w 2914469"/>
+                  <a:gd name="connsiteY7" fmla="*/ 2610849 h 5470974"/>
+                  <a:gd name="connsiteX8" fmla="*/ 1809982 w 2914469"/>
+                  <a:gd name="connsiteY8" fmla="*/ 3622231 h 5470974"/>
+                  <a:gd name="connsiteX9" fmla="*/ 2655109 w 2914469"/>
+                  <a:gd name="connsiteY9" fmla="*/ 4522776 h 5470974"/>
+                  <a:gd name="connsiteX10" fmla="*/ 2890636 w 2914469"/>
+                  <a:gd name="connsiteY10" fmla="*/ 5049249 h 5470974"/>
+                  <a:gd name="connsiteX11" fmla="*/ 2170200 w 2914469"/>
+                  <a:gd name="connsiteY11" fmla="*/ 5423322 h 5470974"/>
+                  <a:gd name="connsiteX12" fmla="*/ 729327 w 2914469"/>
+                  <a:gd name="connsiteY12" fmla="*/ 5395613 h 5470974"/>
+                  <a:gd name="connsiteX13" fmla="*/ 452236 w 2914469"/>
+                  <a:gd name="connsiteY13" fmla="*/ 4744449 h 5470974"/>
+                  <a:gd name="connsiteX0" fmla="*/ 452236 w 2733397"/>
+                  <a:gd name="connsiteY0" fmla="*/ 4744449 h 5470974"/>
+                  <a:gd name="connsiteX1" fmla="*/ 8891 w 2733397"/>
+                  <a:gd name="connsiteY1" fmla="*/ 2749394 h 5470974"/>
+                  <a:gd name="connsiteX2" fmla="*/ 175146 w 2733397"/>
+                  <a:gd name="connsiteY2" fmla="*/ 1211540 h 5470974"/>
+                  <a:gd name="connsiteX3" fmla="*/ 410673 w 2733397"/>
+                  <a:gd name="connsiteY3" fmla="*/ 394122 h 5470974"/>
+                  <a:gd name="connsiteX4" fmla="*/ 1186527 w 2733397"/>
+                  <a:gd name="connsiteY4" fmla="*/ 6194 h 5470974"/>
+                  <a:gd name="connsiteX5" fmla="*/ 2142491 w 2733397"/>
+                  <a:gd name="connsiteY5" fmla="*/ 269431 h 5470974"/>
+                  <a:gd name="connsiteX6" fmla="*/ 2447291 w 2733397"/>
+                  <a:gd name="connsiteY6" fmla="*/ 1599467 h 5470974"/>
+                  <a:gd name="connsiteX7" fmla="*/ 1990091 w 2733397"/>
+                  <a:gd name="connsiteY7" fmla="*/ 2610849 h 5470974"/>
+                  <a:gd name="connsiteX8" fmla="*/ 1809982 w 2733397"/>
+                  <a:gd name="connsiteY8" fmla="*/ 3622231 h 5470974"/>
+                  <a:gd name="connsiteX9" fmla="*/ 2655109 w 2733397"/>
+                  <a:gd name="connsiteY9" fmla="*/ 4522776 h 5470974"/>
+                  <a:gd name="connsiteX10" fmla="*/ 2641254 w 2733397"/>
+                  <a:gd name="connsiteY10" fmla="*/ 5146231 h 5470974"/>
+                  <a:gd name="connsiteX11" fmla="*/ 2170200 w 2733397"/>
+                  <a:gd name="connsiteY11" fmla="*/ 5423322 h 5470974"/>
+                  <a:gd name="connsiteX12" fmla="*/ 729327 w 2733397"/>
+                  <a:gd name="connsiteY12" fmla="*/ 5395613 h 5470974"/>
+                  <a:gd name="connsiteX13" fmla="*/ 452236 w 2733397"/>
+                  <a:gd name="connsiteY13" fmla="*/ 4744449 h 5470974"/>
+                  <a:gd name="connsiteX0" fmla="*/ 452236 w 2662490"/>
+                  <a:gd name="connsiteY0" fmla="*/ 4744449 h 5470974"/>
+                  <a:gd name="connsiteX1" fmla="*/ 8891 w 2662490"/>
+                  <a:gd name="connsiteY1" fmla="*/ 2749394 h 5470974"/>
+                  <a:gd name="connsiteX2" fmla="*/ 175146 w 2662490"/>
+                  <a:gd name="connsiteY2" fmla="*/ 1211540 h 5470974"/>
+                  <a:gd name="connsiteX3" fmla="*/ 410673 w 2662490"/>
+                  <a:gd name="connsiteY3" fmla="*/ 394122 h 5470974"/>
+                  <a:gd name="connsiteX4" fmla="*/ 1186527 w 2662490"/>
+                  <a:gd name="connsiteY4" fmla="*/ 6194 h 5470974"/>
+                  <a:gd name="connsiteX5" fmla="*/ 2142491 w 2662490"/>
+                  <a:gd name="connsiteY5" fmla="*/ 269431 h 5470974"/>
+                  <a:gd name="connsiteX6" fmla="*/ 2447291 w 2662490"/>
+                  <a:gd name="connsiteY6" fmla="*/ 1599467 h 5470974"/>
+                  <a:gd name="connsiteX7" fmla="*/ 1990091 w 2662490"/>
+                  <a:gd name="connsiteY7" fmla="*/ 2610849 h 5470974"/>
+                  <a:gd name="connsiteX8" fmla="*/ 1809982 w 2662490"/>
+                  <a:gd name="connsiteY8" fmla="*/ 3622231 h 5470974"/>
+                  <a:gd name="connsiteX9" fmla="*/ 2502709 w 2662490"/>
+                  <a:gd name="connsiteY9" fmla="*/ 4508922 h 5470974"/>
+                  <a:gd name="connsiteX10" fmla="*/ 2641254 w 2662490"/>
+                  <a:gd name="connsiteY10" fmla="*/ 5146231 h 5470974"/>
+                  <a:gd name="connsiteX11" fmla="*/ 2170200 w 2662490"/>
+                  <a:gd name="connsiteY11" fmla="*/ 5423322 h 5470974"/>
+                  <a:gd name="connsiteX12" fmla="*/ 729327 w 2662490"/>
+                  <a:gd name="connsiteY12" fmla="*/ 5395613 h 5470974"/>
+                  <a:gd name="connsiteX13" fmla="*/ 452236 w 2662490"/>
+                  <a:gd name="connsiteY13" fmla="*/ 4744449 h 5470974"/>
+                  <a:gd name="connsiteX0" fmla="*/ 452236 w 2628430"/>
+                  <a:gd name="connsiteY0" fmla="*/ 4744449 h 5470974"/>
+                  <a:gd name="connsiteX1" fmla="*/ 8891 w 2628430"/>
+                  <a:gd name="connsiteY1" fmla="*/ 2749394 h 5470974"/>
+                  <a:gd name="connsiteX2" fmla="*/ 175146 w 2628430"/>
+                  <a:gd name="connsiteY2" fmla="*/ 1211540 h 5470974"/>
+                  <a:gd name="connsiteX3" fmla="*/ 410673 w 2628430"/>
+                  <a:gd name="connsiteY3" fmla="*/ 394122 h 5470974"/>
+                  <a:gd name="connsiteX4" fmla="*/ 1186527 w 2628430"/>
+                  <a:gd name="connsiteY4" fmla="*/ 6194 h 5470974"/>
+                  <a:gd name="connsiteX5" fmla="*/ 2142491 w 2628430"/>
+                  <a:gd name="connsiteY5" fmla="*/ 269431 h 5470974"/>
+                  <a:gd name="connsiteX6" fmla="*/ 2447291 w 2628430"/>
+                  <a:gd name="connsiteY6" fmla="*/ 1599467 h 5470974"/>
+                  <a:gd name="connsiteX7" fmla="*/ 1990091 w 2628430"/>
+                  <a:gd name="connsiteY7" fmla="*/ 2610849 h 5470974"/>
+                  <a:gd name="connsiteX8" fmla="*/ 1809982 w 2628430"/>
+                  <a:gd name="connsiteY8" fmla="*/ 3622231 h 5470974"/>
+                  <a:gd name="connsiteX9" fmla="*/ 2502709 w 2628430"/>
+                  <a:gd name="connsiteY9" fmla="*/ 4508922 h 5470974"/>
+                  <a:gd name="connsiteX10" fmla="*/ 2599690 w 2628430"/>
+                  <a:gd name="connsiteY10" fmla="*/ 5132377 h 5470974"/>
+                  <a:gd name="connsiteX11" fmla="*/ 2170200 w 2628430"/>
+                  <a:gd name="connsiteY11" fmla="*/ 5423322 h 5470974"/>
+                  <a:gd name="connsiteX12" fmla="*/ 729327 w 2628430"/>
+                  <a:gd name="connsiteY12" fmla="*/ 5395613 h 5470974"/>
+                  <a:gd name="connsiteX13" fmla="*/ 452236 w 2628430"/>
+                  <a:gd name="connsiteY13" fmla="*/ 4744449 h 5470974"/>
+                  <a:gd name="connsiteX0" fmla="*/ 452236 w 2628430"/>
+                  <a:gd name="connsiteY0" fmla="*/ 4744449 h 5464715"/>
+                  <a:gd name="connsiteX1" fmla="*/ 8891 w 2628430"/>
+                  <a:gd name="connsiteY1" fmla="*/ 2749394 h 5464715"/>
+                  <a:gd name="connsiteX2" fmla="*/ 175146 w 2628430"/>
+                  <a:gd name="connsiteY2" fmla="*/ 1211540 h 5464715"/>
+                  <a:gd name="connsiteX3" fmla="*/ 410673 w 2628430"/>
+                  <a:gd name="connsiteY3" fmla="*/ 394122 h 5464715"/>
+                  <a:gd name="connsiteX4" fmla="*/ 1186527 w 2628430"/>
+                  <a:gd name="connsiteY4" fmla="*/ 6194 h 5464715"/>
+                  <a:gd name="connsiteX5" fmla="*/ 2142491 w 2628430"/>
+                  <a:gd name="connsiteY5" fmla="*/ 269431 h 5464715"/>
+                  <a:gd name="connsiteX6" fmla="*/ 2447291 w 2628430"/>
+                  <a:gd name="connsiteY6" fmla="*/ 1599467 h 5464715"/>
+                  <a:gd name="connsiteX7" fmla="*/ 1990091 w 2628430"/>
+                  <a:gd name="connsiteY7" fmla="*/ 2610849 h 5464715"/>
+                  <a:gd name="connsiteX8" fmla="*/ 1809982 w 2628430"/>
+                  <a:gd name="connsiteY8" fmla="*/ 3622231 h 5464715"/>
+                  <a:gd name="connsiteX9" fmla="*/ 2502709 w 2628430"/>
+                  <a:gd name="connsiteY9" fmla="*/ 4508922 h 5464715"/>
+                  <a:gd name="connsiteX10" fmla="*/ 2599690 w 2628430"/>
+                  <a:gd name="connsiteY10" fmla="*/ 5132377 h 5464715"/>
+                  <a:gd name="connsiteX11" fmla="*/ 2170200 w 2628430"/>
+                  <a:gd name="connsiteY11" fmla="*/ 5423322 h 5464715"/>
+                  <a:gd name="connsiteX12" fmla="*/ 895581 w 2628430"/>
+                  <a:gd name="connsiteY12" fmla="*/ 5381759 h 5464715"/>
+                  <a:gd name="connsiteX13" fmla="*/ 452236 w 2628430"/>
+                  <a:gd name="connsiteY13" fmla="*/ 4744449 h 5464715"/>
+                  <a:gd name="connsiteX0" fmla="*/ 281453 w 2457647"/>
+                  <a:gd name="connsiteY0" fmla="*/ 4744449 h 5464715"/>
+                  <a:gd name="connsiteX1" fmla="*/ 101345 w 2457647"/>
+                  <a:gd name="connsiteY1" fmla="*/ 2790958 h 5464715"/>
+                  <a:gd name="connsiteX2" fmla="*/ 4363 w 2457647"/>
+                  <a:gd name="connsiteY2" fmla="*/ 1211540 h 5464715"/>
+                  <a:gd name="connsiteX3" fmla="*/ 239890 w 2457647"/>
+                  <a:gd name="connsiteY3" fmla="*/ 394122 h 5464715"/>
+                  <a:gd name="connsiteX4" fmla="*/ 1015744 w 2457647"/>
+                  <a:gd name="connsiteY4" fmla="*/ 6194 h 5464715"/>
+                  <a:gd name="connsiteX5" fmla="*/ 1971708 w 2457647"/>
+                  <a:gd name="connsiteY5" fmla="*/ 269431 h 5464715"/>
+                  <a:gd name="connsiteX6" fmla="*/ 2276508 w 2457647"/>
+                  <a:gd name="connsiteY6" fmla="*/ 1599467 h 5464715"/>
+                  <a:gd name="connsiteX7" fmla="*/ 1819308 w 2457647"/>
+                  <a:gd name="connsiteY7" fmla="*/ 2610849 h 5464715"/>
+                  <a:gd name="connsiteX8" fmla="*/ 1639199 w 2457647"/>
+                  <a:gd name="connsiteY8" fmla="*/ 3622231 h 5464715"/>
+                  <a:gd name="connsiteX9" fmla="*/ 2331926 w 2457647"/>
+                  <a:gd name="connsiteY9" fmla="*/ 4508922 h 5464715"/>
+                  <a:gd name="connsiteX10" fmla="*/ 2428907 w 2457647"/>
+                  <a:gd name="connsiteY10" fmla="*/ 5132377 h 5464715"/>
+                  <a:gd name="connsiteX11" fmla="*/ 1999417 w 2457647"/>
+                  <a:gd name="connsiteY11" fmla="*/ 5423322 h 5464715"/>
+                  <a:gd name="connsiteX12" fmla="*/ 724798 w 2457647"/>
+                  <a:gd name="connsiteY12" fmla="*/ 5381759 h 5464715"/>
+                  <a:gd name="connsiteX13" fmla="*/ 281453 w 2457647"/>
+                  <a:gd name="connsiteY13" fmla="*/ 4744449 h 5464715"/>
+                  <a:gd name="connsiteX0" fmla="*/ 182997 w 2359191"/>
+                  <a:gd name="connsiteY0" fmla="*/ 4744449 h 5464715"/>
+                  <a:gd name="connsiteX1" fmla="*/ 2889 w 2359191"/>
+                  <a:gd name="connsiteY1" fmla="*/ 2790958 h 5464715"/>
+                  <a:gd name="connsiteX2" fmla="*/ 141434 w 2359191"/>
+                  <a:gd name="connsiteY2" fmla="*/ 394122 h 5464715"/>
+                  <a:gd name="connsiteX3" fmla="*/ 917288 w 2359191"/>
+                  <a:gd name="connsiteY3" fmla="*/ 6194 h 5464715"/>
+                  <a:gd name="connsiteX4" fmla="*/ 1873252 w 2359191"/>
+                  <a:gd name="connsiteY4" fmla="*/ 269431 h 5464715"/>
+                  <a:gd name="connsiteX5" fmla="*/ 2178052 w 2359191"/>
+                  <a:gd name="connsiteY5" fmla="*/ 1599467 h 5464715"/>
+                  <a:gd name="connsiteX6" fmla="*/ 1720852 w 2359191"/>
+                  <a:gd name="connsiteY6" fmla="*/ 2610849 h 5464715"/>
+                  <a:gd name="connsiteX7" fmla="*/ 1540743 w 2359191"/>
+                  <a:gd name="connsiteY7" fmla="*/ 3622231 h 5464715"/>
+                  <a:gd name="connsiteX8" fmla="*/ 2233470 w 2359191"/>
+                  <a:gd name="connsiteY8" fmla="*/ 4508922 h 5464715"/>
+                  <a:gd name="connsiteX9" fmla="*/ 2330451 w 2359191"/>
+                  <a:gd name="connsiteY9" fmla="*/ 5132377 h 5464715"/>
+                  <a:gd name="connsiteX10" fmla="*/ 1900961 w 2359191"/>
+                  <a:gd name="connsiteY10" fmla="*/ 5423322 h 5464715"/>
+                  <a:gd name="connsiteX11" fmla="*/ 626342 w 2359191"/>
+                  <a:gd name="connsiteY11" fmla="*/ 5381759 h 5464715"/>
+                  <a:gd name="connsiteX12" fmla="*/ 182997 w 2359191"/>
+                  <a:gd name="connsiteY12" fmla="*/ 4744449 h 5464715"/>
+                  <a:gd name="connsiteX0" fmla="*/ 180222 w 2356416"/>
+                  <a:gd name="connsiteY0" fmla="*/ 4782093 h 5502359"/>
+                  <a:gd name="connsiteX1" fmla="*/ 114 w 2356416"/>
+                  <a:gd name="connsiteY1" fmla="*/ 2828602 h 5502359"/>
+                  <a:gd name="connsiteX2" fmla="*/ 201419 w 2356416"/>
+                  <a:gd name="connsiteY2" fmla="*/ 982913 h 5502359"/>
+                  <a:gd name="connsiteX3" fmla="*/ 914513 w 2356416"/>
+                  <a:gd name="connsiteY3" fmla="*/ 43838 h 5502359"/>
+                  <a:gd name="connsiteX4" fmla="*/ 1870477 w 2356416"/>
+                  <a:gd name="connsiteY4" fmla="*/ 307075 h 5502359"/>
+                  <a:gd name="connsiteX5" fmla="*/ 2175277 w 2356416"/>
+                  <a:gd name="connsiteY5" fmla="*/ 1637111 h 5502359"/>
+                  <a:gd name="connsiteX6" fmla="*/ 1718077 w 2356416"/>
+                  <a:gd name="connsiteY6" fmla="*/ 2648493 h 5502359"/>
+                  <a:gd name="connsiteX7" fmla="*/ 1537968 w 2356416"/>
+                  <a:gd name="connsiteY7" fmla="*/ 3659875 h 5502359"/>
+                  <a:gd name="connsiteX8" fmla="*/ 2230695 w 2356416"/>
+                  <a:gd name="connsiteY8" fmla="*/ 4546566 h 5502359"/>
+                  <a:gd name="connsiteX9" fmla="*/ 2327676 w 2356416"/>
+                  <a:gd name="connsiteY9" fmla="*/ 5170021 h 5502359"/>
+                  <a:gd name="connsiteX10" fmla="*/ 1898186 w 2356416"/>
+                  <a:gd name="connsiteY10" fmla="*/ 5460966 h 5502359"/>
+                  <a:gd name="connsiteX11" fmla="*/ 623567 w 2356416"/>
+                  <a:gd name="connsiteY11" fmla="*/ 5419403 h 5502359"/>
+                  <a:gd name="connsiteX12" fmla="*/ 180222 w 2356416"/>
+                  <a:gd name="connsiteY12" fmla="*/ 4782093 h 5502359"/>
+                </a:gdLst>
+                <a:ahLst/>
+                <a:cxnLst>
+                  <a:cxn ang="0">
+                    <a:pos x="connsiteX0" y="connsiteY0"/>
+                  </a:cxn>
+                  <a:cxn ang="0">
+                    <a:pos x="connsiteX1" y="connsiteY1"/>
+                  </a:cxn>
+                  <a:cxn ang="0">
+                    <a:pos x="connsiteX2" y="connsiteY2"/>
+                  </a:cxn>
+                  <a:cxn ang="0">
+                    <a:pos x="connsiteX3" y="connsiteY3"/>
+                  </a:cxn>
+                  <a:cxn ang="0">
+                    <a:pos x="connsiteX4" y="connsiteY4"/>
+                  </a:cxn>
+                  <a:cxn ang="0">
+                    <a:pos x="connsiteX5" y="connsiteY5"/>
+                  </a:cxn>
+                  <a:cxn ang="0">
+                    <a:pos x="connsiteX6" y="connsiteY6"/>
+                  </a:cxn>
+                  <a:cxn ang="0">
+                    <a:pos x="connsiteX7" y="connsiteY7"/>
+                  </a:cxn>
+                  <a:cxn ang="0">
+                    <a:pos x="connsiteX8" y="connsiteY8"/>
+                  </a:cxn>
+                  <a:cxn ang="0">
+                    <a:pos x="connsiteX9" y="connsiteY9"/>
+                  </a:cxn>
+                  <a:cxn ang="0">
+                    <a:pos x="connsiteX10" y="connsiteY10"/>
+                  </a:cxn>
+                  <a:cxn ang="0">
+                    <a:pos x="connsiteX11" y="connsiteY11"/>
+                  </a:cxn>
+                  <a:cxn ang="0">
+                    <a:pos x="connsiteX12" y="connsiteY12"/>
+                  </a:cxn>
+                </a:cxnLst>
+                <a:rect l="l" t="t" r="r" b="b"/>
+                <a:pathLst>
+                  <a:path w="2356416" h="5502359">
+                    <a:moveTo>
+                      <a:pt x="180222" y="4782093"/>
+                    </a:moveTo>
+                    <a:cubicBezTo>
+                      <a:pt x="76313" y="4350293"/>
+                      <a:pt x="-3419" y="3461799"/>
+                      <a:pt x="114" y="2828602"/>
+                    </a:cubicBezTo>
+                    <a:cubicBezTo>
+                      <a:pt x="3647" y="2195405"/>
+                      <a:pt x="49019" y="1447040"/>
+                      <a:pt x="201419" y="982913"/>
+                    </a:cubicBezTo>
+                    <a:cubicBezTo>
+                      <a:pt x="353819" y="518786"/>
+                      <a:pt x="636337" y="156478"/>
+                      <a:pt x="914513" y="43838"/>
+                    </a:cubicBezTo>
+                    <a:cubicBezTo>
+                      <a:pt x="1192689" y="-68802"/>
+                      <a:pt x="1660350" y="41530"/>
+                      <a:pt x="1870477" y="307075"/>
+                    </a:cubicBezTo>
+                    <a:cubicBezTo>
+                      <a:pt x="2080604" y="572620"/>
+                      <a:pt x="2200677" y="1246875"/>
+                      <a:pt x="2175277" y="1637111"/>
+                    </a:cubicBezTo>
+                    <a:cubicBezTo>
+                      <a:pt x="2149877" y="2027347"/>
+                      <a:pt x="1824295" y="2311366"/>
+                      <a:pt x="1718077" y="2648493"/>
+                    </a:cubicBezTo>
+                    <a:cubicBezTo>
+                      <a:pt x="1611859" y="2985620"/>
+                      <a:pt x="1452532" y="3343530"/>
+                      <a:pt x="1537968" y="3659875"/>
+                    </a:cubicBezTo>
+                    <a:cubicBezTo>
+                      <a:pt x="1623404" y="3976221"/>
+                      <a:pt x="2099077" y="4294875"/>
+                      <a:pt x="2230695" y="4546566"/>
+                    </a:cubicBezTo>
+                    <a:cubicBezTo>
+                      <a:pt x="2362313" y="4798257"/>
+                      <a:pt x="2383094" y="5017621"/>
+                      <a:pt x="2327676" y="5170021"/>
+                    </a:cubicBezTo>
+                    <a:cubicBezTo>
+                      <a:pt x="2272258" y="5322421"/>
+                      <a:pt x="2258404" y="5403239"/>
+                      <a:pt x="1898186" y="5460966"/>
+                    </a:cubicBezTo>
+                    <a:cubicBezTo>
+                      <a:pt x="1537968" y="5518693"/>
+                      <a:pt x="907585" y="5525621"/>
+                      <a:pt x="623567" y="5419403"/>
+                    </a:cubicBezTo>
+                    <a:cubicBezTo>
+                      <a:pt x="339549" y="5313185"/>
+                      <a:pt x="284131" y="5213893"/>
+                      <a:pt x="180222" y="4782093"/>
+                    </a:cubicBezTo>
+                    <a:close/>
+                  </a:path>
+                </a:pathLst>
+              </a:custGeom>
+              <a:solidFill>
+                <a:schemeClr val="accent2"/>
+              </a:solidFill>
+              <a:ln>
+                <a:noFill/>
+              </a:ln>
+            </p:spPr>
+            <p:style>
+              <a:lnRef idx="2">
+                <a:schemeClr val="accent1">
+                  <a:shade val="50000"/>
+                </a:schemeClr>
+              </a:lnRef>
+              <a:fillRef idx="1">
+                <a:schemeClr val="accent1"/>
+              </a:fillRef>
+              <a:effectRef idx="0">
+                <a:schemeClr val="accent1"/>
+              </a:effectRef>
+              <a:fontRef idx="minor">
+                <a:schemeClr val="lt1"/>
+              </a:fontRef>
+            </p:style>
+            <p:txBody>
+              <a:bodyPr rtlCol="0" anchor="ctr"/>
+              <a:lstStyle/>
+              <a:p>
+                <a:pPr algn="ctr"/>
+                <a:endParaRPr lang="en-US"/>
+              </a:p>
+            </p:txBody>
+          </p:sp>
+          <p:sp>
+            <p:nvSpPr>
+              <p:cNvPr id="30" name="Oval 29">
+                <a:extLst>
+                  <a:ext uri="{FF2B5EF4-FFF2-40B4-BE49-F238E27FC236}">
+                    <a16:creationId xmlns:a16="http://schemas.microsoft.com/office/drawing/2014/main" id="{6C938A78-DD00-8AF8-9157-B98D7B25B28E}"/>
+                  </a:ext>
+                </a:extLst>
+              </p:cNvPr>
+              <p:cNvSpPr/>
+              <p:nvPr/>
+            </p:nvSpPr>
+            <p:spPr>
+              <a:xfrm rot="10800000">
+                <a:off x="8747807" y="1008139"/>
+                <a:ext cx="609600" cy="893561"/>
+              </a:xfrm>
+              <a:prstGeom prst="ellipse">
+                <a:avLst/>
+              </a:prstGeom>
+              <a:solidFill>
+                <a:schemeClr val="accent2"/>
+              </a:solidFill>
+              <a:ln>
+                <a:noFill/>
+              </a:ln>
+              <a:effectLst/>
+            </p:spPr>
+            <p:style>
+              <a:lnRef idx="2">
+                <a:schemeClr val="accent1">
+                  <a:shade val="50000"/>
+                </a:schemeClr>
+              </a:lnRef>
+              <a:fillRef idx="1">
+                <a:schemeClr val="accent1"/>
+              </a:fillRef>
+              <a:effectRef idx="0">
+                <a:schemeClr val="accent1"/>
+              </a:effectRef>
+              <a:fontRef idx="minor">
+                <a:schemeClr val="lt1"/>
+              </a:fontRef>
+            </p:style>
+            <p:txBody>
+              <a:bodyPr rtlCol="0" anchor="ctr"/>
+              <a:lstStyle/>
+              <a:p>
+                <a:pPr algn="ctr"/>
+                <a:endParaRPr lang="en-US"/>
+              </a:p>
+            </p:txBody>
+          </p:sp>
+          <p:sp>
+            <p:nvSpPr>
+              <p:cNvPr id="31" name="Oval 30">
+                <a:extLst>
+                  <a:ext uri="{FF2B5EF4-FFF2-40B4-BE49-F238E27FC236}">
+                    <a16:creationId xmlns:a16="http://schemas.microsoft.com/office/drawing/2014/main" id="{95F6F89A-83BB-197E-744B-31A0F60A6132}"/>
+                  </a:ext>
+                </a:extLst>
+              </p:cNvPr>
+              <p:cNvSpPr/>
+              <p:nvPr/>
+            </p:nvSpPr>
+            <p:spPr>
+              <a:xfrm rot="10800000">
+                <a:off x="9519274" y="1213747"/>
+                <a:ext cx="274361" cy="548640"/>
+              </a:xfrm>
+              <a:prstGeom prst="ellipse">
+                <a:avLst/>
+              </a:prstGeom>
+              <a:solidFill>
+                <a:schemeClr val="accent2"/>
+              </a:solidFill>
+              <a:ln>
+                <a:noFill/>
+              </a:ln>
+              <a:effectLst/>
+            </p:spPr>
+            <p:style>
+              <a:lnRef idx="2">
+                <a:schemeClr val="accent1">
+                  <a:shade val="50000"/>
+                </a:schemeClr>
+              </a:lnRef>
+              <a:fillRef idx="1">
+                <a:schemeClr val="accent1"/>
+              </a:fillRef>
+              <a:effectRef idx="0">
+                <a:schemeClr val="accent1"/>
+              </a:effectRef>
+              <a:fontRef idx="minor">
+                <a:schemeClr val="lt1"/>
+              </a:fontRef>
+            </p:style>
+            <p:txBody>
+              <a:bodyPr rtlCol="0" anchor="ctr"/>
+              <a:lstStyle/>
+              <a:p>
+                <a:pPr algn="ctr"/>
+                <a:endParaRPr lang="en-US"/>
+              </a:p>
+            </p:txBody>
+          </p:sp>
+          <p:sp>
+            <p:nvSpPr>
+              <p:cNvPr id="32" name="Oval 31">
+                <a:extLst>
+                  <a:ext uri="{FF2B5EF4-FFF2-40B4-BE49-F238E27FC236}">
+                    <a16:creationId xmlns:a16="http://schemas.microsoft.com/office/drawing/2014/main" id="{A047550C-BC60-F571-B56B-96CB67D049B6}"/>
+                  </a:ext>
+                </a:extLst>
+              </p:cNvPr>
+              <p:cNvSpPr/>
+              <p:nvPr/>
+            </p:nvSpPr>
+            <p:spPr>
+              <a:xfrm rot="10800000">
+                <a:off x="9854512" y="1305187"/>
+                <a:ext cx="274361" cy="548640"/>
+              </a:xfrm>
+              <a:prstGeom prst="ellipse">
+                <a:avLst/>
+              </a:prstGeom>
+              <a:solidFill>
+                <a:schemeClr val="accent2"/>
+              </a:solidFill>
+              <a:ln>
+                <a:noFill/>
+              </a:ln>
+              <a:effectLst/>
+            </p:spPr>
+            <p:style>
+              <a:lnRef idx="2">
+                <a:schemeClr val="accent1">
+                  <a:shade val="50000"/>
+                </a:schemeClr>
+              </a:lnRef>
+              <a:fillRef idx="1">
+                <a:schemeClr val="accent1"/>
+              </a:fillRef>
+              <a:effectRef idx="0">
+                <a:schemeClr val="accent1"/>
+              </a:effectRef>
+              <a:fontRef idx="minor">
+                <a:schemeClr val="lt1"/>
+              </a:fontRef>
+            </p:style>
+            <p:txBody>
+              <a:bodyPr rtlCol="0" anchor="ctr"/>
+              <a:lstStyle/>
+              <a:p>
+                <a:pPr algn="ctr"/>
+                <a:endParaRPr lang="en-US"/>
+              </a:p>
+            </p:txBody>
+          </p:sp>
+          <p:sp>
+            <p:nvSpPr>
+              <p:cNvPr id="33" name="Oval 32">
+                <a:extLst>
+                  <a:ext uri="{FF2B5EF4-FFF2-40B4-BE49-F238E27FC236}">
+                    <a16:creationId xmlns:a16="http://schemas.microsoft.com/office/drawing/2014/main" id="{29E9A4DC-4591-1B40-AEA0-C1326610A6F7}"/>
+                  </a:ext>
+                </a:extLst>
+              </p:cNvPr>
+              <p:cNvSpPr/>
+              <p:nvPr/>
+            </p:nvSpPr>
+            <p:spPr>
+              <a:xfrm rot="10800000">
+                <a:off x="10205073" y="1416688"/>
+                <a:ext cx="274361" cy="457200"/>
+              </a:xfrm>
+              <a:prstGeom prst="ellipse">
+                <a:avLst/>
+              </a:prstGeom>
+              <a:solidFill>
+                <a:schemeClr val="accent2"/>
+              </a:solidFill>
+              <a:ln>
+                <a:noFill/>
+              </a:ln>
+              <a:effectLst/>
+            </p:spPr>
+            <p:style>
+              <a:lnRef idx="2">
+                <a:schemeClr val="accent1">
+                  <a:shade val="50000"/>
+                </a:schemeClr>
+              </a:lnRef>
+              <a:fillRef idx="1">
+                <a:schemeClr val="accent1"/>
+              </a:fillRef>
+              <a:effectRef idx="0">
+                <a:schemeClr val="accent1"/>
+              </a:effectRef>
+              <a:fontRef idx="minor">
+                <a:schemeClr val="lt1"/>
+              </a:fontRef>
+            </p:style>
+            <p:txBody>
+              <a:bodyPr rtlCol="0" anchor="ctr"/>
+              <a:lstStyle/>
+              <a:p>
+                <a:pPr algn="ctr"/>
+                <a:endParaRPr lang="en-US"/>
+              </a:p>
+            </p:txBody>
+          </p:sp>
+          <p:sp>
+            <p:nvSpPr>
+              <p:cNvPr id="34" name="Oval 33">
+                <a:extLst>
+                  <a:ext uri="{FF2B5EF4-FFF2-40B4-BE49-F238E27FC236}">
+                    <a16:creationId xmlns:a16="http://schemas.microsoft.com/office/drawing/2014/main" id="{BB63FD16-0444-C11F-35B5-EA590D821F6D}"/>
+                  </a:ext>
+                </a:extLst>
+              </p:cNvPr>
+              <p:cNvSpPr/>
+              <p:nvPr/>
+            </p:nvSpPr>
+            <p:spPr>
+              <a:xfrm rot="10800000">
+                <a:off x="10540311" y="1670947"/>
+                <a:ext cx="274361" cy="365760"/>
+              </a:xfrm>
+              <a:prstGeom prst="ellipse">
+                <a:avLst/>
+              </a:prstGeom>
+              <a:solidFill>
+                <a:schemeClr val="accent2"/>
+              </a:solidFill>
+              <a:ln>
+                <a:noFill/>
+              </a:ln>
+              <a:effectLst/>
+            </p:spPr>
+            <p:style>
+              <a:lnRef idx="2">
+                <a:schemeClr val="accent1">
+                  <a:shade val="50000"/>
+                </a:schemeClr>
+              </a:lnRef>
+              <a:fillRef idx="1">
+                <a:schemeClr val="accent1"/>
+              </a:fillRef>
+              <a:effectRef idx="0">
+                <a:schemeClr val="accent1"/>
+              </a:effectRef>
+              <a:fontRef idx="minor">
+                <a:schemeClr val="lt1"/>
+              </a:fontRef>
+            </p:style>
+            <p:txBody>
+              <a:bodyPr rtlCol="0" anchor="ctr"/>
+              <a:lstStyle/>
+              <a:p>
+                <a:pPr algn="ctr"/>
+                <a:endParaRPr lang="en-US"/>
+              </a:p>
+            </p:txBody>
+          </p:sp>
+        </p:grpSp>
+      </p:grpSp>
+      <p:pic>
+        <p:nvPicPr>
+          <p:cNvPr id="3" name="Picture 2">
+            <a:extLst>
+              <a:ext uri="{FF2B5EF4-FFF2-40B4-BE49-F238E27FC236}">
+                <a16:creationId xmlns:a16="http://schemas.microsoft.com/office/drawing/2014/main" id="{334A6E1A-5569-4D4B-7A95-74C3138C64FE}"/>
+              </a:ext>
+            </a:extLst>
+          </p:cNvPr>
+          <p:cNvPicPr>
+            <a:picLocks noChangeAspect="1"/>
+          </p:cNvPicPr>
+          <p:nvPr/>
+        </p:nvPicPr>
+        <p:blipFill>
+          <a:blip r:embed="rId2">
+            <a:extLst>
+              <a:ext uri="{28A0092B-C50C-407E-A947-70E740481C1C}">
+                <a14:useLocalDpi xmlns:a14="http://schemas.microsoft.com/office/drawing/2010/main" val="0"/>
+              </a:ext>
+            </a:extLst>
+          </a:blip>
+          <a:stretch>
+            <a:fillRect/>
+          </a:stretch>
+        </p:blipFill>
+        <p:spPr>
+          <a:xfrm>
+            <a:off x="3849421" y="838200"/>
+            <a:ext cx="4761905" cy="4761905"/>
+          </a:xfrm>
+          <a:prstGeom prst="rect">
+            <a:avLst/>
+          </a:prstGeom>
+        </p:spPr>
+      </p:pic>
     </p:spTree>
     <p:extLst>
       <p:ext uri="{BB962C8B-B14F-4D97-AF65-F5344CB8AC3E}">

</xml_diff>

<commit_message>
content always shows shloka
</commit_message>
<xml_diff>
--- a/feeder/tools/pics-making.pptx
+++ b/feeder/tools/pics-making.pptx
@@ -311,7 +311,7 @@
           <a:p>
             <a:fld id="{56E5DCE2-4C0C-4B49-9538-1E32127C0620}" type="datetimeFigureOut">
               <a:rPr lang="en-IN" smtClean="0"/>
-              <a:t>10-11-2024</a:t>
+              <a:t>13-11-2024</a:t>
             </a:fld>
             <a:endParaRPr lang="en-IN"/>
           </a:p>
@@ -481,7 +481,7 @@
           <a:p>
             <a:fld id="{56E5DCE2-4C0C-4B49-9538-1E32127C0620}" type="datetimeFigureOut">
               <a:rPr lang="en-IN" smtClean="0"/>
-              <a:t>10-11-2024</a:t>
+              <a:t>13-11-2024</a:t>
             </a:fld>
             <a:endParaRPr lang="en-IN"/>
           </a:p>
@@ -661,7 +661,7 @@
           <a:p>
             <a:fld id="{56E5DCE2-4C0C-4B49-9538-1E32127C0620}" type="datetimeFigureOut">
               <a:rPr lang="en-IN" smtClean="0"/>
-              <a:t>10-11-2024</a:t>
+              <a:t>13-11-2024</a:t>
             </a:fld>
             <a:endParaRPr lang="en-IN"/>
           </a:p>
@@ -831,7 +831,7 @@
           <a:p>
             <a:fld id="{56E5DCE2-4C0C-4B49-9538-1E32127C0620}" type="datetimeFigureOut">
               <a:rPr lang="en-IN" smtClean="0"/>
-              <a:t>10-11-2024</a:t>
+              <a:t>13-11-2024</a:t>
             </a:fld>
             <a:endParaRPr lang="en-IN"/>
           </a:p>
@@ -1077,7 +1077,7 @@
           <a:p>
             <a:fld id="{56E5DCE2-4C0C-4B49-9538-1E32127C0620}" type="datetimeFigureOut">
               <a:rPr lang="en-IN" smtClean="0"/>
-              <a:t>10-11-2024</a:t>
+              <a:t>13-11-2024</a:t>
             </a:fld>
             <a:endParaRPr lang="en-IN"/>
           </a:p>
@@ -1365,7 +1365,7 @@
           <a:p>
             <a:fld id="{56E5DCE2-4C0C-4B49-9538-1E32127C0620}" type="datetimeFigureOut">
               <a:rPr lang="en-IN" smtClean="0"/>
-              <a:t>10-11-2024</a:t>
+              <a:t>13-11-2024</a:t>
             </a:fld>
             <a:endParaRPr lang="en-IN"/>
           </a:p>
@@ -1787,7 +1787,7 @@
           <a:p>
             <a:fld id="{56E5DCE2-4C0C-4B49-9538-1E32127C0620}" type="datetimeFigureOut">
               <a:rPr lang="en-IN" smtClean="0"/>
-              <a:t>10-11-2024</a:t>
+              <a:t>13-11-2024</a:t>
             </a:fld>
             <a:endParaRPr lang="en-IN"/>
           </a:p>
@@ -1905,7 +1905,7 @@
           <a:p>
             <a:fld id="{56E5DCE2-4C0C-4B49-9538-1E32127C0620}" type="datetimeFigureOut">
               <a:rPr lang="en-IN" smtClean="0"/>
-              <a:t>10-11-2024</a:t>
+              <a:t>13-11-2024</a:t>
             </a:fld>
             <a:endParaRPr lang="en-IN"/>
           </a:p>
@@ -2000,7 +2000,7 @@
           <a:p>
             <a:fld id="{56E5DCE2-4C0C-4B49-9538-1E32127C0620}" type="datetimeFigureOut">
               <a:rPr lang="en-IN" smtClean="0"/>
-              <a:t>10-11-2024</a:t>
+              <a:t>13-11-2024</a:t>
             </a:fld>
             <a:endParaRPr lang="en-IN"/>
           </a:p>
@@ -2277,7 +2277,7 @@
           <a:p>
             <a:fld id="{56E5DCE2-4C0C-4B49-9538-1E32127C0620}" type="datetimeFigureOut">
               <a:rPr lang="en-IN" smtClean="0"/>
-              <a:t>10-11-2024</a:t>
+              <a:t>13-11-2024</a:t>
             </a:fld>
             <a:endParaRPr lang="en-IN"/>
           </a:p>
@@ -2530,7 +2530,7 @@
           <a:p>
             <a:fld id="{56E5DCE2-4C0C-4B49-9538-1E32127C0620}" type="datetimeFigureOut">
               <a:rPr lang="en-IN" smtClean="0"/>
-              <a:t>10-11-2024</a:t>
+              <a:t>13-11-2024</a:t>
             </a:fld>
             <a:endParaRPr lang="en-IN"/>
           </a:p>
@@ -2743,7 +2743,7 @@
           <a:p>
             <a:fld id="{56E5DCE2-4C0C-4B49-9538-1E32127C0620}" type="datetimeFigureOut">
               <a:rPr lang="en-IN" smtClean="0"/>
-              <a:t>10-11-2024</a:t>
+              <a:t>13-11-2024</a:t>
             </a:fld>
             <a:endParaRPr lang="en-IN"/>
           </a:p>
@@ -4372,16 +4372,22 @@
       </p:grpSpPr>
       <p:grpSp>
         <p:nvGrpSpPr>
-          <p:cNvPr id="2" name="Group 1"/>
+          <p:cNvPr id="7" name="Group 6">
+            <a:extLst>
+              <a:ext uri="{FF2B5EF4-FFF2-40B4-BE49-F238E27FC236}">
+                <a16:creationId xmlns:a16="http://schemas.microsoft.com/office/drawing/2014/main" id="{02D31641-6E16-D3C5-104F-D809F1FF0869}"/>
+              </a:ext>
+            </a:extLst>
+          </p:cNvPr>
           <p:cNvGrpSpPr/>
           <p:nvPr/>
         </p:nvGrpSpPr>
         <p:grpSpPr>
           <a:xfrm>
-            <a:off x="2359383" y="803586"/>
-            <a:ext cx="4406543" cy="4911414"/>
-            <a:chOff x="2359383" y="803586"/>
-            <a:chExt cx="4406543" cy="4911414"/>
+            <a:off x="2128241" y="803586"/>
+            <a:ext cx="4680000" cy="4680000"/>
+            <a:chOff x="2128241" y="803586"/>
+            <a:chExt cx="4680000" cy="4680000"/>
           </a:xfrm>
         </p:grpSpPr>
         <p:sp>
@@ -4392,8 +4398,8 @@
           </p:nvSpPr>
           <p:spPr>
             <a:xfrm rot="184993">
-              <a:off x="2359383" y="813923"/>
-              <a:ext cx="2140997" cy="3912970"/>
+              <a:off x="2354041" y="813236"/>
+              <a:ext cx="2091516" cy="3652843"/>
             </a:xfrm>
             <a:custGeom>
               <a:avLst/>
@@ -4771,8 +4777,8 @@
           </p:nvSpPr>
           <p:spPr>
             <a:xfrm rot="21426065" flipH="1">
-              <a:off x="4624151" y="803586"/>
-              <a:ext cx="2141775" cy="3923144"/>
+              <a:off x="4566468" y="803586"/>
+              <a:ext cx="2092276" cy="3662341"/>
             </a:xfrm>
             <a:custGeom>
               <a:avLst/>
@@ -5176,31 +5182,500 @@
           </p:nvSpPr>
           <p:spPr>
             <a:xfrm>
-              <a:off x="3810000" y="4821439"/>
-              <a:ext cx="609600" cy="893561"/>
+              <a:off x="3771133" y="4554340"/>
+              <a:ext cx="595511" cy="834159"/>
             </a:xfrm>
             <a:prstGeom prst="ellipse">
               <a:avLst/>
             </a:prstGeom>
             <a:solidFill>
-              <a:schemeClr val="accent2"/>
+              <a:srgbClr val="C0504D"/>
+            </a:solidFill>
+            <a:ln>
+              <a:noFill/>
+            </a:ln>
+          </p:spPr>
+          <p:style>
+            <a:lnRef idx="2">
+              <a:schemeClr val="dk1"/>
+            </a:lnRef>
+            <a:fillRef idx="1">
+              <a:schemeClr val="lt1"/>
+            </a:fillRef>
+            <a:effectRef idx="0">
+              <a:schemeClr val="dk1"/>
+            </a:effectRef>
+            <a:fontRef idx="minor">
+              <a:schemeClr val="dk1"/>
+            </a:fontRef>
+          </p:style>
+          <p:txBody>
+            <a:bodyPr rtlCol="0" anchor="ctr"/>
+            <a:lstStyle/>
+            <a:p>
+              <a:pPr algn="ctr"/>
+              <a:endParaRPr lang="en-US"/>
+            </a:p>
+          </p:txBody>
+        </p:sp>
+        <p:sp>
+          <p:nvSpPr>
+            <p:cNvPr id="9" name="Oval 8"/>
+            <p:cNvSpPr/>
+            <p:nvPr/>
+          </p:nvSpPr>
+          <p:spPr>
+            <a:xfrm>
+              <a:off x="4617030" y="4554340"/>
+              <a:ext cx="595511" cy="834159"/>
+            </a:xfrm>
+            <a:prstGeom prst="ellipse">
+              <a:avLst/>
+            </a:prstGeom>
+            <a:solidFill>
+              <a:srgbClr val="C0504D"/>
+            </a:solidFill>
+            <a:ln>
+              <a:noFill/>
+            </a:ln>
+          </p:spPr>
+          <p:style>
+            <a:lnRef idx="2">
+              <a:schemeClr val="dk1"/>
+            </a:lnRef>
+            <a:fillRef idx="1">
+              <a:schemeClr val="lt1"/>
+            </a:fillRef>
+            <a:effectRef idx="0">
+              <a:schemeClr val="dk1"/>
+            </a:effectRef>
+            <a:fontRef idx="minor">
+              <a:schemeClr val="dk1"/>
+            </a:fontRef>
+          </p:style>
+          <p:txBody>
+            <a:bodyPr rtlCol="0" anchor="ctr"/>
+            <a:lstStyle/>
+            <a:p>
+              <a:pPr algn="ctr"/>
+              <a:endParaRPr lang="en-US">
+                <a:solidFill>
+                  <a:schemeClr val="dk1"/>
+                </a:solidFill>
+              </a:endParaRPr>
+            </a:p>
+          </p:txBody>
+        </p:sp>
+        <p:sp>
+          <p:nvSpPr>
+            <p:cNvPr id="10" name="Oval 9"/>
+            <p:cNvSpPr/>
+            <p:nvPr/>
+          </p:nvSpPr>
+          <p:spPr>
+            <a:xfrm>
+              <a:off x="3354235" y="4751883"/>
+              <a:ext cx="268020" cy="512167"/>
+            </a:xfrm>
+            <a:prstGeom prst="ellipse">
+              <a:avLst/>
+            </a:prstGeom>
+            <a:solidFill>
+              <a:srgbClr val="C0504D"/>
+            </a:solidFill>
+            <a:ln>
+              <a:noFill/>
+            </a:ln>
+          </p:spPr>
+          <p:style>
+            <a:lnRef idx="2">
+              <a:schemeClr val="dk1"/>
+            </a:lnRef>
+            <a:fillRef idx="1">
+              <a:schemeClr val="lt1"/>
+            </a:fillRef>
+            <a:effectRef idx="0">
+              <a:schemeClr val="dk1"/>
+            </a:effectRef>
+            <a:fontRef idx="minor">
+              <a:schemeClr val="dk1"/>
+            </a:fontRef>
+          </p:style>
+          <p:txBody>
+            <a:bodyPr rtlCol="0" anchor="ctr"/>
+            <a:lstStyle/>
+            <a:p>
+              <a:pPr algn="ctr"/>
+              <a:endParaRPr lang="en-US">
+                <a:solidFill>
+                  <a:schemeClr val="dk1"/>
+                </a:solidFill>
+              </a:endParaRPr>
+            </a:p>
+          </p:txBody>
+        </p:sp>
+        <p:sp>
+          <p:nvSpPr>
+            <p:cNvPr id="11" name="Oval 10"/>
+            <p:cNvSpPr/>
+            <p:nvPr/>
+          </p:nvSpPr>
+          <p:spPr>
+            <a:xfrm>
+              <a:off x="5334350" y="4751883"/>
+              <a:ext cx="268020" cy="512167"/>
+            </a:xfrm>
+            <a:prstGeom prst="ellipse">
+              <a:avLst/>
+            </a:prstGeom>
+            <a:solidFill>
+              <a:srgbClr val="C0504D"/>
+            </a:solidFill>
+            <a:ln>
+              <a:noFill/>
+            </a:ln>
+          </p:spPr>
+          <p:style>
+            <a:lnRef idx="2">
+              <a:schemeClr val="dk1"/>
+            </a:lnRef>
+            <a:fillRef idx="1">
+              <a:schemeClr val="lt1"/>
+            </a:fillRef>
+            <a:effectRef idx="0">
+              <a:schemeClr val="dk1"/>
+            </a:effectRef>
+            <a:fontRef idx="minor">
+              <a:schemeClr val="dk1"/>
+            </a:fontRef>
+          </p:style>
+          <p:txBody>
+            <a:bodyPr rtlCol="0" anchor="ctr"/>
+            <a:lstStyle/>
+            <a:p>
+              <a:pPr algn="ctr"/>
+              <a:endParaRPr lang="en-US">
+                <a:solidFill>
+                  <a:schemeClr val="dk1"/>
+                </a:solidFill>
+              </a:endParaRPr>
+            </a:p>
+          </p:txBody>
+        </p:sp>
+        <p:sp>
+          <p:nvSpPr>
+            <p:cNvPr id="12" name="Oval 11"/>
+            <p:cNvSpPr/>
+            <p:nvPr/>
+          </p:nvSpPr>
+          <p:spPr>
+            <a:xfrm>
+              <a:off x="3026743" y="4666522"/>
+              <a:ext cx="268020" cy="512167"/>
+            </a:xfrm>
+            <a:prstGeom prst="ellipse">
+              <a:avLst/>
+            </a:prstGeom>
+            <a:solidFill>
+              <a:srgbClr val="C0504D"/>
+            </a:solidFill>
+            <a:ln>
+              <a:noFill/>
+            </a:ln>
+          </p:spPr>
+          <p:style>
+            <a:lnRef idx="2">
+              <a:schemeClr val="dk1"/>
+            </a:lnRef>
+            <a:fillRef idx="1">
+              <a:schemeClr val="lt1"/>
+            </a:fillRef>
+            <a:effectRef idx="0">
+              <a:schemeClr val="dk1"/>
+            </a:effectRef>
+            <a:fontRef idx="minor">
+              <a:schemeClr val="dk1"/>
+            </a:fontRef>
+          </p:style>
+          <p:txBody>
+            <a:bodyPr rtlCol="0" anchor="ctr"/>
+            <a:lstStyle/>
+            <a:p>
+              <a:pPr algn="ctr"/>
+              <a:endParaRPr lang="en-US">
+                <a:solidFill>
+                  <a:schemeClr val="dk1"/>
+                </a:solidFill>
+              </a:endParaRPr>
+            </a:p>
+          </p:txBody>
+        </p:sp>
+        <p:sp>
+          <p:nvSpPr>
+            <p:cNvPr id="13" name="Oval 12"/>
+            <p:cNvSpPr/>
+            <p:nvPr/>
+          </p:nvSpPr>
+          <p:spPr>
+            <a:xfrm>
+              <a:off x="2684284" y="4647795"/>
+              <a:ext cx="268020" cy="426806"/>
+            </a:xfrm>
+            <a:prstGeom prst="ellipse">
+              <a:avLst/>
+            </a:prstGeom>
+            <a:solidFill>
+              <a:srgbClr val="C0504D"/>
+            </a:solidFill>
+            <a:ln>
+              <a:noFill/>
+            </a:ln>
+          </p:spPr>
+          <p:style>
+            <a:lnRef idx="2">
+              <a:schemeClr val="dk1"/>
+            </a:lnRef>
+            <a:fillRef idx="1">
+              <a:schemeClr val="lt1"/>
+            </a:fillRef>
+            <a:effectRef idx="0">
+              <a:schemeClr val="dk1"/>
+            </a:effectRef>
+            <a:fontRef idx="minor">
+              <a:schemeClr val="dk1"/>
+            </a:fontRef>
+          </p:style>
+          <p:txBody>
+            <a:bodyPr rtlCol="0" anchor="ctr"/>
+            <a:lstStyle/>
+            <a:p>
+              <a:pPr algn="ctr"/>
+              <a:endParaRPr lang="en-US">
+                <a:solidFill>
+                  <a:schemeClr val="dk1"/>
+                </a:solidFill>
+              </a:endParaRPr>
+            </a:p>
+          </p:txBody>
+        </p:sp>
+        <p:sp>
+          <p:nvSpPr>
+            <p:cNvPr id="14" name="Oval 13"/>
+            <p:cNvSpPr/>
+            <p:nvPr/>
+          </p:nvSpPr>
+          <p:spPr>
+            <a:xfrm>
+              <a:off x="2356793" y="4495800"/>
+              <a:ext cx="268020" cy="341445"/>
+            </a:xfrm>
+            <a:prstGeom prst="ellipse">
+              <a:avLst/>
+            </a:prstGeom>
+            <a:solidFill>
+              <a:srgbClr val="C0504D"/>
+            </a:solidFill>
+            <a:ln>
+              <a:noFill/>
+            </a:ln>
+          </p:spPr>
+          <p:style>
+            <a:lnRef idx="2">
+              <a:schemeClr val="dk1"/>
+            </a:lnRef>
+            <a:fillRef idx="1">
+              <a:schemeClr val="lt1"/>
+            </a:fillRef>
+            <a:effectRef idx="0">
+              <a:schemeClr val="dk1"/>
+            </a:effectRef>
+            <a:fontRef idx="minor">
+              <a:schemeClr val="dk1"/>
+            </a:fontRef>
+          </p:style>
+          <p:txBody>
+            <a:bodyPr rtlCol="0" anchor="ctr"/>
+            <a:lstStyle/>
+            <a:p>
+              <a:pPr algn="ctr"/>
+              <a:endParaRPr lang="en-US">
+                <a:solidFill>
+                  <a:schemeClr val="dk1"/>
+                </a:solidFill>
+              </a:endParaRPr>
+            </a:p>
+          </p:txBody>
+        </p:sp>
+        <p:sp>
+          <p:nvSpPr>
+            <p:cNvPr id="15" name="Oval 14"/>
+            <p:cNvSpPr/>
+            <p:nvPr/>
+          </p:nvSpPr>
+          <p:spPr>
+            <a:xfrm>
+              <a:off x="5693010" y="4666522"/>
+              <a:ext cx="268020" cy="512167"/>
+            </a:xfrm>
+            <a:prstGeom prst="ellipse">
+              <a:avLst/>
+            </a:prstGeom>
+            <a:solidFill>
+              <a:srgbClr val="C0504D"/>
+            </a:solidFill>
+            <a:ln>
+              <a:noFill/>
+            </a:ln>
+          </p:spPr>
+          <p:style>
+            <a:lnRef idx="2">
+              <a:schemeClr val="dk1"/>
+            </a:lnRef>
+            <a:fillRef idx="1">
+              <a:schemeClr val="lt1"/>
+            </a:fillRef>
+            <a:effectRef idx="0">
+              <a:schemeClr val="dk1"/>
+            </a:effectRef>
+            <a:fontRef idx="minor">
+              <a:schemeClr val="dk1"/>
+            </a:fontRef>
+          </p:style>
+          <p:txBody>
+            <a:bodyPr rtlCol="0" anchor="ctr"/>
+            <a:lstStyle/>
+            <a:p>
+              <a:pPr algn="ctr"/>
+              <a:endParaRPr lang="en-US">
+                <a:solidFill>
+                  <a:schemeClr val="dk1"/>
+                </a:solidFill>
+              </a:endParaRPr>
+            </a:p>
+          </p:txBody>
+        </p:sp>
+        <p:sp>
+          <p:nvSpPr>
+            <p:cNvPr id="16" name="Oval 15"/>
+            <p:cNvSpPr/>
+            <p:nvPr/>
+          </p:nvSpPr>
+          <p:spPr>
+            <a:xfrm>
+              <a:off x="6034036" y="4647795"/>
+              <a:ext cx="268020" cy="426806"/>
+            </a:xfrm>
+            <a:prstGeom prst="ellipse">
+              <a:avLst/>
+            </a:prstGeom>
+            <a:solidFill>
+              <a:srgbClr val="C0504D"/>
+            </a:solidFill>
+            <a:ln>
+              <a:noFill/>
+            </a:ln>
+          </p:spPr>
+          <p:style>
+            <a:lnRef idx="2">
+              <a:schemeClr val="dk1"/>
+            </a:lnRef>
+            <a:fillRef idx="1">
+              <a:schemeClr val="lt1"/>
+            </a:fillRef>
+            <a:effectRef idx="0">
+              <a:schemeClr val="dk1"/>
+            </a:effectRef>
+            <a:fontRef idx="minor">
+              <a:schemeClr val="dk1"/>
+            </a:fontRef>
+          </p:style>
+          <p:txBody>
+            <a:bodyPr rtlCol="0" anchor="ctr"/>
+            <a:lstStyle/>
+            <a:p>
+              <a:pPr algn="ctr"/>
+              <a:endParaRPr lang="en-US">
+                <a:solidFill>
+                  <a:schemeClr val="dk1"/>
+                </a:solidFill>
+              </a:endParaRPr>
+            </a:p>
+          </p:txBody>
+        </p:sp>
+        <p:sp>
+          <p:nvSpPr>
+            <p:cNvPr id="17" name="Oval 16"/>
+            <p:cNvSpPr/>
+            <p:nvPr/>
+          </p:nvSpPr>
+          <p:spPr>
+            <a:xfrm>
+              <a:off x="6376495" y="4495800"/>
+              <a:ext cx="268020" cy="341445"/>
+            </a:xfrm>
+            <a:prstGeom prst="ellipse">
+              <a:avLst/>
+            </a:prstGeom>
+            <a:solidFill>
+              <a:srgbClr val="C0504D"/>
+            </a:solidFill>
+            <a:ln>
+              <a:noFill/>
+            </a:ln>
+          </p:spPr>
+          <p:style>
+            <a:lnRef idx="2">
+              <a:schemeClr val="dk1"/>
+            </a:lnRef>
+            <a:fillRef idx="1">
+              <a:schemeClr val="lt1"/>
+            </a:fillRef>
+            <a:effectRef idx="0">
+              <a:schemeClr val="dk1"/>
+            </a:effectRef>
+            <a:fontRef idx="minor">
+              <a:schemeClr val="dk1"/>
+            </a:fontRef>
+          </p:style>
+          <p:txBody>
+            <a:bodyPr rtlCol="0" anchor="ctr"/>
+            <a:lstStyle/>
+            <a:p>
+              <a:pPr algn="ctr"/>
+              <a:endParaRPr lang="en-US">
+                <a:solidFill>
+                  <a:schemeClr val="dk1"/>
+                </a:solidFill>
+              </a:endParaRPr>
+            </a:p>
+          </p:txBody>
+        </p:sp>
+        <p:sp>
+          <p:nvSpPr>
+            <p:cNvPr id="4" name="Teardrop 3"/>
+            <p:cNvSpPr/>
+            <p:nvPr/>
+          </p:nvSpPr>
+          <p:spPr>
+            <a:xfrm>
+              <a:off x="6450934" y="835899"/>
+              <a:ext cx="357307" cy="341445"/>
+            </a:xfrm>
+            <a:prstGeom prst="teardrop">
+              <a:avLst/>
+            </a:prstGeom>
+            <a:solidFill>
+              <a:srgbClr val="FFCC00"/>
             </a:solidFill>
             <a:ln>
               <a:noFill/>
             </a:ln>
             <a:effectLst>
-              <a:glow rad="101600">
-                <a:schemeClr val="accent2">
-                  <a:satMod val="175000"/>
+              <a:glow rad="63500">
+                <a:srgbClr val="FFFF00">
                   <a:alpha val="40000"/>
-                </a:schemeClr>
+                </a:srgbClr>
               </a:glow>
-              <a:outerShdw blurRad="50800" dist="38100" dir="5400000" algn="t" rotWithShape="0">
-                <a:prstClr val="black">
-                  <a:alpha val="40000"/>
-                </a:prstClr>
-              </a:outerShdw>
-              <a:reflection blurRad="6350" stA="52000" endA="300" endPos="35000" dir="5400000" sy="-100000" algn="bl" rotWithShape="0"/>
             </a:effectLst>
           </p:spPr>
           <p:style>
@@ -5224,43 +5699,36 @@
             <a:lstStyle/>
             <a:p>
               <a:pPr algn="ctr"/>
-              <a:endParaRPr lang="en-US"/>
+              <a:endParaRPr lang="en-IN"/>
             </a:p>
           </p:txBody>
         </p:sp>
         <p:sp>
           <p:nvSpPr>
-            <p:cNvPr id="9" name="Oval 8"/>
+            <p:cNvPr id="18" name="Teardrop 17"/>
             <p:cNvSpPr/>
             <p:nvPr/>
           </p:nvSpPr>
           <p:spPr>
-            <a:xfrm>
-              <a:off x="4675910" y="4821439"/>
-              <a:ext cx="609600" cy="893561"/>
+            <a:xfrm flipV="1">
+              <a:off x="6450934" y="5142141"/>
+              <a:ext cx="357307" cy="341445"/>
             </a:xfrm>
-            <a:prstGeom prst="ellipse">
+            <a:prstGeom prst="teardrop">
               <a:avLst/>
             </a:prstGeom>
             <a:solidFill>
-              <a:schemeClr val="accent2"/>
+              <a:srgbClr val="FFCC00"/>
             </a:solidFill>
             <a:ln>
               <a:noFill/>
             </a:ln>
             <a:effectLst>
-              <a:glow rad="101600">
-                <a:schemeClr val="accent2">
-                  <a:satMod val="175000"/>
+              <a:glow rad="63500">
+                <a:srgbClr val="FFFF00">
                   <a:alpha val="40000"/>
-                </a:schemeClr>
+                </a:srgbClr>
               </a:glow>
-              <a:outerShdw blurRad="50800" dist="38100" dir="5400000" algn="t" rotWithShape="0">
-                <a:prstClr val="black">
-                  <a:alpha val="40000"/>
-                </a:prstClr>
-              </a:outerShdw>
-              <a:reflection blurRad="6350" stA="52000" endA="300" endPos="35000" dir="5400000" sy="-100000" algn="bl" rotWithShape="0"/>
             </a:effectLst>
           </p:spPr>
           <p:style>
@@ -5284,43 +5752,36 @@
             <a:lstStyle/>
             <a:p>
               <a:pPr algn="ctr"/>
-              <a:endParaRPr lang="en-US"/>
+              <a:endParaRPr lang="en-IN"/>
             </a:p>
           </p:txBody>
         </p:sp>
         <p:sp>
           <p:nvSpPr>
-            <p:cNvPr id="10" name="Oval 9"/>
+            <p:cNvPr id="19" name="Teardrop 18"/>
             <p:cNvSpPr/>
             <p:nvPr/>
           </p:nvSpPr>
           <p:spPr>
-            <a:xfrm>
-              <a:off x="3383239" y="5105400"/>
-              <a:ext cx="274361" cy="548640"/>
+            <a:xfrm flipH="1" flipV="1">
+              <a:off x="2128241" y="5142141"/>
+              <a:ext cx="357307" cy="341445"/>
             </a:xfrm>
-            <a:prstGeom prst="ellipse">
+            <a:prstGeom prst="teardrop">
               <a:avLst/>
             </a:prstGeom>
             <a:solidFill>
-              <a:schemeClr val="accent2"/>
+              <a:srgbClr val="FFCC00"/>
             </a:solidFill>
             <a:ln>
               <a:noFill/>
             </a:ln>
             <a:effectLst>
-              <a:glow rad="101600">
-                <a:schemeClr val="accent2">
-                  <a:satMod val="175000"/>
+              <a:glow rad="63500">
+                <a:srgbClr val="FFFF00">
                   <a:alpha val="40000"/>
-                </a:schemeClr>
+                </a:srgbClr>
               </a:glow>
-              <a:outerShdw blurRad="50800" dist="38100" dir="5400000" algn="t" rotWithShape="0">
-                <a:prstClr val="black">
-                  <a:alpha val="40000"/>
-                </a:prstClr>
-              </a:outerShdw>
-              <a:reflection blurRad="6350" stA="52000" endA="300" endPos="35000" dir="5400000" sy="-100000" algn="bl" rotWithShape="0"/>
             </a:effectLst>
           </p:spPr>
           <p:style>
@@ -5344,43 +5805,36 @@
             <a:lstStyle/>
             <a:p>
               <a:pPr algn="ctr"/>
-              <a:endParaRPr lang="en-US"/>
+              <a:endParaRPr lang="en-IN"/>
             </a:p>
           </p:txBody>
         </p:sp>
         <p:sp>
           <p:nvSpPr>
-            <p:cNvPr id="11" name="Oval 10"/>
+            <p:cNvPr id="20" name="Teardrop 19"/>
             <p:cNvSpPr/>
             <p:nvPr/>
           </p:nvSpPr>
           <p:spPr>
-            <a:xfrm>
-              <a:off x="5410200" y="5105400"/>
-              <a:ext cx="274361" cy="548640"/>
+            <a:xfrm flipH="1">
+              <a:off x="2128241" y="835899"/>
+              <a:ext cx="357307" cy="341445"/>
             </a:xfrm>
-            <a:prstGeom prst="ellipse">
+            <a:prstGeom prst="teardrop">
               <a:avLst/>
             </a:prstGeom>
             <a:solidFill>
-              <a:schemeClr val="accent2"/>
+              <a:srgbClr val="FFCC00"/>
             </a:solidFill>
             <a:ln>
               <a:noFill/>
             </a:ln>
             <a:effectLst>
-              <a:glow rad="101600">
-                <a:schemeClr val="accent2">
-                  <a:satMod val="175000"/>
+              <a:glow rad="63500">
+                <a:srgbClr val="FFFF00">
                   <a:alpha val="40000"/>
-                </a:schemeClr>
+                </a:srgbClr>
               </a:glow>
-              <a:outerShdw blurRad="50800" dist="38100" dir="5400000" algn="t" rotWithShape="0">
-                <a:prstClr val="black">
-                  <a:alpha val="40000"/>
-                </a:prstClr>
-              </a:outerShdw>
-              <a:reflection blurRad="6350" stA="52000" endA="300" endPos="35000" dir="5400000" sy="-100000" algn="bl" rotWithShape="0"/>
             </a:effectLst>
           </p:spPr>
           <p:style>
@@ -5404,607 +5858,52 @@
             <a:lstStyle/>
             <a:p>
               <a:pPr algn="ctr"/>
-              <a:endParaRPr lang="en-US"/>
+              <a:endParaRPr lang="en-IN"/>
             </a:p>
           </p:txBody>
         </p:sp>
         <p:sp>
           <p:nvSpPr>
-            <p:cNvPr id="12" name="Oval 11"/>
-            <p:cNvSpPr/>
+            <p:cNvPr id="22" name="TextBox 21"/>
+            <p:cNvSpPr txBox="1"/>
             <p:nvPr/>
           </p:nvSpPr>
           <p:spPr>
             <a:xfrm>
-              <a:off x="3048000" y="5013960"/>
-              <a:ext cx="274361" cy="548640"/>
+              <a:off x="2832713" y="1262705"/>
+              <a:ext cx="1161737" cy="1051295"/>
             </a:xfrm>
-            <a:prstGeom prst="ellipse">
+            <a:prstGeom prst="rect">
               <a:avLst/>
             </a:prstGeom>
-            <a:solidFill>
-              <a:schemeClr val="accent2"/>
-            </a:solidFill>
-            <a:ln>
-              <a:noFill/>
-            </a:ln>
-            <a:effectLst>
-              <a:glow rad="101600">
-                <a:schemeClr val="accent2">
-                  <a:satMod val="175000"/>
-                  <a:alpha val="40000"/>
-                </a:schemeClr>
-              </a:glow>
-              <a:outerShdw blurRad="50800" dist="38100" dir="5400000" algn="t" rotWithShape="0">
-                <a:prstClr val="black">
-                  <a:alpha val="40000"/>
-                </a:prstClr>
-              </a:outerShdw>
-              <a:reflection blurRad="6350" stA="52000" endA="300" endPos="35000" dir="5400000" sy="-100000" algn="bl" rotWithShape="0"/>
-            </a:effectLst>
+            <a:noFill/>
           </p:spPr>
-          <p:style>
-            <a:lnRef idx="2">
-              <a:schemeClr val="accent1">
-                <a:shade val="50000"/>
-              </a:schemeClr>
-            </a:lnRef>
-            <a:fillRef idx="1">
-              <a:schemeClr val="accent1"/>
-            </a:fillRef>
-            <a:effectRef idx="0">
-              <a:schemeClr val="accent1"/>
-            </a:effectRef>
-            <a:fontRef idx="minor">
-              <a:schemeClr val="lt1"/>
-            </a:fontRef>
-          </p:style>
           <p:txBody>
-            <a:bodyPr rtlCol="0" anchor="ctr"/>
+            <a:bodyPr wrap="square" rtlCol="0">
+              <a:spAutoFit/>
+            </a:bodyPr>
             <a:lstStyle/>
             <a:p>
-              <a:pPr algn="ctr"/>
-              <a:endParaRPr lang="en-US"/>
-            </a:p>
-          </p:txBody>
-        </p:sp>
-        <p:sp>
-          <p:nvSpPr>
-            <p:cNvPr id="13" name="Oval 12"/>
-            <p:cNvSpPr/>
-            <p:nvPr/>
-          </p:nvSpPr>
-          <p:spPr>
-            <a:xfrm>
-              <a:off x="2697439" y="4993899"/>
-              <a:ext cx="274361" cy="457200"/>
-            </a:xfrm>
-            <a:prstGeom prst="ellipse">
-              <a:avLst/>
-            </a:prstGeom>
-            <a:solidFill>
-              <a:schemeClr val="accent2"/>
-            </a:solidFill>
-            <a:ln>
-              <a:noFill/>
-            </a:ln>
-            <a:effectLst>
-              <a:glow rad="101600">
-                <a:schemeClr val="accent2">
-                  <a:satMod val="175000"/>
-                  <a:alpha val="40000"/>
-                </a:schemeClr>
-              </a:glow>
-              <a:outerShdw blurRad="50800" dist="38100" dir="5400000" algn="t" rotWithShape="0">
-                <a:prstClr val="black">
-                  <a:alpha val="40000"/>
-                </a:prstClr>
-              </a:outerShdw>
-              <a:reflection blurRad="6350" stA="52000" endA="300" endPos="35000" dir="5400000" sy="-100000" algn="bl" rotWithShape="0"/>
-            </a:effectLst>
-          </p:spPr>
-          <p:style>
-            <a:lnRef idx="2">
-              <a:schemeClr val="accent1">
-                <a:shade val="50000"/>
-              </a:schemeClr>
-            </a:lnRef>
-            <a:fillRef idx="1">
-              <a:schemeClr val="accent1"/>
-            </a:fillRef>
-            <a:effectRef idx="0">
-              <a:schemeClr val="accent1"/>
-            </a:effectRef>
-            <a:fontRef idx="minor">
-              <a:schemeClr val="lt1"/>
-            </a:fontRef>
-          </p:style>
-          <p:txBody>
-            <a:bodyPr rtlCol="0" anchor="ctr"/>
-            <a:lstStyle/>
-            <a:p>
-              <a:pPr algn="ctr"/>
-              <a:endParaRPr lang="en-US"/>
-            </a:p>
-          </p:txBody>
-        </p:sp>
-        <p:sp>
-          <p:nvSpPr>
-            <p:cNvPr id="14" name="Oval 13"/>
-            <p:cNvSpPr/>
-            <p:nvPr/>
-          </p:nvSpPr>
-          <p:spPr>
-            <a:xfrm>
-              <a:off x="2362200" y="4831080"/>
-              <a:ext cx="274361" cy="365760"/>
-            </a:xfrm>
-            <a:prstGeom prst="ellipse">
-              <a:avLst/>
-            </a:prstGeom>
-            <a:solidFill>
-              <a:schemeClr val="accent2"/>
-            </a:solidFill>
-            <a:ln>
-              <a:noFill/>
-            </a:ln>
-            <a:effectLst>
-              <a:glow rad="101600">
-                <a:schemeClr val="accent2">
-                  <a:satMod val="175000"/>
-                  <a:alpha val="40000"/>
-                </a:schemeClr>
-              </a:glow>
-              <a:outerShdw blurRad="50800" dist="38100" dir="5400000" algn="t" rotWithShape="0">
-                <a:prstClr val="black">
-                  <a:alpha val="40000"/>
-                </a:prstClr>
-              </a:outerShdw>
-              <a:reflection blurRad="6350" stA="52000" endA="300" endPos="35000" dir="5400000" sy="-100000" algn="bl" rotWithShape="0"/>
-            </a:effectLst>
-          </p:spPr>
-          <p:style>
-            <a:lnRef idx="2">
-              <a:schemeClr val="accent1">
-                <a:shade val="50000"/>
-              </a:schemeClr>
-            </a:lnRef>
-            <a:fillRef idx="1">
-              <a:schemeClr val="accent1"/>
-            </a:fillRef>
-            <a:effectRef idx="0">
-              <a:schemeClr val="accent1"/>
-            </a:effectRef>
-            <a:fontRef idx="minor">
-              <a:schemeClr val="lt1"/>
-            </a:fontRef>
-          </p:style>
-          <p:txBody>
-            <a:bodyPr rtlCol="0" anchor="ctr"/>
-            <a:lstStyle/>
-            <a:p>
-              <a:pPr algn="ctr"/>
-              <a:endParaRPr lang="en-US"/>
-            </a:p>
-          </p:txBody>
-        </p:sp>
-        <p:sp>
-          <p:nvSpPr>
-            <p:cNvPr id="15" name="Oval 14"/>
-            <p:cNvSpPr/>
-            <p:nvPr/>
-          </p:nvSpPr>
-          <p:spPr>
-            <a:xfrm>
-              <a:off x="5777345" y="5013960"/>
-              <a:ext cx="274361" cy="548640"/>
-            </a:xfrm>
-            <a:prstGeom prst="ellipse">
-              <a:avLst/>
-            </a:prstGeom>
-            <a:solidFill>
-              <a:schemeClr val="accent2"/>
-            </a:solidFill>
-            <a:ln>
-              <a:noFill/>
-            </a:ln>
-            <a:effectLst>
-              <a:glow rad="101600">
-                <a:schemeClr val="accent2">
-                  <a:satMod val="175000"/>
-                  <a:alpha val="40000"/>
-                </a:schemeClr>
-              </a:glow>
-              <a:outerShdw blurRad="50800" dist="38100" dir="5400000" algn="t" rotWithShape="0">
-                <a:prstClr val="black">
-                  <a:alpha val="40000"/>
-                </a:prstClr>
-              </a:outerShdw>
-              <a:reflection blurRad="6350" stA="52000" endA="300" endPos="35000" dir="5400000" sy="-100000" algn="bl" rotWithShape="0"/>
-            </a:effectLst>
-          </p:spPr>
-          <p:style>
-            <a:lnRef idx="2">
-              <a:schemeClr val="accent1">
-                <a:shade val="50000"/>
-              </a:schemeClr>
-            </a:lnRef>
-            <a:fillRef idx="1">
-              <a:schemeClr val="accent1"/>
-            </a:fillRef>
-            <a:effectRef idx="0">
-              <a:schemeClr val="accent1"/>
-            </a:effectRef>
-            <a:fontRef idx="minor">
-              <a:schemeClr val="lt1"/>
-            </a:fontRef>
-          </p:style>
-          <p:txBody>
-            <a:bodyPr rtlCol="0" anchor="ctr"/>
-            <a:lstStyle/>
-            <a:p>
-              <a:pPr algn="ctr"/>
-              <a:endParaRPr lang="en-US"/>
-            </a:p>
-          </p:txBody>
-        </p:sp>
-        <p:sp>
-          <p:nvSpPr>
-            <p:cNvPr id="16" name="Oval 15"/>
-            <p:cNvSpPr/>
-            <p:nvPr/>
-          </p:nvSpPr>
-          <p:spPr>
-            <a:xfrm>
-              <a:off x="6126439" y="4993899"/>
-              <a:ext cx="274361" cy="457200"/>
-            </a:xfrm>
-            <a:prstGeom prst="ellipse">
-              <a:avLst/>
-            </a:prstGeom>
-            <a:solidFill>
-              <a:schemeClr val="accent2"/>
-            </a:solidFill>
-            <a:ln>
-              <a:noFill/>
-            </a:ln>
-            <a:effectLst>
-              <a:glow rad="101600">
-                <a:schemeClr val="accent2">
-                  <a:satMod val="175000"/>
-                  <a:alpha val="40000"/>
-                </a:schemeClr>
-              </a:glow>
-              <a:outerShdw blurRad="50800" dist="38100" dir="5400000" algn="t" rotWithShape="0">
-                <a:prstClr val="black">
-                  <a:alpha val="40000"/>
-                </a:prstClr>
-              </a:outerShdw>
-              <a:reflection blurRad="6350" stA="52000" endA="300" endPos="35000" dir="5400000" sy="-100000" algn="bl" rotWithShape="0"/>
-            </a:effectLst>
-          </p:spPr>
-          <p:style>
-            <a:lnRef idx="2">
-              <a:schemeClr val="accent1">
-                <a:shade val="50000"/>
-              </a:schemeClr>
-            </a:lnRef>
-            <a:fillRef idx="1">
-              <a:schemeClr val="accent1"/>
-            </a:fillRef>
-            <a:effectRef idx="0">
-              <a:schemeClr val="accent1"/>
-            </a:effectRef>
-            <a:fontRef idx="minor">
-              <a:schemeClr val="lt1"/>
-            </a:fontRef>
-          </p:style>
-          <p:txBody>
-            <a:bodyPr rtlCol="0" anchor="ctr"/>
-            <a:lstStyle/>
-            <a:p>
-              <a:pPr algn="ctr"/>
-              <a:endParaRPr lang="en-US"/>
-            </a:p>
-          </p:txBody>
-        </p:sp>
-        <p:sp>
-          <p:nvSpPr>
-            <p:cNvPr id="17" name="Oval 16"/>
-            <p:cNvSpPr/>
-            <p:nvPr/>
-          </p:nvSpPr>
-          <p:spPr>
-            <a:xfrm>
-              <a:off x="6477000" y="4831080"/>
-              <a:ext cx="274361" cy="365760"/>
-            </a:xfrm>
-            <a:prstGeom prst="ellipse">
-              <a:avLst/>
-            </a:prstGeom>
-            <a:solidFill>
-              <a:schemeClr val="accent2"/>
-            </a:solidFill>
-            <a:ln>
-              <a:noFill/>
-            </a:ln>
-            <a:effectLst>
-              <a:glow rad="101600">
-                <a:schemeClr val="accent2">
-                  <a:satMod val="175000"/>
-                  <a:alpha val="40000"/>
-                </a:schemeClr>
-              </a:glow>
-              <a:outerShdw blurRad="50800" dist="38100" dir="5400000" algn="t" rotWithShape="0">
-                <a:prstClr val="black">
-                  <a:alpha val="40000"/>
-                </a:prstClr>
-              </a:outerShdw>
-              <a:reflection blurRad="6350" stA="52000" endA="300" endPos="35000" dir="5400000" sy="-100000" algn="bl" rotWithShape="0"/>
-            </a:effectLst>
-          </p:spPr>
-          <p:style>
-            <a:lnRef idx="2">
-              <a:schemeClr val="accent1">
-                <a:shade val="50000"/>
-              </a:schemeClr>
-            </a:lnRef>
-            <a:fillRef idx="1">
-              <a:schemeClr val="accent1"/>
-            </a:fillRef>
-            <a:effectRef idx="0">
-              <a:schemeClr val="accent1"/>
-            </a:effectRef>
-            <a:fontRef idx="minor">
-              <a:schemeClr val="lt1"/>
-            </a:fontRef>
-          </p:style>
-          <p:txBody>
-            <a:bodyPr rtlCol="0" anchor="ctr"/>
-            <a:lstStyle/>
-            <a:p>
-              <a:pPr algn="ctr"/>
-              <a:endParaRPr lang="en-US"/>
-            </a:p>
-          </p:txBody>
-        </p:sp>
-      </p:grpSp>
-      <p:sp>
-        <p:nvSpPr>
-          <p:cNvPr id="4" name="Teardrop 3"/>
-          <p:cNvSpPr/>
-          <p:nvPr/>
-        </p:nvSpPr>
-        <p:spPr>
-          <a:xfrm>
-            <a:off x="6553200" y="838200"/>
-            <a:ext cx="365760" cy="365760"/>
-          </a:xfrm>
-          <a:prstGeom prst="teardrop">
-            <a:avLst/>
-          </a:prstGeom>
-          <a:solidFill>
-            <a:srgbClr val="FFCC00"/>
-          </a:solidFill>
-          <a:ln>
-            <a:noFill/>
-          </a:ln>
-          <a:effectLst>
-            <a:glow rad="63500">
-              <a:srgbClr val="FFFF00">
-                <a:alpha val="40000"/>
-              </a:srgbClr>
-            </a:glow>
-          </a:effectLst>
-        </p:spPr>
-        <p:style>
-          <a:lnRef idx="2">
-            <a:schemeClr val="accent1">
-              <a:shade val="50000"/>
-            </a:schemeClr>
-          </a:lnRef>
-          <a:fillRef idx="1">
-            <a:schemeClr val="accent1"/>
-          </a:fillRef>
-          <a:effectRef idx="0">
-            <a:schemeClr val="accent1"/>
-          </a:effectRef>
-          <a:fontRef idx="minor">
-            <a:schemeClr val="lt1"/>
-          </a:fontRef>
-        </p:style>
-        <p:txBody>
-          <a:bodyPr rtlCol="0" anchor="ctr"/>
-          <a:lstStyle/>
-          <a:p>
-            <a:pPr algn="ctr"/>
-            <a:endParaRPr lang="en-IN"/>
-          </a:p>
-        </p:txBody>
-      </p:sp>
-      <p:sp>
-        <p:nvSpPr>
-          <p:cNvPr id="18" name="Teardrop 17"/>
-          <p:cNvSpPr/>
-          <p:nvPr/>
-        </p:nvSpPr>
-        <p:spPr>
-          <a:xfrm flipV="1">
-            <a:off x="6553200" y="5451099"/>
-            <a:ext cx="365760" cy="365760"/>
-          </a:xfrm>
-          <a:prstGeom prst="teardrop">
-            <a:avLst/>
-          </a:prstGeom>
-          <a:solidFill>
-            <a:srgbClr val="FFCC00"/>
-          </a:solidFill>
-          <a:ln>
-            <a:noFill/>
-          </a:ln>
-          <a:effectLst>
-            <a:glow rad="63500">
-              <a:srgbClr val="FFFF00">
-                <a:alpha val="40000"/>
-              </a:srgbClr>
-            </a:glow>
-          </a:effectLst>
-        </p:spPr>
-        <p:style>
-          <a:lnRef idx="2">
-            <a:schemeClr val="accent1">
-              <a:shade val="50000"/>
-            </a:schemeClr>
-          </a:lnRef>
-          <a:fillRef idx="1">
-            <a:schemeClr val="accent1"/>
-          </a:fillRef>
-          <a:effectRef idx="0">
-            <a:schemeClr val="accent1"/>
-          </a:effectRef>
-          <a:fontRef idx="minor">
-            <a:schemeClr val="lt1"/>
-          </a:fontRef>
-        </p:style>
-        <p:txBody>
-          <a:bodyPr rtlCol="0" anchor="ctr"/>
-          <a:lstStyle/>
-          <a:p>
-            <a:pPr algn="ctr"/>
-            <a:endParaRPr lang="en-IN"/>
-          </a:p>
-        </p:txBody>
-      </p:sp>
-      <p:sp>
-        <p:nvSpPr>
-          <p:cNvPr id="19" name="Teardrop 18"/>
-          <p:cNvSpPr/>
-          <p:nvPr/>
-        </p:nvSpPr>
-        <p:spPr>
-          <a:xfrm flipH="1" flipV="1">
-            <a:off x="2128241" y="5451099"/>
-            <a:ext cx="365760" cy="365760"/>
-          </a:xfrm>
-          <a:prstGeom prst="teardrop">
-            <a:avLst/>
-          </a:prstGeom>
-          <a:solidFill>
-            <a:srgbClr val="FFCC00"/>
-          </a:solidFill>
-          <a:ln>
-            <a:noFill/>
-          </a:ln>
-          <a:effectLst>
-            <a:glow rad="63500">
-              <a:srgbClr val="FFFF00">
-                <a:alpha val="40000"/>
-              </a:srgbClr>
-            </a:glow>
-          </a:effectLst>
-        </p:spPr>
-        <p:style>
-          <a:lnRef idx="2">
-            <a:schemeClr val="accent1">
-              <a:shade val="50000"/>
-            </a:schemeClr>
-          </a:lnRef>
-          <a:fillRef idx="1">
-            <a:schemeClr val="accent1"/>
-          </a:fillRef>
-          <a:effectRef idx="0">
-            <a:schemeClr val="accent1"/>
-          </a:effectRef>
-          <a:fontRef idx="minor">
-            <a:schemeClr val="lt1"/>
-          </a:fontRef>
-        </p:style>
-        <p:txBody>
-          <a:bodyPr rtlCol="0" anchor="ctr"/>
-          <a:lstStyle/>
-          <a:p>
-            <a:pPr algn="ctr"/>
-            <a:endParaRPr lang="en-IN"/>
-          </a:p>
-        </p:txBody>
-      </p:sp>
-      <p:sp>
-        <p:nvSpPr>
-          <p:cNvPr id="20" name="Teardrop 19"/>
-          <p:cNvSpPr/>
-          <p:nvPr/>
-        </p:nvSpPr>
-        <p:spPr>
-          <a:xfrm flipH="1">
-            <a:off x="2128241" y="838200"/>
-            <a:ext cx="365760" cy="365760"/>
-          </a:xfrm>
-          <a:prstGeom prst="teardrop">
-            <a:avLst/>
-          </a:prstGeom>
-          <a:solidFill>
-            <a:srgbClr val="FFCC00"/>
-          </a:solidFill>
-          <a:ln>
-            <a:noFill/>
-          </a:ln>
-          <a:effectLst>
-            <a:glow rad="63500">
-              <a:srgbClr val="FFFF00">
-                <a:alpha val="40000"/>
-              </a:srgbClr>
-            </a:glow>
-          </a:effectLst>
-        </p:spPr>
-        <p:style>
-          <a:lnRef idx="2">
-            <a:schemeClr val="accent1">
-              <a:shade val="50000"/>
-            </a:schemeClr>
-          </a:lnRef>
-          <a:fillRef idx="1">
-            <a:schemeClr val="accent1"/>
-          </a:fillRef>
-          <a:effectRef idx="0">
-            <a:schemeClr val="accent1"/>
-          </a:effectRef>
-          <a:fontRef idx="minor">
-            <a:schemeClr val="lt1"/>
-          </a:fontRef>
-        </p:style>
-        <p:txBody>
-          <a:bodyPr rtlCol="0" anchor="ctr"/>
-          <a:lstStyle/>
-          <a:p>
-            <a:pPr algn="ctr"/>
-            <a:endParaRPr lang="en-IN"/>
-          </a:p>
-        </p:txBody>
-      </p:sp>
-      <p:sp>
-        <p:nvSpPr>
-          <p:cNvPr id="22" name="TextBox 21"/>
-          <p:cNvSpPr txBox="1"/>
-          <p:nvPr/>
-        </p:nvSpPr>
-        <p:spPr>
-          <a:xfrm>
-            <a:off x="2849379" y="1295400"/>
-            <a:ext cx="1189221" cy="1126160"/>
-          </a:xfrm>
-          <a:prstGeom prst="rect">
-            <a:avLst/>
-          </a:prstGeom>
-          <a:noFill/>
-        </p:spPr>
-        <p:txBody>
-          <a:bodyPr wrap="square" rtlCol="0">
-            <a:spAutoFit/>
-          </a:bodyPr>
-          <a:lstStyle/>
-          <a:p>
-            <a:r>
-              <a:rPr lang="hi-IN" sz="6600" dirty="0">
+              <a:r>
+                <a:rPr lang="hi-IN" sz="6600" dirty="0">
+                  <a:ln w="12700">
+                    <a:noFill/>
+                  </a:ln>
+                  <a:solidFill>
+                    <a:sysClr val="windowText" lastClr="000000"/>
+                  </a:solidFill>
+                  <a:effectLst>
+                    <a:glow rad="139700">
+                      <a:schemeClr val="accent6">
+                        <a:satMod val="175000"/>
+                        <a:alpha val="40000"/>
+                      </a:schemeClr>
+                    </a:glow>
+                  </a:effectLst>
+                </a:rPr>
+                <a:t>मा</a:t>
+              </a:r>
+              <a:endParaRPr lang="en-US" sz="6600" dirty="0">
                 <a:ln w="12700">
                   <a:noFill/>
                 </a:ln>
@@ -6019,91 +5918,74 @@
                     </a:schemeClr>
                   </a:glow>
                 </a:effectLst>
-              </a:rPr>
-              <a:t>मा</a:t>
-            </a:r>
-            <a:endParaRPr lang="en-US" sz="6600" dirty="0">
-              <a:ln w="12700">
-                <a:noFill/>
-              </a:ln>
-              <a:solidFill>
-                <a:sysClr val="windowText" lastClr="000000"/>
-              </a:solidFill>
-              <a:effectLst>
-                <a:glow rad="139700">
-                  <a:schemeClr val="accent6">
-                    <a:satMod val="175000"/>
-                    <a:alpha val="40000"/>
-                  </a:schemeClr>
-                </a:glow>
-              </a:effectLst>
-            </a:endParaRPr>
-          </a:p>
-        </p:txBody>
-      </p:sp>
-      <p:sp>
-        <p:nvSpPr>
-          <p:cNvPr id="23" name="TextBox 22"/>
-          <p:cNvSpPr txBox="1"/>
-          <p:nvPr/>
-        </p:nvSpPr>
-        <p:spPr>
-          <a:xfrm>
-            <a:off x="4876800" y="1295400"/>
-            <a:ext cx="2006541" cy="1126160"/>
-          </a:xfrm>
-          <a:prstGeom prst="rect">
-            <a:avLst/>
-          </a:prstGeom>
-          <a:noFill/>
-        </p:spPr>
-        <p:txBody>
-          <a:bodyPr wrap="square" rtlCol="0">
-            <a:spAutoFit/>
-          </a:bodyPr>
-          <a:lstStyle/>
-          <a:p>
-            <a:r>
-              <a:rPr lang="hi-IN" sz="6600" dirty="0">
-                <a:ln w="12700">
-                  <a:noFill/>
-                </a:ln>
-                <a:solidFill>
-                  <a:sysClr val="windowText" lastClr="000000"/>
-                </a:solidFill>
-                <a:effectLst>
-                  <a:glow rad="139700">
-                    <a:schemeClr val="accent6">
-                      <a:satMod val="175000"/>
-                      <a:alpha val="40000"/>
-                    </a:schemeClr>
-                  </a:glow>
-                </a:effectLst>
-              </a:rPr>
-              <a:t>शुच</a:t>
-            </a:r>
-            <a:r>
-              <a:rPr lang="en-US" sz="6600" dirty="0">
-                <a:ln w="12700">
-                  <a:noFill/>
-                </a:ln>
-                <a:solidFill>
-                  <a:sysClr val="windowText" lastClr="000000"/>
-                </a:solidFill>
-                <a:effectLst>
-                  <a:glow rad="139700">
-                    <a:schemeClr val="accent6">
-                      <a:satMod val="175000"/>
-                      <a:alpha val="40000"/>
-                    </a:schemeClr>
-                  </a:glow>
-                </a:effectLst>
-              </a:rPr>
-              <a:t>:</a:t>
-            </a:r>
-          </a:p>
-        </p:txBody>
-      </p:sp>
+              </a:endParaRPr>
+            </a:p>
+          </p:txBody>
+        </p:sp>
+        <p:sp>
+          <p:nvSpPr>
+            <p:cNvPr id="23" name="TextBox 22"/>
+            <p:cNvSpPr txBox="1"/>
+            <p:nvPr/>
+          </p:nvSpPr>
+          <p:spPr>
+            <a:xfrm>
+              <a:off x="4813278" y="1262705"/>
+              <a:ext cx="1960168" cy="1051295"/>
+            </a:xfrm>
+            <a:prstGeom prst="rect">
+              <a:avLst/>
+            </a:prstGeom>
+            <a:noFill/>
+          </p:spPr>
+          <p:txBody>
+            <a:bodyPr wrap="square" rtlCol="0">
+              <a:spAutoFit/>
+            </a:bodyPr>
+            <a:lstStyle/>
+            <a:p>
+              <a:r>
+                <a:rPr lang="hi-IN" sz="6600" dirty="0">
+                  <a:ln w="12700">
+                    <a:noFill/>
+                  </a:ln>
+                  <a:solidFill>
+                    <a:sysClr val="windowText" lastClr="000000"/>
+                  </a:solidFill>
+                  <a:effectLst>
+                    <a:glow rad="139700">
+                      <a:schemeClr val="accent6">
+                        <a:satMod val="175000"/>
+                        <a:alpha val="40000"/>
+                      </a:schemeClr>
+                    </a:glow>
+                  </a:effectLst>
+                </a:rPr>
+                <a:t>शुच</a:t>
+              </a:r>
+              <a:r>
+                <a:rPr lang="en-US" sz="6600" dirty="0">
+                  <a:ln w="12700">
+                    <a:noFill/>
+                  </a:ln>
+                  <a:solidFill>
+                    <a:sysClr val="windowText" lastClr="000000"/>
+                  </a:solidFill>
+                  <a:effectLst>
+                    <a:glow rad="139700">
+                      <a:schemeClr val="accent6">
+                        <a:satMod val="175000"/>
+                        <a:alpha val="40000"/>
+                      </a:schemeClr>
+                    </a:glow>
+                  </a:effectLst>
+                </a:rPr>
+                <a:t>:</a:t>
+              </a:r>
+            </a:p>
+          </p:txBody>
+        </p:sp>
+      </p:grpSp>
     </p:spTree>
     <p:extLst>
       <p:ext uri="{BB962C8B-B14F-4D97-AF65-F5344CB8AC3E}">

</xml_diff>